<commit_message>
Fix 6 × 40 m as the selected layout
- Dashboard opens on 6 × 40 m (marked selected); other layouts stay as alternatives
- Blueprint 26029-PFD-003 rev B, methodology sheet 6 and PowerPoint marked as selected layout

Co-Authored-By: Claude Opus 5.5 <noreply@anthropic.com>
Claude-Session: https://claude.ai/code/session_01DJdAKW37ox1vjrzWffae3K
</commit_message>
<xml_diff>
--- a/Coleraine-6x40m-Tunnel-PFD.pptx
+++ b/Coleraine-6x40m-Tunnel-PFD.pptx
@@ -1086,7 +1086,7 @@
                 <a:ea typeface="Arial" pitchFamily="34" charset="-122"/>
                 <a:cs typeface="Arial" pitchFamily="34" charset="-120"/>
               </a:rPr>
-              <a:t>PROCESS FLOW SHEET · 6 × 40 m</a:t>
+              <a:t>SELECTED LAYOUT · 6 × 40 m</a:t>
             </a:r>
             <a:endParaRPr lang="en-US" sz="2400" dirty="0"/>
           </a:p>
@@ -1168,7 +1168,7 @@
                 <a:ea typeface="Courier New" pitchFamily="34" charset="-122"/>
                 <a:cs typeface="Courier New" pitchFamily="34" charset="-120"/>
               </a:rPr>
-              <a:t>INTERIM · NOT FOR CONSTRUCTION</a:t>
+              <a:t>SELECTED LAYOUT · INTERIM</a:t>
             </a:r>
             <a:endParaRPr lang="en-US" sz="900" dirty="0"/>
           </a:p>
@@ -1816,7 +1816,7 @@
                 <a:ea typeface="Courier New" pitchFamily="34" charset="-122"/>
                 <a:cs typeface="Courier New" pitchFamily="34" charset="-120"/>
               </a:rPr>
-              <a:t>26029-PFD-003 rev A · Coleraine / Riverridge · WTT 26029 rev 1 basis · sheet 1 of 3</a:t>
+              <a:t>26029-PFD-003 rev B · Coleraine / Riverridge · WTT 26029 rev 1 basis · sheet 1 of 3</a:t>
             </a:r>
             <a:endParaRPr lang="en-US" sz="800" dirty="0"/>
           </a:p>
@@ -1969,7 +1969,7 @@
                 <a:ea typeface="Courier New" pitchFamily="34" charset="-122"/>
                 <a:cs typeface="Courier New" pitchFamily="34" charset="-120"/>
               </a:rPr>
-              <a:t>INTERIM · NOT FOR CONSTRUCTION</a:t>
+              <a:t>SELECTED LAYOUT · INTERIM</a:t>
             </a:r>
             <a:endParaRPr lang="en-US" sz="900" dirty="0"/>
           </a:p>
@@ -3919,7 +3919,7 @@
                 <a:ea typeface="Courier New" pitchFamily="34" charset="-122"/>
                 <a:cs typeface="Courier New" pitchFamily="34" charset="-120"/>
               </a:rPr>
-              <a:t>26029-PFD-003 rev A · Coleraine / Riverridge · WTT 26029 rev 1 basis · sheet 2 of 3</a:t>
+              <a:t>26029-PFD-003 rev B · Coleraine / Riverridge · WTT 26029 rev 1 basis · sheet 2 of 3</a:t>
             </a:r>
             <a:endParaRPr lang="en-US" sz="800" dirty="0"/>
           </a:p>
@@ -4072,7 +4072,7 @@
                 <a:ea typeface="Courier New" pitchFamily="34" charset="-122"/>
                 <a:cs typeface="Courier New" pitchFamily="34" charset="-120"/>
               </a:rPr>
-              <a:t>INTERIM · NOT FOR CONSTRUCTION</a:t>
+              <a:t>SELECTED LAYOUT · INTERIM</a:t>
             </a:r>
             <a:endParaRPr lang="en-US" sz="900" dirty="0"/>
           </a:p>
@@ -9606,7 +9606,7 @@
                 <a:ea typeface="Courier New" pitchFamily="34" charset="-122"/>
                 <a:cs typeface="Courier New" pitchFamily="34" charset="-120"/>
               </a:rPr>
-              <a:t>26029-PFD-003 rev A · Coleraine / Riverridge · WTT 26029 rev 1 basis · sheet 3 of 3</a:t>
+              <a:t>26029-PFD-003 rev B · Coleraine / Riverridge · WTT 26029 rev 1 basis · sheet 3 of 3</a:t>
             </a:r>
             <a:endParaRPr lang="en-US" sz="800" dirty="0"/>
           </a:p>

</xml_diff>

<commit_message>
Add 80 mm preprocessing: SH-01 → trommel TR-01 → unders to bays, overs via SH-03 secondary shredder; 5 magnets
- Blueprint 26029-PFD-003 rev C: TR-01, SH-03, M1–M5, Blazequel on both shredders, streams 3a/4a/4b/16
- Dashboard: preprocessing inputs (unders %, ferrous %, magnet capture) and design row
- Methodology sheet 7: trommel split, SH-03 rate, ferrous balance
- PowerPoint regenerated (rev C)

Co-Authored-By: Claude Opus 5.5 <noreply@anthropic.com>
Claude-Session: https://claude.ai/code/session_01DJdAKW37ox1vjrzWffae3K
</commit_message>
<xml_diff>
--- a/Coleraine-6x40m-Tunnel-PFD.pptx
+++ b/Coleraine-6x40m-Tunnel-PFD.pptx
@@ -504,7 +504,7 @@
           <a:p>
             <a:r>
               <a:rPr lang="en-US" dirty="0"/>
-              <a:t>6 identical 40 m tunnels: stage 1 is unchanged from WTT (481 t at 4.46 m); stage 2 holds 384 t at 3.56 m, so any tunnel can take a stage 1 batch if one is out of service. WTT should confirm stage 2 heat and aeration for the lower pile. MSW goes from reception straight to SH-01 (no picking station), with Blazequel fire detection on the outfeed belt. Shredded MSW waits at least 12 h in four IR-watched detection bays (two pairs, one per shredding day) before filling a stage 1 tunnel. Stage 1 turns into an emptied stage 2 tunnel on Mon/Wed/Fri. Stage 2 empties into the OS-01 storage bays, then the DH-01 dosing hopper meters SP-01 at 33 t/h. Bulky waste has its own shredder, SH-02, and does not go to the tunnels.</a:t>
+              <a:t>Rev C adds preprocessing: SH-01 primary shredder, M1, TR-01 80 mm trommel. Unders (65%, assumed) go via M2 to the detection bays; overs (35%) go via M3 to the SH-03 secondary shredder (about 16.3 t/h) and M4, then to the bays. Blazequel on both shredder outfeeds. M5 sits on the SP-01 output line. Tunnel figures keep WTT's 75,000 t basis; ferrous removal makes them about 1.2% conservative.</a:t>
             </a:r>
             <a:endParaRPr lang="en-US" dirty="0"/>
           </a:p>
@@ -592,7 +592,7 @@
           <a:p>
             <a:r>
               <a:rPr lang="en-US" dirty="0"/>
-              <a:t>Bucket counts use a 9 m³ bucket and an assumed 2-minute cycle. L2 feeds SH-01 in short spells, about 2.6 h of work a day. L1 feeds the dosing hopper in the afternoons; L2 covers the hopper on Mon/Wed/Fri until L1 finishes turning at 14:38. SH-02 is assumed to have its own grab or feeder. The 12 h hold works because shredding ends at 17:08 and the next fill starts at 07:00.</a:t>
+              <a:t>Shown for the 7 + 7 process with a turn. In single-pass 14-day mode, loads are Tue/Thu/Fri and unloads Mon/Wed/Thu (see the dashboard and the rotation page). Bucket counts at 9 m³ and an assumed 2-minute cycle.</a:t>
             </a:r>
             <a:endParaRPr lang="en-US" dirty="0"/>
           </a:p>
@@ -680,7 +680,7 @@
           <a:p>
             <a:r>
               <a:rPr lang="en-US" dirty="0"/>
-              <a:t>Streams are identical to the 40 + 33 m layout; only the stage 2 tunnel length changes. m³ at 350 kg/m³ throughout; the output density is not in the WTT sheet, so 0.35 t/m³ is assumed and may be low for dry compost. Build 2 doubles every MSW stream and uses T1–T6 stage 1 and T7–T12 stage 2; it needs a second 33 t/h line and about 4 loaders.</a:t>
+              <a:t>Streams 3a, 4a, 4b and 16 are new in rev C. Tunnel streams keep WTT's 75,000 t basis even though ~870 t of ferrous is removed before the tunnels (about 1.2% conservative). m³ at 350 kg/m³.</a:t>
             </a:r>
             <a:endParaRPr lang="en-US" dirty="0"/>
           </a:p>
@@ -1125,7 +1125,7 @@
                 <a:ea typeface="Arial" pitchFamily="34" charset="-122"/>
                 <a:cs typeface="Arial" pitchFamily="34" charset="-120"/>
               </a:rPr>
-              <a:t>75,000 t/yr MSW · 6 identical tunnels 40 × 8 × 6 m (T1–T3 stage 1, T4–T6 stage 2) · Mon–Sat · 350 kg/m³</a:t>
+              <a:t>75,000 t/yr MSW · SH-01 → 80 mm trommel → SH-03 on overs · 5 magnets · 6 identical tunnels 40 × 8 × 6 m · Mon–Sat</a:t>
             </a:r>
             <a:endParaRPr lang="en-US" sz="1200" dirty="0"/>
           </a:p>
@@ -1348,7 +1348,7 @@
                 <a:ea typeface="Arial" pitchFamily="34" charset="-122"/>
                 <a:cs typeface="Arial" pitchFamily="34" charset="-120"/>
               </a:rPr>
-              <a:t>3.56 m</a:t>
+              <a:t>80 mm</a:t>
             </a:r>
             <a:endParaRPr lang="en-US" sz="2400" dirty="0"/>
           </a:p>
@@ -1387,7 +1387,7 @@
                 <a:ea typeface="Arial" pitchFamily="34" charset="-122"/>
                 <a:cs typeface="Arial" pitchFamily="34" charset="-120"/>
               </a:rPr>
-              <a:t>STAGE 2 FILL (40 M)</a:t>
+              <a:t>TROMMEL TR-01</a:t>
             </a:r>
             <a:endParaRPr lang="en-US" sz="1000" dirty="0"/>
           </a:p>
@@ -1426,7 +1426,7 @@
                 <a:ea typeface="Arial" pitchFamily="34" charset="-122"/>
                 <a:cs typeface="Arial" pitchFamily="34" charset="-120"/>
               </a:rPr>
-              <a:t>384 t · 101 t spare per fill</a:t>
+              <a:t>65% unders · 35% to SH-03</a:t>
             </a:r>
             <a:endParaRPr lang="en-US" sz="1000" dirty="0"/>
           </a:p>
@@ -1582,7 +1582,7 @@
                 <a:ea typeface="Arial" pitchFamily="34" charset="-122"/>
                 <a:cs typeface="Arial" pitchFamily="34" charset="-120"/>
               </a:rPr>
-              <a:t>2 × 9 m³</a:t>
+              <a:t>~950 t</a:t>
             </a:r>
             <a:endParaRPr lang="en-US" sz="2400" dirty="0"/>
           </a:p>
@@ -1621,7 +1621,7 @@
                 <a:ea typeface="Arial" pitchFamily="34" charset="-122"/>
                 <a:cs typeface="Arial" pitchFamily="34" charset="-120"/>
               </a:rPr>
-              <a:t>LOADERS</a:t>
+              <a:t>FERROUS RECOVERED</a:t>
             </a:r>
             <a:endParaRPr lang="en-US" sz="1000" dirty="0"/>
           </a:p>
@@ -1660,7 +1660,7 @@
                 <a:ea typeface="Arial" pitchFamily="34" charset="-122"/>
                 <a:cs typeface="Arial" pitchFamily="34" charset="-120"/>
               </a:rPr>
-              <a:t>~3,340 h/yr in total</a:t>
+              <a:t>5 magnets · 1.29% Fe</a:t>
             </a:r>
             <a:endParaRPr lang="en-US" sz="1000" dirty="0"/>
           </a:p>
@@ -1699,7 +1699,7 @@
                 <a:ea typeface="Arial" pitchFamily="34" charset="-122"/>
                 <a:cs typeface="Arial" pitchFamily="34" charset="-120"/>
               </a:rPr>
-              <a:t>1,920 m²</a:t>
+              <a:t>4.46 m</a:t>
             </a:r>
             <a:endParaRPr lang="en-US" sz="2400" dirty="0"/>
           </a:p>
@@ -1738,7 +1738,7 @@
                 <a:ea typeface="Arial" pitchFamily="34" charset="-122"/>
                 <a:cs typeface="Arial" pitchFamily="34" charset="-120"/>
               </a:rPr>
-              <a:t>TUNNEL FLOOR</a:t>
+              <a:t>FILL IN EVERY TUNNEL</a:t>
             </a:r>
             <a:endParaRPr lang="en-US" sz="1000" dirty="0"/>
           </a:p>
@@ -1777,7 +1777,7 @@
                 <a:ea typeface="Arial" pitchFamily="34" charset="-122"/>
                 <a:cs typeface="Arial" pitchFamily="34" charset="-120"/>
               </a:rPr>
-              <a:t>+168 m² vs 40 + 33 m</a:t>
+              <a:t>481 t per load · 40 m</a:t>
             </a:r>
             <a:endParaRPr lang="en-US" sz="1000" dirty="0"/>
           </a:p>
@@ -1816,7 +1816,7 @@
                 <a:ea typeface="Courier New" pitchFamily="34" charset="-122"/>
                 <a:cs typeface="Courier New" pitchFamily="34" charset="-120"/>
               </a:rPr>
-              <a:t>26029-PFD-003 rev B · Coleraine / Riverridge · WTT 26029 rev 1 basis · sheet 1 of 3</a:t>
+              <a:t>26029-PFD-003 rev C · Coleraine / Riverridge · WTT 26029 rev 1 basis · sheet 1 of 3</a:t>
             </a:r>
             <a:endParaRPr lang="en-US" sz="800" dirty="0"/>
           </a:p>
@@ -1887,7 +1887,7 @@
                 <a:ea typeface="Arial" pitchFamily="34" charset="-122"/>
                 <a:cs typeface="Arial" pitchFamily="34" charset="-120"/>
               </a:rPr>
-              <a:t>DAILY RHYTHM · 6 × 40 m</a:t>
+              <a:t>DAILY RHYTHM · MON–SAT</a:t>
             </a:r>
             <a:endParaRPr lang="en-US" sz="2400" dirty="0"/>
           </a:p>
@@ -1926,7 +1926,7 @@
                 <a:ea typeface="Arial" pitchFamily="34" charset="-122"/>
                 <a:cs typeface="Arial" pitchFamily="34" charset="-120"/>
               </a:rPr>
-              <a:t>Same as the 40 + 33 m layout: tonnes and volumes are unchanged. Loading in the morning, shredding in the afternoon.</a:t>
+              <a:t>Loading in the morning, shredding and screening in the afternoon, so the two never share a bay.</a:t>
             </a:r>
             <a:endParaRPr lang="en-US" sz="1200" dirty="0"/>
           </a:p>
@@ -1984,7 +1984,7 @@
         <p:spPr>
           <a:xfrm>
             <a:off x="2377440" y="1371600"/>
-            <a:ext cx="0" cy="3557016"/>
+            <a:ext cx="0" cy="3337560"/>
           </a:xfrm>
           <a:prstGeom prst="line">
             <a:avLst/>
@@ -2046,7 +2046,7 @@
         <p:spPr>
           <a:xfrm>
             <a:off x="3046911" y="1371600"/>
-            <a:ext cx="0" cy="3557016"/>
+            <a:ext cx="0" cy="3337560"/>
           </a:xfrm>
           <a:prstGeom prst="line">
             <a:avLst/>
@@ -2069,7 +2069,7 @@
         <p:spPr>
           <a:xfrm>
             <a:off x="3716383" y="1371600"/>
-            <a:ext cx="0" cy="3557016"/>
+            <a:ext cx="0" cy="3337560"/>
           </a:xfrm>
           <a:prstGeom prst="line">
             <a:avLst/>
@@ -2131,7 +2131,7 @@
         <p:spPr>
           <a:xfrm>
             <a:off x="4385854" y="1371600"/>
-            <a:ext cx="0" cy="3557016"/>
+            <a:ext cx="0" cy="3337560"/>
           </a:xfrm>
           <a:prstGeom prst="line">
             <a:avLst/>
@@ -2154,7 +2154,7 @@
         <p:spPr>
           <a:xfrm>
             <a:off x="5055326" y="1371600"/>
-            <a:ext cx="0" cy="3557016"/>
+            <a:ext cx="0" cy="3337560"/>
           </a:xfrm>
           <a:prstGeom prst="line">
             <a:avLst/>
@@ -2216,7 +2216,7 @@
         <p:spPr>
           <a:xfrm>
             <a:off x="5724797" y="1371600"/>
-            <a:ext cx="0" cy="3557016"/>
+            <a:ext cx="0" cy="3337560"/>
           </a:xfrm>
           <a:prstGeom prst="line">
             <a:avLst/>
@@ -2239,7 +2239,7 @@
         <p:spPr>
           <a:xfrm>
             <a:off x="6394269" y="1371600"/>
-            <a:ext cx="0" cy="3557016"/>
+            <a:ext cx="0" cy="3337560"/>
           </a:xfrm>
           <a:prstGeom prst="line">
             <a:avLst/>
@@ -2301,7 +2301,7 @@
         <p:spPr>
           <a:xfrm>
             <a:off x="7063740" y="1371600"/>
-            <a:ext cx="0" cy="3557016"/>
+            <a:ext cx="0" cy="3337560"/>
           </a:xfrm>
           <a:prstGeom prst="line">
             <a:avLst/>
@@ -2324,7 +2324,7 @@
         <p:spPr>
           <a:xfrm>
             <a:off x="7733211" y="1371600"/>
-            <a:ext cx="0" cy="3557016"/>
+            <a:ext cx="0" cy="3337560"/>
           </a:xfrm>
           <a:prstGeom prst="line">
             <a:avLst/>
@@ -2386,7 +2386,7 @@
         <p:spPr>
           <a:xfrm>
             <a:off x="8402683" y="1371600"/>
-            <a:ext cx="0" cy="3557016"/>
+            <a:ext cx="0" cy="3337560"/>
           </a:xfrm>
           <a:prstGeom prst="line">
             <a:avLst/>
@@ -2409,7 +2409,7 @@
         <p:spPr>
           <a:xfrm>
             <a:off x="9072154" y="1371600"/>
-            <a:ext cx="0" cy="3557016"/>
+            <a:ext cx="0" cy="3337560"/>
           </a:xfrm>
           <a:prstGeom prst="line">
             <a:avLst/>
@@ -2471,7 +2471,7 @@
         <p:spPr>
           <a:xfrm>
             <a:off x="9741626" y="1371600"/>
-            <a:ext cx="0" cy="3557016"/>
+            <a:ext cx="0" cy="3337560"/>
           </a:xfrm>
           <a:prstGeom prst="line">
             <a:avLst/>
@@ -2494,7 +2494,7 @@
         <p:spPr>
           <a:xfrm>
             <a:off x="10411097" y="1371600"/>
-            <a:ext cx="0" cy="3557016"/>
+            <a:ext cx="0" cy="3337560"/>
           </a:xfrm>
           <a:prstGeom prst="line">
             <a:avLst/>
@@ -2556,7 +2556,7 @@
         <p:spPr>
           <a:xfrm>
             <a:off x="11080569" y="1371600"/>
-            <a:ext cx="0" cy="3557016"/>
+            <a:ext cx="0" cy="3337560"/>
           </a:xfrm>
           <a:prstGeom prst="line">
             <a:avLst/>
@@ -2579,7 +2579,7 @@
         <p:spPr>
           <a:xfrm>
             <a:off x="11750040" y="1371600"/>
-            <a:ext cx="0" cy="3557016"/>
+            <a:ext cx="0" cy="3337560"/>
           </a:xfrm>
           <a:prstGeom prst="line">
             <a:avLst/>
@@ -2640,8 +2640,8 @@
         </p:nvSpPr>
         <p:spPr>
           <a:xfrm>
-            <a:off x="411480" y="1472184"/>
-            <a:ext cx="1874520" cy="329184"/>
+            <a:off x="411480" y="1463040"/>
+            <a:ext cx="1920240" cy="320040"/>
           </a:xfrm>
           <a:prstGeom prst="rect">
             <a:avLst/>
@@ -2657,7 +2657,7 @@
               <a:buNone/>
             </a:pPr>
             <a:r>
-              <a:rPr lang="en-US" sz="1200" b="1" dirty="0">
+              <a:rPr lang="en-US" sz="1100" b="1" dirty="0">
                 <a:solidFill>
                   <a:srgbClr val="E8F1FF"/>
                 </a:solidFill>
@@ -2667,7 +2667,7 @@
               </a:rPr>
               <a:t>L1 · Mon/Wed/Fri</a:t>
             </a:r>
-            <a:endParaRPr lang="en-US" sz="1200" dirty="0"/>
+            <a:endParaRPr lang="en-US" sz="1100" dirty="0"/>
           </a:p>
         </p:txBody>
       </p:sp>
@@ -2679,8 +2679,8 @@
         </p:nvSpPr>
         <p:spPr>
           <a:xfrm>
-            <a:off x="5436924" y="1472184"/>
-            <a:ext cx="2718054" cy="329184"/>
+            <a:off x="5436924" y="1463040"/>
+            <a:ext cx="2718054" cy="320040"/>
           </a:xfrm>
           <a:prstGeom prst="rect">
             <a:avLst/>
@@ -2712,7 +2712,7 @@
                 <a:ea typeface="Arial" pitchFamily="34" charset="-122"/>
                 <a:cs typeface="Arial" pitchFamily="34" charset="-120"/>
               </a:rPr>
-              <a:t>  ② turn T1→T4 · 122 buckets</a:t>
+              <a:t>  ② turn T1→T4 · 122 b</a:t>
             </a:r>
             <a:endParaRPr lang="en-US" sz="1000" dirty="0"/>
           </a:p>
@@ -2726,8 +2726,8 @@
         </p:nvSpPr>
         <p:spPr>
           <a:xfrm>
-            <a:off x="8154978" y="1472184"/>
-            <a:ext cx="2343150" cy="329184"/>
+            <a:off x="8154978" y="1463040"/>
+            <a:ext cx="2343150" cy="320040"/>
           </a:xfrm>
           <a:prstGeom prst="rect">
             <a:avLst/>
@@ -2773,8 +2773,8 @@
         </p:nvSpPr>
         <p:spPr>
           <a:xfrm>
-            <a:off x="411480" y="1911096"/>
-            <a:ext cx="1874520" cy="329184"/>
+            <a:off x="411480" y="1874520"/>
+            <a:ext cx="1920240" cy="320040"/>
           </a:xfrm>
           <a:prstGeom prst="rect">
             <a:avLst/>
@@ -2790,7 +2790,7 @@
               <a:buNone/>
             </a:pPr>
             <a:r>
-              <a:rPr lang="en-US" sz="1200" b="1" dirty="0">
+              <a:rPr lang="en-US" sz="1100" b="1" dirty="0">
                 <a:solidFill>
                   <a:srgbClr val="E8F1FF"/>
                 </a:solidFill>
@@ -2800,7 +2800,7 @@
               </a:rPr>
               <a:t>L2 · Mon/Wed/Fri</a:t>
             </a:r>
-            <a:endParaRPr lang="en-US" sz="1200" dirty="0"/>
+            <a:endParaRPr lang="en-US" sz="1100" dirty="0"/>
           </a:p>
         </p:txBody>
       </p:sp>
@@ -2812,8 +2812,8 @@
         </p:nvSpPr>
         <p:spPr>
           <a:xfrm>
-            <a:off x="3046911" y="1911096"/>
-            <a:ext cx="2390013" cy="329184"/>
+            <a:off x="3046911" y="1874520"/>
+            <a:ext cx="2390013" cy="320040"/>
           </a:xfrm>
           <a:prstGeom prst="rect">
             <a:avLst/>
@@ -2859,8 +2859,8 @@
         </p:nvSpPr>
         <p:spPr>
           <a:xfrm>
-            <a:off x="6394269" y="1911096"/>
-            <a:ext cx="3434388" cy="329184"/>
+            <a:off x="6394269" y="1874520"/>
+            <a:ext cx="3434388" cy="320040"/>
           </a:xfrm>
           <a:prstGeom prst="rect">
             <a:avLst/>
@@ -2906,8 +2906,8 @@
         </p:nvSpPr>
         <p:spPr>
           <a:xfrm>
-            <a:off x="411480" y="2350008"/>
-            <a:ext cx="1874520" cy="329184"/>
+            <a:off x="411480" y="2286000"/>
+            <a:ext cx="1920240" cy="320040"/>
           </a:xfrm>
           <a:prstGeom prst="rect">
             <a:avLst/>
@@ -2923,7 +2923,7 @@
               <a:buNone/>
             </a:pPr>
             <a:r>
-              <a:rPr lang="en-US" sz="1200" b="1" dirty="0">
+              <a:rPr lang="en-US" sz="1100" b="1" dirty="0">
                 <a:solidFill>
                   <a:srgbClr val="E8F1FF"/>
                 </a:solidFill>
@@ -2933,7 +2933,7 @@
               </a:rPr>
               <a:t>L1 · Tue/Thu/Sat</a:t>
             </a:r>
-            <a:endParaRPr lang="en-US" sz="1200" dirty="0"/>
+            <a:endParaRPr lang="en-US" sz="1100" dirty="0"/>
           </a:p>
         </p:txBody>
       </p:sp>
@@ -2945,8 +2945,8 @@
         </p:nvSpPr>
         <p:spPr>
           <a:xfrm>
-            <a:off x="3046911" y="2350008"/>
-            <a:ext cx="3414304" cy="329184"/>
+            <a:off x="3046911" y="2286000"/>
+            <a:ext cx="3414304" cy="320040"/>
           </a:xfrm>
           <a:prstGeom prst="rect">
             <a:avLst/>
@@ -2992,8 +2992,8 @@
         </p:nvSpPr>
         <p:spPr>
           <a:xfrm>
-            <a:off x="7063740" y="2350008"/>
-            <a:ext cx="3434388" cy="329184"/>
+            <a:off x="7063740" y="2286000"/>
+            <a:ext cx="3434388" cy="320040"/>
           </a:xfrm>
           <a:prstGeom prst="rect">
             <a:avLst/>
@@ -3039,8 +3039,8 @@
         </p:nvSpPr>
         <p:spPr>
           <a:xfrm>
-            <a:off x="411480" y="2788920"/>
-            <a:ext cx="1874520" cy="329184"/>
+            <a:off x="411480" y="2697480"/>
+            <a:ext cx="1920240" cy="320040"/>
           </a:xfrm>
           <a:prstGeom prst="rect">
             <a:avLst/>
@@ -3056,7 +3056,7 @@
               <a:buNone/>
             </a:pPr>
             <a:r>
-              <a:rPr lang="en-US" sz="1200" b="1" dirty="0">
+              <a:rPr lang="en-US" sz="1100" b="1" dirty="0">
                 <a:solidFill>
                   <a:srgbClr val="E8F1FF"/>
                 </a:solidFill>
@@ -3066,7 +3066,7 @@
               </a:rPr>
               <a:t>L2 · Tue/Thu/Sat</a:t>
             </a:r>
-            <a:endParaRPr lang="en-US" sz="1200" dirty="0"/>
+            <a:endParaRPr lang="en-US" sz="1100" dirty="0"/>
           </a:p>
         </p:txBody>
       </p:sp>
@@ -3078,8 +3078,8 @@
         </p:nvSpPr>
         <p:spPr>
           <a:xfrm>
-            <a:off x="6394269" y="2788920"/>
-            <a:ext cx="3434388" cy="329184"/>
+            <a:off x="6394269" y="2697480"/>
+            <a:ext cx="3434388" cy="320040"/>
           </a:xfrm>
           <a:prstGeom prst="rect">
             <a:avLst/>
@@ -3125,8 +3125,8 @@
         </p:nvSpPr>
         <p:spPr>
           <a:xfrm>
-            <a:off x="411480" y="3227832"/>
-            <a:ext cx="1874520" cy="329184"/>
+            <a:off x="411480" y="3108960"/>
+            <a:ext cx="1920240" cy="320040"/>
           </a:xfrm>
           <a:prstGeom prst="rect">
             <a:avLst/>
@@ -3142,7 +3142,7 @@
               <a:buNone/>
             </a:pPr>
             <a:r>
-              <a:rPr lang="en-US" sz="1200" b="1" dirty="0">
+              <a:rPr lang="en-US" sz="1100" b="1" dirty="0">
                 <a:solidFill>
                   <a:srgbClr val="E8F1FF"/>
                 </a:solidFill>
@@ -3150,9 +3150,9 @@
                 <a:ea typeface="Arial" pitchFamily="34" charset="-122"/>
                 <a:cs typeface="Arial" pitchFamily="34" charset="-120"/>
               </a:rPr>
-              <a:t>SH-01 MSW</a:t>
+              <a:t>SH-01 → TR-01 → SH-03</a:t>
             </a:r>
-            <a:endParaRPr lang="en-US" sz="1200" dirty="0"/>
+            <a:endParaRPr lang="en-US" sz="1100" dirty="0"/>
           </a:p>
         </p:txBody>
       </p:sp>
@@ -3164,8 +3164,8 @@
         </p:nvSpPr>
         <p:spPr>
           <a:xfrm>
-            <a:off x="6394269" y="3227832"/>
-            <a:ext cx="3434388" cy="329184"/>
+            <a:off x="6394269" y="3108960"/>
+            <a:ext cx="3434388" cy="320040"/>
           </a:xfrm>
           <a:prstGeom prst="rect">
             <a:avLst/>
@@ -3197,7 +3197,7 @@
                 <a:ea typeface="Arial" pitchFamily="34" charset="-122"/>
                 <a:cs typeface="Arial" pitchFamily="34" charset="-120"/>
               </a:rPr>
-              <a:t>  shred 240 t → next empty bay pair</a:t>
+              <a:t>  shred · screen 80 mm · overs re-shred → bays</a:t>
             </a:r>
             <a:endParaRPr lang="en-US" sz="1000" dirty="0"/>
           </a:p>
@@ -3211,8 +3211,8 @@
         </p:nvSpPr>
         <p:spPr>
           <a:xfrm>
-            <a:off x="411480" y="3666744"/>
-            <a:ext cx="1874520" cy="329184"/>
+            <a:off x="411480" y="3520440"/>
+            <a:ext cx="1920240" cy="320040"/>
           </a:xfrm>
           <a:prstGeom prst="rect">
             <a:avLst/>
@@ -3228,7 +3228,7 @@
               <a:buNone/>
             </a:pPr>
             <a:r>
-              <a:rPr lang="en-US" sz="1200" b="1" dirty="0">
+              <a:rPr lang="en-US" sz="1100" b="1" dirty="0">
                 <a:solidFill>
                   <a:srgbClr val="E8F1FF"/>
                 </a:solidFill>
@@ -3238,7 +3238,7 @@
               </a:rPr>
               <a:t>DH-01 → SP-01</a:t>
             </a:r>
-            <a:endParaRPr lang="en-US" sz="1200" dirty="0"/>
+            <a:endParaRPr lang="en-US" sz="1100" dirty="0"/>
           </a:p>
         </p:txBody>
       </p:sp>
@@ -3250,8 +3250,8 @@
         </p:nvSpPr>
         <p:spPr>
           <a:xfrm>
-            <a:off x="7063740" y="3666744"/>
-            <a:ext cx="3434388" cy="329184"/>
+            <a:off x="7063740" y="3520440"/>
+            <a:ext cx="3434388" cy="320040"/>
           </a:xfrm>
           <a:prstGeom prst="rect">
             <a:avLst/>
@@ -3283,7 +3283,7 @@
                 <a:ea typeface="Arial" pitchFamily="34" charset="-122"/>
                 <a:cs typeface="Arial" pitchFamily="34" charset="-120"/>
               </a:rPr>
-              <a:t>  secondary processing 33 t/h</a:t>
+              <a:t>  secondary processing 33 t/h · M5</a:t>
             </a:r>
             <a:endParaRPr lang="en-US" sz="1000" dirty="0"/>
           </a:p>
@@ -3297,8 +3297,8 @@
         </p:nvSpPr>
         <p:spPr>
           <a:xfrm>
-            <a:off x="411480" y="4105656"/>
-            <a:ext cx="1874520" cy="329184"/>
+            <a:off x="411480" y="3931920"/>
+            <a:ext cx="1920240" cy="320040"/>
           </a:xfrm>
           <a:prstGeom prst="rect">
             <a:avLst/>
@@ -3314,7 +3314,7 @@
               <a:buNone/>
             </a:pPr>
             <a:r>
-              <a:rPr lang="en-US" sz="1200" b="1" dirty="0">
+              <a:rPr lang="en-US" sz="1100" b="1" dirty="0">
                 <a:solidFill>
                   <a:srgbClr val="E8F1FF"/>
                 </a:solidFill>
@@ -3324,7 +3324,7 @@
               </a:rPr>
               <a:t>SH-02 bulky</a:t>
             </a:r>
-            <a:endParaRPr lang="en-US" sz="1200" dirty="0"/>
+            <a:endParaRPr lang="en-US" sz="1100" dirty="0"/>
           </a:p>
         </p:txBody>
       </p:sp>
@@ -3336,8 +3336,8 @@
         </p:nvSpPr>
         <p:spPr>
           <a:xfrm>
-            <a:off x="3046911" y="4105656"/>
-            <a:ext cx="3213463" cy="329184"/>
+            <a:off x="3046911" y="3931920"/>
+            <a:ext cx="3213463" cy="320040"/>
           </a:xfrm>
           <a:prstGeom prst="rect">
             <a:avLst/>
@@ -3383,8 +3383,8 @@
         </p:nvSpPr>
         <p:spPr>
           <a:xfrm>
-            <a:off x="411480" y="4544568"/>
-            <a:ext cx="1874520" cy="329184"/>
+            <a:off x="411480" y="4343400"/>
+            <a:ext cx="1920240" cy="320040"/>
           </a:xfrm>
           <a:prstGeom prst="rect">
             <a:avLst/>
@@ -3400,7 +3400,7 @@
               <a:buNone/>
             </a:pPr>
             <a:r>
-              <a:rPr lang="en-US" sz="1200" b="1" dirty="0">
+              <a:rPr lang="en-US" sz="1100" b="1" dirty="0">
                 <a:solidFill>
                   <a:srgbClr val="E8F1FF"/>
                 </a:solidFill>
@@ -3410,7 +3410,7 @@
               </a:rPr>
               <a:t>Detection bays</a:t>
             </a:r>
-            <a:endParaRPr lang="en-US" sz="1200" dirty="0"/>
+            <a:endParaRPr lang="en-US" sz="1100" dirty="0"/>
           </a:p>
         </p:txBody>
       </p:sp>
@@ -3422,8 +3422,8 @@
         </p:nvSpPr>
         <p:spPr>
           <a:xfrm>
-            <a:off x="2377440" y="4544568"/>
-            <a:ext cx="9372600" cy="329184"/>
+            <a:off x="2377440" y="4343400"/>
+            <a:ext cx="9372600" cy="320040"/>
           </a:xfrm>
           <a:prstGeom prst="rect">
             <a:avLst/>
@@ -3468,7 +3468,7 @@
         </p:nvSpPr>
         <p:spPr>
           <a:xfrm>
-            <a:off x="411480" y="5248656"/>
+            <a:off x="411480" y="5029200"/>
             <a:ext cx="3611880" cy="960120"/>
           </a:xfrm>
           <a:prstGeom prst="rect">
@@ -3493,7 +3493,7 @@
         </p:nvSpPr>
         <p:spPr>
           <a:xfrm>
-            <a:off x="594360" y="5340096"/>
+            <a:off x="594360" y="5120640"/>
             <a:ext cx="1417320" cy="457200"/>
           </a:xfrm>
           <a:prstGeom prst="rect">
@@ -3532,7 +3532,7 @@
         </p:nvSpPr>
         <p:spPr>
           <a:xfrm>
-            <a:off x="2057400" y="5358384"/>
+            <a:off x="2057400" y="5138928"/>
             <a:ext cx="1828800" cy="411480"/>
           </a:xfrm>
           <a:prstGeom prst="rect">
@@ -3571,7 +3571,7 @@
         </p:nvSpPr>
         <p:spPr>
           <a:xfrm>
-            <a:off x="594360" y="5797296"/>
+            <a:off x="594360" y="5577840"/>
             <a:ext cx="3246120" cy="347472"/>
           </a:xfrm>
           <a:prstGeom prst="rect">
@@ -3610,7 +3610,7 @@
         </p:nvSpPr>
         <p:spPr>
           <a:xfrm>
-            <a:off x="4270248" y="5248656"/>
+            <a:off x="4270248" y="5029200"/>
             <a:ext cx="3611880" cy="960120"/>
           </a:xfrm>
           <a:prstGeom prst="rect">
@@ -3635,7 +3635,7 @@
         </p:nvSpPr>
         <p:spPr>
           <a:xfrm>
-            <a:off x="4453128" y="5340096"/>
+            <a:off x="4453128" y="5120640"/>
             <a:ext cx="1417320" cy="457200"/>
           </a:xfrm>
           <a:prstGeom prst="rect">
@@ -3652,7 +3652,7 @@
               <a:buNone/>
             </a:pPr>
             <a:r>
-              <a:rPr lang="en-US" sz="1600" b="1" dirty="0">
+              <a:rPr lang="en-US" sz="2000" b="1" dirty="0">
                 <a:solidFill>
                   <a:srgbClr val="E8F1FF"/>
                 </a:solidFill>
@@ -3660,9 +3660,9 @@
                 <a:ea typeface="Arial" pitchFamily="34" charset="-122"/>
                 <a:cs typeface="Arial" pitchFamily="34" charset="-120"/>
               </a:rPr>
-              <a:t>①→②→③</a:t>
+              <a:t>16.3 t/h</a:t>
             </a:r>
-            <a:endParaRPr lang="en-US" sz="1600" dirty="0"/>
+            <a:endParaRPr lang="en-US" sz="2000" dirty="0"/>
           </a:p>
         </p:txBody>
       </p:sp>
@@ -3674,7 +3674,7 @@
         </p:nvSpPr>
         <p:spPr>
           <a:xfrm>
-            <a:off x="5916168" y="5358384"/>
+            <a:off x="5916168" y="5138928"/>
             <a:ext cx="1828800" cy="411480"/>
           </a:xfrm>
           <a:prstGeom prst="rect">
@@ -3699,7 +3699,7 @@
                 <a:ea typeface="Arial" pitchFamily="34" charset="-122"/>
                 <a:cs typeface="Arial" pitchFamily="34" charset="-120"/>
               </a:rPr>
-              <a:t>empty, turn, refill</a:t>
+              <a:t>SH-03 on trommel overs</a:t>
             </a:r>
             <a:endParaRPr lang="en-US" sz="1100" dirty="0"/>
           </a:p>
@@ -3713,7 +3713,7 @@
         </p:nvSpPr>
         <p:spPr>
           <a:xfrm>
-            <a:off x="4453128" y="5797296"/>
+            <a:off x="4453128" y="5577840"/>
             <a:ext cx="3246120" cy="347472"/>
           </a:xfrm>
           <a:prstGeom prst="rect">
@@ -3738,7 +3738,7 @@
                 <a:ea typeface="Arial" pitchFamily="34" charset="-122"/>
                 <a:cs typeface="Arial" pitchFamily="34" charset="-120"/>
               </a:rPr>
-              <a:t>the stage 2 tunnel is emptied before each turn; stage 1 refills next day</a:t>
+              <a:t>26,047 t/yr in the same 1,600 h as SH-01</a:t>
             </a:r>
             <a:endParaRPr lang="en-US" sz="1000" dirty="0"/>
           </a:p>
@@ -3752,7 +3752,7 @@
         </p:nvSpPr>
         <p:spPr>
           <a:xfrm>
-            <a:off x="8129016" y="5248656"/>
+            <a:off x="8129016" y="5029200"/>
             <a:ext cx="3611880" cy="960120"/>
           </a:xfrm>
           <a:prstGeom prst="rect">
@@ -3777,7 +3777,7 @@
         </p:nvSpPr>
         <p:spPr>
           <a:xfrm>
-            <a:off x="8311896" y="5340096"/>
+            <a:off x="8311896" y="5120640"/>
             <a:ext cx="1417320" cy="457200"/>
           </a:xfrm>
           <a:prstGeom prst="rect">
@@ -3816,7 +3816,7 @@
         </p:nvSpPr>
         <p:spPr>
           <a:xfrm>
-            <a:off x="9774936" y="5358384"/>
+            <a:off x="9774936" y="5138928"/>
             <a:ext cx="1828800" cy="411480"/>
           </a:xfrm>
           <a:prstGeom prst="rect">
@@ -3855,7 +3855,7 @@
         </p:nvSpPr>
         <p:spPr>
           <a:xfrm>
-            <a:off x="8311896" y="5797296"/>
+            <a:off x="8311896" y="5577840"/>
             <a:ext cx="3246120" cy="347472"/>
           </a:xfrm>
           <a:prstGeom prst="rect">
@@ -3880,7 +3880,7 @@
                 <a:ea typeface="Arial" pitchFamily="34" charset="-122"/>
                 <a:cs typeface="Arial" pitchFamily="34" charset="-120"/>
               </a:rPr>
-              <a:t>2 loaders at ~1,670 h each (4% over 1,600 h) or a third</a:t>
+              <a:t>2 loaders at ~1,670 h each (conveyors link SH-01, TR-01, SH-03)</a:t>
             </a:r>
             <a:endParaRPr lang="en-US" sz="1000" dirty="0"/>
           </a:p>
@@ -3919,7 +3919,7 @@
                 <a:ea typeface="Courier New" pitchFamily="34" charset="-122"/>
                 <a:cs typeface="Courier New" pitchFamily="34" charset="-120"/>
               </a:rPr>
-              <a:t>26029-PFD-003 rev B · Coleraine / Riverridge · WTT 26029 rev 1 basis · sheet 2 of 3</a:t>
+              <a:t>26029-PFD-003 rev C · Coleraine / Riverridge · WTT 26029 rev 1 basis · sheet 2 of 3</a:t>
             </a:r>
             <a:endParaRPr lang="en-US" sz="800" dirty="0"/>
           </a:p>
@@ -4029,7 +4029,7 @@
                 <a:ea typeface="Arial" pitchFamily="34" charset="-122"/>
                 <a:cs typeface="Arial" pitchFamily="34" charset="-120"/>
               </a:rPr>
-              <a:t>Annual averages, WTT 26029 rev 1 mass balance. MSW check: output 52,485 + off-gas 15,090 + 7,425 = 75,000 t/yr.</a:t>
+              <a:t>Annual averages, WTT 26029 rev 1 basis. MSW check: output 52,485 + off-gas 15,090 + 7,425 = 75,000 t/yr.</a:t>
             </a:r>
             <a:endParaRPr lang="en-US" sz="1200" dirty="0"/>
           </a:p>
@@ -4101,11 +4101,10 @@
             <a:tbl>
               <a:tblPr/>
               <a:tblGrid>
-                <a:gridCol w="457200"/>
-                <a:gridCol w="3657600"/>
+                <a:gridCol w="502920"/>
+                <a:gridCol w="4709160"/>
                 <a:gridCol w="1097280"/>
-                <a:gridCol w="731520"/>
-                <a:gridCol w="1280160"/>
+                <a:gridCol w="914400"/>
               </a:tblGrid>
               <a:tr h="329184">
                 <a:tc>
@@ -4330,74 +4329,6 @@
                           <a:cs typeface="Arial" pitchFamily="34" charset="-120"/>
                         </a:rPr>
                         <a:t>DS %</a:t>
-                      </a:r>
-                      <a:endParaRPr lang="en-US" sz="1000" dirty="0">
-                        <a:latin typeface="Arial" charset="0"/>
-                        <a:ea typeface="Arial" charset="0"/>
-                        <a:cs typeface="Arial" charset="0"/>
-                      </a:endParaRPr>
-                    </a:p>
-                  </a:txBody>
-                  <a:tcPr marL="73152" marR="73152" marT="18288" marB="18288" anchor="ctr">
-                    <a:lnL w="9525" cap="flat" cmpd="sng" algn="ctr">
-                      <a:solidFill>
-                        <a:srgbClr val="2A5790"/>
-                      </a:solidFill>
-                      <a:prstDash val="solid"/>
-                      <a:round/>
-                      <a:headEnd type="none" w="med" len="med"/>
-                      <a:tailEnd type="none" w="med" len="med"/>
-                    </a:lnL>
-                    <a:lnR w="9525" cap="flat" cmpd="sng" algn="ctr">
-                      <a:solidFill>
-                        <a:srgbClr val="2A5790"/>
-                      </a:solidFill>
-                      <a:prstDash val="solid"/>
-                      <a:round/>
-                      <a:headEnd type="none" w="med" len="med"/>
-                      <a:tailEnd type="none" w="med" len="med"/>
-                    </a:lnR>
-                    <a:lnT w="9525" cap="flat" cmpd="sng" algn="ctr">
-                      <a:solidFill>
-                        <a:srgbClr val="2A5790"/>
-                      </a:solidFill>
-                      <a:prstDash val="solid"/>
-                      <a:round/>
-                      <a:headEnd type="none" w="med" len="med"/>
-                      <a:tailEnd type="none" w="med" len="med"/>
-                    </a:lnT>
-                    <a:lnB w="9525" cap="flat" cmpd="sng" algn="ctr">
-                      <a:solidFill>
-                        <a:srgbClr val="2A5790"/>
-                      </a:solidFill>
-                      <a:prstDash val="solid"/>
-                      <a:round/>
-                      <a:headEnd type="none" w="med" len="med"/>
-                      <a:tailEnd type="none" w="med" len="med"/>
-                    </a:lnB>
-                    <a:solidFill>
-                      <a:srgbClr val="0D3B73"/>
-                    </a:solidFill>
-                  </a:tcPr>
-                </a:tc>
-                <a:tc>
-                  <a:txBody>
-                    <a:bodyPr/>
-                    <a:lstStyle/>
-                    <a:p>
-                      <a:pPr algn="r" indent="0" marL="0">
-                        <a:buNone/>
-                      </a:pPr>
-                      <a:r>
-                        <a:rPr lang="en-US" sz="1000" b="1" dirty="0">
-                          <a:solidFill>
-                            <a:srgbClr val="9EC3F0"/>
-                          </a:solidFill>
-                          <a:latin typeface="Arial" pitchFamily="34" charset="0"/>
-                          <a:ea typeface="Arial" pitchFamily="34" charset="-122"/>
-                          <a:cs typeface="Arial" pitchFamily="34" charset="-120"/>
-                        </a:rPr>
-                        <a:t>m³/yr</a:t>
                       </a:r>
                       <a:endParaRPr lang="en-US" sz="1000" dirty="0">
                         <a:latin typeface="Arial" charset="0"/>
@@ -4722,74 +4653,6 @@
                     </a:solidFill>
                   </a:tcPr>
                 </a:tc>
-                <a:tc>
-                  <a:txBody>
-                    <a:bodyPr/>
-                    <a:lstStyle/>
-                    <a:p>
-                      <a:pPr algn="r" indent="0" marL="0">
-                        <a:buNone/>
-                      </a:pPr>
-                      <a:r>
-                        <a:rPr lang="en-US" sz="1000" dirty="0">
-                          <a:solidFill>
-                            <a:srgbClr val="E8F1FF"/>
-                          </a:solidFill>
-                          <a:latin typeface="Courier New" pitchFamily="34" charset="0"/>
-                          <a:ea typeface="Courier New" pitchFamily="34" charset="-122"/>
-                          <a:cs typeface="Courier New" pitchFamily="34" charset="-120"/>
-                        </a:rPr>
-                        <a:t>214,286</a:t>
-                      </a:r>
-                      <a:endParaRPr lang="en-US" sz="1000" dirty="0">
-                        <a:latin typeface="Courier New" charset="0"/>
-                        <a:ea typeface="Courier New" charset="0"/>
-                        <a:cs typeface="Courier New" charset="0"/>
-                      </a:endParaRPr>
-                    </a:p>
-                  </a:txBody>
-                  <a:tcPr marL="73152" marR="73152" marT="18288" marB="18288" anchor="ctr">
-                    <a:lnL w="9525" cap="flat" cmpd="sng" algn="ctr">
-                      <a:solidFill>
-                        <a:srgbClr val="2A5790"/>
-                      </a:solidFill>
-                      <a:prstDash val="solid"/>
-                      <a:round/>
-                      <a:headEnd type="none" w="med" len="med"/>
-                      <a:tailEnd type="none" w="med" len="med"/>
-                    </a:lnL>
-                    <a:lnR w="9525" cap="flat" cmpd="sng" algn="ctr">
-                      <a:solidFill>
-                        <a:srgbClr val="2A5790"/>
-                      </a:solidFill>
-                      <a:prstDash val="solid"/>
-                      <a:round/>
-                      <a:headEnd type="none" w="med" len="med"/>
-                      <a:tailEnd type="none" w="med" len="med"/>
-                    </a:lnR>
-                    <a:lnT w="9525" cap="flat" cmpd="sng" algn="ctr">
-                      <a:solidFill>
-                        <a:srgbClr val="2A5790"/>
-                      </a:solidFill>
-                      <a:prstDash val="solid"/>
-                      <a:round/>
-                      <a:headEnd type="none" w="med" len="med"/>
-                      <a:tailEnd type="none" w="med" len="med"/>
-                    </a:lnT>
-                    <a:lnB w="9525" cap="flat" cmpd="sng" algn="ctr">
-                      <a:solidFill>
-                        <a:srgbClr val="2A5790"/>
-                      </a:solidFill>
-                      <a:prstDash val="solid"/>
-                      <a:round/>
-                      <a:headEnd type="none" w="med" len="med"/>
-                      <a:tailEnd type="none" w="med" len="med"/>
-                    </a:lnB>
-                    <a:solidFill>
-                      <a:srgbClr val="0D3B73"/>
-                    </a:solidFill>
-                  </a:tcPr>
-                </a:tc>
               </a:tr>
               <a:tr h="329184">
                 <a:tc>
@@ -4877,7 +4740,7 @@
                           <a:ea typeface="Arial" pitchFamily="34" charset="-122"/>
                           <a:cs typeface="Arial" pitchFamily="34" charset="-120"/>
                         </a:rPr>
-                        <a:t>MSW to SH-01 (no picking; stream 2 deleted)</a:t>
+                        <a:t>MSW to SH-01 primary (no picking)</a:t>
                       </a:r>
                       <a:endParaRPr lang="en-US" sz="1000" dirty="0">
                         <a:latin typeface="Arial" charset="0"/>
@@ -5014,6 +4877,760 @@
                           <a:cs typeface="Courier New" pitchFamily="34" charset="-120"/>
                         </a:rPr>
                         <a:t>63.0</a:t>
+                      </a:r>
+                      <a:endParaRPr lang="en-US" sz="1000" dirty="0">
+                        <a:latin typeface="Courier New" charset="0"/>
+                        <a:ea typeface="Courier New" charset="0"/>
+                        <a:cs typeface="Courier New" charset="0"/>
+                      </a:endParaRPr>
+                    </a:p>
+                  </a:txBody>
+                  <a:tcPr marL="73152" marR="73152" marT="18288" marB="18288" anchor="ctr">
+                    <a:lnL w="9525" cap="flat" cmpd="sng" algn="ctr">
+                      <a:solidFill>
+                        <a:srgbClr val="2A5790"/>
+                      </a:solidFill>
+                      <a:prstDash val="solid"/>
+                      <a:round/>
+                      <a:headEnd type="none" w="med" len="med"/>
+                      <a:tailEnd type="none" w="med" len="med"/>
+                    </a:lnL>
+                    <a:lnR w="9525" cap="flat" cmpd="sng" algn="ctr">
+                      <a:solidFill>
+                        <a:srgbClr val="2A5790"/>
+                      </a:solidFill>
+                      <a:prstDash val="solid"/>
+                      <a:round/>
+                      <a:headEnd type="none" w="med" len="med"/>
+                      <a:tailEnd type="none" w="med" len="med"/>
+                    </a:lnR>
+                    <a:lnT w="9525" cap="flat" cmpd="sng" algn="ctr">
+                      <a:solidFill>
+                        <a:srgbClr val="2A5790"/>
+                      </a:solidFill>
+                      <a:prstDash val="solid"/>
+                      <a:round/>
+                      <a:headEnd type="none" w="med" len="med"/>
+                      <a:tailEnd type="none" w="med" len="med"/>
+                    </a:lnT>
+                    <a:lnB w="9525" cap="flat" cmpd="sng" algn="ctr">
+                      <a:solidFill>
+                        <a:srgbClr val="2A5790"/>
+                      </a:solidFill>
+                      <a:prstDash val="solid"/>
+                      <a:round/>
+                      <a:headEnd type="none" w="med" len="med"/>
+                      <a:tailEnd type="none" w="med" len="med"/>
+                    </a:lnB>
+                    <a:solidFill>
+                      <a:srgbClr val="0D3B73"/>
+                    </a:solidFill>
+                  </a:tcPr>
+                </a:tc>
+              </a:tr>
+              <a:tr h="329184">
+                <a:tc>
+                  <a:txBody>
+                    <a:bodyPr/>
+                    <a:lstStyle/>
+                    <a:p>
+                      <a:pPr algn="ctr" indent="0" marL="0">
+                        <a:buNone/>
+                      </a:pPr>
+                      <a:r>
+                        <a:rPr lang="en-US" sz="1000" dirty="0">
+                          <a:solidFill>
+                            <a:srgbClr val="E8F1FF"/>
+                          </a:solidFill>
+                          <a:latin typeface="Courier New" pitchFamily="34" charset="0"/>
+                          <a:ea typeface="Courier New" pitchFamily="34" charset="-122"/>
+                          <a:cs typeface="Courier New" pitchFamily="34" charset="-120"/>
+                        </a:rPr>
+                        <a:t>3a</a:t>
+                      </a:r>
+                      <a:endParaRPr lang="en-US" sz="1000" dirty="0">
+                        <a:latin typeface="Courier New" charset="0"/>
+                        <a:ea typeface="Courier New" charset="0"/>
+                        <a:cs typeface="Courier New" charset="0"/>
+                      </a:endParaRPr>
+                    </a:p>
+                  </a:txBody>
+                  <a:tcPr marL="73152" marR="73152" marT="18288" marB="18288" anchor="ctr">
+                    <a:lnL w="9525" cap="flat" cmpd="sng" algn="ctr">
+                      <a:solidFill>
+                        <a:srgbClr val="2A5790"/>
+                      </a:solidFill>
+                      <a:prstDash val="solid"/>
+                      <a:round/>
+                      <a:headEnd type="none" w="med" len="med"/>
+                      <a:tailEnd type="none" w="med" len="med"/>
+                    </a:lnL>
+                    <a:lnR w="9525" cap="flat" cmpd="sng" algn="ctr">
+                      <a:solidFill>
+                        <a:srgbClr val="2A5790"/>
+                      </a:solidFill>
+                      <a:prstDash val="solid"/>
+                      <a:round/>
+                      <a:headEnd type="none" w="med" len="med"/>
+                      <a:tailEnd type="none" w="med" len="med"/>
+                    </a:lnR>
+                    <a:lnT w="9525" cap="flat" cmpd="sng" algn="ctr">
+                      <a:solidFill>
+                        <a:srgbClr val="2A5790"/>
+                      </a:solidFill>
+                      <a:prstDash val="solid"/>
+                      <a:round/>
+                      <a:headEnd type="none" w="med" len="med"/>
+                      <a:tailEnd type="none" w="med" len="med"/>
+                    </a:lnT>
+                    <a:lnB w="9525" cap="flat" cmpd="sng" algn="ctr">
+                      <a:solidFill>
+                        <a:srgbClr val="2A5790"/>
+                      </a:solidFill>
+                      <a:prstDash val="solid"/>
+                      <a:round/>
+                      <a:headEnd type="none" w="med" len="med"/>
+                      <a:tailEnd type="none" w="med" len="med"/>
+                    </a:lnB>
+                    <a:solidFill>
+                      <a:srgbClr val="0D3B73"/>
+                    </a:solidFill>
+                  </a:tcPr>
+                </a:tc>
+                <a:tc>
+                  <a:txBody>
+                    <a:bodyPr/>
+                    <a:lstStyle/>
+                    <a:p>
+                      <a:pPr algn="l" indent="0" marL="0">
+                        <a:buNone/>
+                      </a:pPr>
+                      <a:r>
+                        <a:rPr lang="en-US" sz="1000" dirty="0">
+                          <a:solidFill>
+                            <a:srgbClr val="E8F1FF"/>
+                          </a:solidFill>
+                          <a:latin typeface="Arial" pitchFamily="34" charset="0"/>
+                          <a:ea typeface="Arial" pitchFamily="34" charset="-122"/>
+                          <a:cs typeface="Arial" pitchFamily="34" charset="-120"/>
+                        </a:rPr>
+                        <a:t>SH-01 → M1 → TR-01 trommel 80 mm</a:t>
+                      </a:r>
+                      <a:endParaRPr lang="en-US" sz="1000" dirty="0">
+                        <a:latin typeface="Arial" charset="0"/>
+                        <a:ea typeface="Arial" charset="0"/>
+                        <a:cs typeface="Arial" charset="0"/>
+                      </a:endParaRPr>
+                    </a:p>
+                  </a:txBody>
+                  <a:tcPr marL="73152" marR="73152" marT="18288" marB="18288" anchor="ctr">
+                    <a:lnL w="9525" cap="flat" cmpd="sng" algn="ctr">
+                      <a:solidFill>
+                        <a:srgbClr val="2A5790"/>
+                      </a:solidFill>
+                      <a:prstDash val="solid"/>
+                      <a:round/>
+                      <a:headEnd type="none" w="med" len="med"/>
+                      <a:tailEnd type="none" w="med" len="med"/>
+                    </a:lnL>
+                    <a:lnR w="9525" cap="flat" cmpd="sng" algn="ctr">
+                      <a:solidFill>
+                        <a:srgbClr val="2A5790"/>
+                      </a:solidFill>
+                      <a:prstDash val="solid"/>
+                      <a:round/>
+                      <a:headEnd type="none" w="med" len="med"/>
+                      <a:tailEnd type="none" w="med" len="med"/>
+                    </a:lnR>
+                    <a:lnT w="9525" cap="flat" cmpd="sng" algn="ctr">
+                      <a:solidFill>
+                        <a:srgbClr val="2A5790"/>
+                      </a:solidFill>
+                      <a:prstDash val="solid"/>
+                      <a:round/>
+                      <a:headEnd type="none" w="med" len="med"/>
+                      <a:tailEnd type="none" w="med" len="med"/>
+                    </a:lnT>
+                    <a:lnB w="9525" cap="flat" cmpd="sng" algn="ctr">
+                      <a:solidFill>
+                        <a:srgbClr val="2A5790"/>
+                      </a:solidFill>
+                      <a:prstDash val="solid"/>
+                      <a:round/>
+                      <a:headEnd type="none" w="med" len="med"/>
+                      <a:tailEnd type="none" w="med" len="med"/>
+                    </a:lnB>
+                    <a:solidFill>
+                      <a:srgbClr val="0D3B73"/>
+                    </a:solidFill>
+                  </a:tcPr>
+                </a:tc>
+                <a:tc>
+                  <a:txBody>
+                    <a:bodyPr/>
+                    <a:lstStyle/>
+                    <a:p>
+                      <a:pPr algn="r" indent="0" marL="0">
+                        <a:buNone/>
+                      </a:pPr>
+                      <a:r>
+                        <a:rPr lang="en-US" sz="1000" dirty="0">
+                          <a:solidFill>
+                            <a:srgbClr val="E8F1FF"/>
+                          </a:solidFill>
+                          <a:latin typeface="Courier New" pitchFamily="34" charset="0"/>
+                          <a:ea typeface="Courier New" pitchFamily="34" charset="-122"/>
+                          <a:cs typeface="Courier New" pitchFamily="34" charset="-120"/>
+                        </a:rPr>
+                        <a:t>74,419</a:t>
+                      </a:r>
+                      <a:endParaRPr lang="en-US" sz="1000" dirty="0">
+                        <a:latin typeface="Courier New" charset="0"/>
+                        <a:ea typeface="Courier New" charset="0"/>
+                        <a:cs typeface="Courier New" charset="0"/>
+                      </a:endParaRPr>
+                    </a:p>
+                  </a:txBody>
+                  <a:tcPr marL="73152" marR="73152" marT="18288" marB="18288" anchor="ctr">
+                    <a:lnL w="9525" cap="flat" cmpd="sng" algn="ctr">
+                      <a:solidFill>
+                        <a:srgbClr val="2A5790"/>
+                      </a:solidFill>
+                      <a:prstDash val="solid"/>
+                      <a:round/>
+                      <a:headEnd type="none" w="med" len="med"/>
+                      <a:tailEnd type="none" w="med" len="med"/>
+                    </a:lnL>
+                    <a:lnR w="9525" cap="flat" cmpd="sng" algn="ctr">
+                      <a:solidFill>
+                        <a:srgbClr val="2A5790"/>
+                      </a:solidFill>
+                      <a:prstDash val="solid"/>
+                      <a:round/>
+                      <a:headEnd type="none" w="med" len="med"/>
+                      <a:tailEnd type="none" w="med" len="med"/>
+                    </a:lnR>
+                    <a:lnT w="9525" cap="flat" cmpd="sng" algn="ctr">
+                      <a:solidFill>
+                        <a:srgbClr val="2A5790"/>
+                      </a:solidFill>
+                      <a:prstDash val="solid"/>
+                      <a:round/>
+                      <a:headEnd type="none" w="med" len="med"/>
+                      <a:tailEnd type="none" w="med" len="med"/>
+                    </a:lnT>
+                    <a:lnB w="9525" cap="flat" cmpd="sng" algn="ctr">
+                      <a:solidFill>
+                        <a:srgbClr val="2A5790"/>
+                      </a:solidFill>
+                      <a:prstDash val="solid"/>
+                      <a:round/>
+                      <a:headEnd type="none" w="med" len="med"/>
+                      <a:tailEnd type="none" w="med" len="med"/>
+                    </a:lnB>
+                    <a:solidFill>
+                      <a:srgbClr val="0D3B73"/>
+                    </a:solidFill>
+                  </a:tcPr>
+                </a:tc>
+                <a:tc>
+                  <a:txBody>
+                    <a:bodyPr/>
+                    <a:lstStyle/>
+                    <a:p>
+                      <a:pPr algn="r" indent="0" marL="0">
+                        <a:buNone/>
+                      </a:pPr>
+                      <a:r>
+                        <a:rPr lang="en-US" sz="1000" dirty="0">
+                          <a:solidFill>
+                            <a:srgbClr val="E8F1FF"/>
+                          </a:solidFill>
+                          <a:latin typeface="Courier New" pitchFamily="34" charset="0"/>
+                          <a:ea typeface="Courier New" pitchFamily="34" charset="-122"/>
+                          <a:cs typeface="Courier New" pitchFamily="34" charset="-120"/>
+                        </a:rPr>
+                        <a:t>–</a:t>
+                      </a:r>
+                      <a:endParaRPr lang="en-US" sz="1000" dirty="0">
+                        <a:latin typeface="Courier New" charset="0"/>
+                        <a:ea typeface="Courier New" charset="0"/>
+                        <a:cs typeface="Courier New" charset="0"/>
+                      </a:endParaRPr>
+                    </a:p>
+                  </a:txBody>
+                  <a:tcPr marL="73152" marR="73152" marT="18288" marB="18288" anchor="ctr">
+                    <a:lnL w="9525" cap="flat" cmpd="sng" algn="ctr">
+                      <a:solidFill>
+                        <a:srgbClr val="2A5790"/>
+                      </a:solidFill>
+                      <a:prstDash val="solid"/>
+                      <a:round/>
+                      <a:headEnd type="none" w="med" len="med"/>
+                      <a:tailEnd type="none" w="med" len="med"/>
+                    </a:lnL>
+                    <a:lnR w="9525" cap="flat" cmpd="sng" algn="ctr">
+                      <a:solidFill>
+                        <a:srgbClr val="2A5790"/>
+                      </a:solidFill>
+                      <a:prstDash val="solid"/>
+                      <a:round/>
+                      <a:headEnd type="none" w="med" len="med"/>
+                      <a:tailEnd type="none" w="med" len="med"/>
+                    </a:lnR>
+                    <a:lnT w="9525" cap="flat" cmpd="sng" algn="ctr">
+                      <a:solidFill>
+                        <a:srgbClr val="2A5790"/>
+                      </a:solidFill>
+                      <a:prstDash val="solid"/>
+                      <a:round/>
+                      <a:headEnd type="none" w="med" len="med"/>
+                      <a:tailEnd type="none" w="med" len="med"/>
+                    </a:lnT>
+                    <a:lnB w="9525" cap="flat" cmpd="sng" algn="ctr">
+                      <a:solidFill>
+                        <a:srgbClr val="2A5790"/>
+                      </a:solidFill>
+                      <a:prstDash val="solid"/>
+                      <a:round/>
+                      <a:headEnd type="none" w="med" len="med"/>
+                      <a:tailEnd type="none" w="med" len="med"/>
+                    </a:lnB>
+                    <a:solidFill>
+                      <a:srgbClr val="0D3B73"/>
+                    </a:solidFill>
+                  </a:tcPr>
+                </a:tc>
+              </a:tr>
+              <a:tr h="329184">
+                <a:tc>
+                  <a:txBody>
+                    <a:bodyPr/>
+                    <a:lstStyle/>
+                    <a:p>
+                      <a:pPr algn="ctr" indent="0" marL="0">
+                        <a:buNone/>
+                      </a:pPr>
+                      <a:r>
+                        <a:rPr lang="en-US" sz="1000" dirty="0">
+                          <a:solidFill>
+                            <a:srgbClr val="E8F1FF"/>
+                          </a:solidFill>
+                          <a:latin typeface="Courier New" pitchFamily="34" charset="0"/>
+                          <a:ea typeface="Courier New" pitchFamily="34" charset="-122"/>
+                          <a:cs typeface="Courier New" pitchFamily="34" charset="-120"/>
+                        </a:rPr>
+                        <a:t>4a</a:t>
+                      </a:r>
+                      <a:endParaRPr lang="en-US" sz="1000" dirty="0">
+                        <a:latin typeface="Courier New" charset="0"/>
+                        <a:ea typeface="Courier New" charset="0"/>
+                        <a:cs typeface="Courier New" charset="0"/>
+                      </a:endParaRPr>
+                    </a:p>
+                  </a:txBody>
+                  <a:tcPr marL="73152" marR="73152" marT="18288" marB="18288" anchor="ctr">
+                    <a:lnL w="9525" cap="flat" cmpd="sng" algn="ctr">
+                      <a:solidFill>
+                        <a:srgbClr val="2A5790"/>
+                      </a:solidFill>
+                      <a:prstDash val="solid"/>
+                      <a:round/>
+                      <a:headEnd type="none" w="med" len="med"/>
+                      <a:tailEnd type="none" w="med" len="med"/>
+                    </a:lnL>
+                    <a:lnR w="9525" cap="flat" cmpd="sng" algn="ctr">
+                      <a:solidFill>
+                        <a:srgbClr val="2A5790"/>
+                      </a:solidFill>
+                      <a:prstDash val="solid"/>
+                      <a:round/>
+                      <a:headEnd type="none" w="med" len="med"/>
+                      <a:tailEnd type="none" w="med" len="med"/>
+                    </a:lnR>
+                    <a:lnT w="9525" cap="flat" cmpd="sng" algn="ctr">
+                      <a:solidFill>
+                        <a:srgbClr val="2A5790"/>
+                      </a:solidFill>
+                      <a:prstDash val="solid"/>
+                      <a:round/>
+                      <a:headEnd type="none" w="med" len="med"/>
+                      <a:tailEnd type="none" w="med" len="med"/>
+                    </a:lnT>
+                    <a:lnB w="9525" cap="flat" cmpd="sng" algn="ctr">
+                      <a:solidFill>
+                        <a:srgbClr val="2A5790"/>
+                      </a:solidFill>
+                      <a:prstDash val="solid"/>
+                      <a:round/>
+                      <a:headEnd type="none" w="med" len="med"/>
+                      <a:tailEnd type="none" w="med" len="med"/>
+                    </a:lnB>
+                    <a:solidFill>
+                      <a:srgbClr val="0D3B73"/>
+                    </a:solidFill>
+                  </a:tcPr>
+                </a:tc>
+                <a:tc>
+                  <a:txBody>
+                    <a:bodyPr/>
+                    <a:lstStyle/>
+                    <a:p>
+                      <a:pPr algn="l" indent="0" marL="0">
+                        <a:buNone/>
+                      </a:pPr>
+                      <a:r>
+                        <a:rPr lang="en-US" sz="1000" dirty="0">
+                          <a:solidFill>
+                            <a:srgbClr val="E8F1FF"/>
+                          </a:solidFill>
+                          <a:latin typeface="Arial" pitchFamily="34" charset="0"/>
+                          <a:ea typeface="Arial" pitchFamily="34" charset="-122"/>
+                          <a:cs typeface="Arial" pitchFamily="34" charset="-120"/>
+                        </a:rPr>
+                        <a:t>Unders &lt;80 mm (65%) → M2 → bays</a:t>
+                      </a:r>
+                      <a:endParaRPr lang="en-US" sz="1000" dirty="0">
+                        <a:latin typeface="Arial" charset="0"/>
+                        <a:ea typeface="Arial" charset="0"/>
+                        <a:cs typeface="Arial" charset="0"/>
+                      </a:endParaRPr>
+                    </a:p>
+                  </a:txBody>
+                  <a:tcPr marL="73152" marR="73152" marT="18288" marB="18288" anchor="ctr">
+                    <a:lnL w="9525" cap="flat" cmpd="sng" algn="ctr">
+                      <a:solidFill>
+                        <a:srgbClr val="2A5790"/>
+                      </a:solidFill>
+                      <a:prstDash val="solid"/>
+                      <a:round/>
+                      <a:headEnd type="none" w="med" len="med"/>
+                      <a:tailEnd type="none" w="med" len="med"/>
+                    </a:lnL>
+                    <a:lnR w="9525" cap="flat" cmpd="sng" algn="ctr">
+                      <a:solidFill>
+                        <a:srgbClr val="2A5790"/>
+                      </a:solidFill>
+                      <a:prstDash val="solid"/>
+                      <a:round/>
+                      <a:headEnd type="none" w="med" len="med"/>
+                      <a:tailEnd type="none" w="med" len="med"/>
+                    </a:lnR>
+                    <a:lnT w="9525" cap="flat" cmpd="sng" algn="ctr">
+                      <a:solidFill>
+                        <a:srgbClr val="2A5790"/>
+                      </a:solidFill>
+                      <a:prstDash val="solid"/>
+                      <a:round/>
+                      <a:headEnd type="none" w="med" len="med"/>
+                      <a:tailEnd type="none" w="med" len="med"/>
+                    </a:lnT>
+                    <a:lnB w="9525" cap="flat" cmpd="sng" algn="ctr">
+                      <a:solidFill>
+                        <a:srgbClr val="2A5790"/>
+                      </a:solidFill>
+                      <a:prstDash val="solid"/>
+                      <a:round/>
+                      <a:headEnd type="none" w="med" len="med"/>
+                      <a:tailEnd type="none" w="med" len="med"/>
+                    </a:lnB>
+                    <a:solidFill>
+                      <a:srgbClr val="0D3B73"/>
+                    </a:solidFill>
+                  </a:tcPr>
+                </a:tc>
+                <a:tc>
+                  <a:txBody>
+                    <a:bodyPr/>
+                    <a:lstStyle/>
+                    <a:p>
+                      <a:pPr algn="r" indent="0" marL="0">
+                        <a:buNone/>
+                      </a:pPr>
+                      <a:r>
+                        <a:rPr lang="en-US" sz="1000" dirty="0">
+                          <a:solidFill>
+                            <a:srgbClr val="E8F1FF"/>
+                          </a:solidFill>
+                          <a:latin typeface="Courier New" pitchFamily="34" charset="0"/>
+                          <a:ea typeface="Courier New" pitchFamily="34" charset="-122"/>
+                          <a:cs typeface="Courier New" pitchFamily="34" charset="-120"/>
+                        </a:rPr>
+                        <a:t>48,295</a:t>
+                      </a:r>
+                      <a:endParaRPr lang="en-US" sz="1000" dirty="0">
+                        <a:latin typeface="Courier New" charset="0"/>
+                        <a:ea typeface="Courier New" charset="0"/>
+                        <a:cs typeface="Courier New" charset="0"/>
+                      </a:endParaRPr>
+                    </a:p>
+                  </a:txBody>
+                  <a:tcPr marL="73152" marR="73152" marT="18288" marB="18288" anchor="ctr">
+                    <a:lnL w="9525" cap="flat" cmpd="sng" algn="ctr">
+                      <a:solidFill>
+                        <a:srgbClr val="2A5790"/>
+                      </a:solidFill>
+                      <a:prstDash val="solid"/>
+                      <a:round/>
+                      <a:headEnd type="none" w="med" len="med"/>
+                      <a:tailEnd type="none" w="med" len="med"/>
+                    </a:lnL>
+                    <a:lnR w="9525" cap="flat" cmpd="sng" algn="ctr">
+                      <a:solidFill>
+                        <a:srgbClr val="2A5790"/>
+                      </a:solidFill>
+                      <a:prstDash val="solid"/>
+                      <a:round/>
+                      <a:headEnd type="none" w="med" len="med"/>
+                      <a:tailEnd type="none" w="med" len="med"/>
+                    </a:lnR>
+                    <a:lnT w="9525" cap="flat" cmpd="sng" algn="ctr">
+                      <a:solidFill>
+                        <a:srgbClr val="2A5790"/>
+                      </a:solidFill>
+                      <a:prstDash val="solid"/>
+                      <a:round/>
+                      <a:headEnd type="none" w="med" len="med"/>
+                      <a:tailEnd type="none" w="med" len="med"/>
+                    </a:lnT>
+                    <a:lnB w="9525" cap="flat" cmpd="sng" algn="ctr">
+                      <a:solidFill>
+                        <a:srgbClr val="2A5790"/>
+                      </a:solidFill>
+                      <a:prstDash val="solid"/>
+                      <a:round/>
+                      <a:headEnd type="none" w="med" len="med"/>
+                      <a:tailEnd type="none" w="med" len="med"/>
+                    </a:lnB>
+                    <a:solidFill>
+                      <a:srgbClr val="0D3B73"/>
+                    </a:solidFill>
+                  </a:tcPr>
+                </a:tc>
+                <a:tc>
+                  <a:txBody>
+                    <a:bodyPr/>
+                    <a:lstStyle/>
+                    <a:p>
+                      <a:pPr algn="r" indent="0" marL="0">
+                        <a:buNone/>
+                      </a:pPr>
+                      <a:r>
+                        <a:rPr lang="en-US" sz="1000" dirty="0">
+                          <a:solidFill>
+                            <a:srgbClr val="E8F1FF"/>
+                          </a:solidFill>
+                          <a:latin typeface="Courier New" pitchFamily="34" charset="0"/>
+                          <a:ea typeface="Courier New" pitchFamily="34" charset="-122"/>
+                          <a:cs typeface="Courier New" pitchFamily="34" charset="-120"/>
+                        </a:rPr>
+                        <a:t>–</a:t>
+                      </a:r>
+                      <a:endParaRPr lang="en-US" sz="1000" dirty="0">
+                        <a:latin typeface="Courier New" charset="0"/>
+                        <a:ea typeface="Courier New" charset="0"/>
+                        <a:cs typeface="Courier New" charset="0"/>
+                      </a:endParaRPr>
+                    </a:p>
+                  </a:txBody>
+                  <a:tcPr marL="73152" marR="73152" marT="18288" marB="18288" anchor="ctr">
+                    <a:lnL w="9525" cap="flat" cmpd="sng" algn="ctr">
+                      <a:solidFill>
+                        <a:srgbClr val="2A5790"/>
+                      </a:solidFill>
+                      <a:prstDash val="solid"/>
+                      <a:round/>
+                      <a:headEnd type="none" w="med" len="med"/>
+                      <a:tailEnd type="none" w="med" len="med"/>
+                    </a:lnL>
+                    <a:lnR w="9525" cap="flat" cmpd="sng" algn="ctr">
+                      <a:solidFill>
+                        <a:srgbClr val="2A5790"/>
+                      </a:solidFill>
+                      <a:prstDash val="solid"/>
+                      <a:round/>
+                      <a:headEnd type="none" w="med" len="med"/>
+                      <a:tailEnd type="none" w="med" len="med"/>
+                    </a:lnR>
+                    <a:lnT w="9525" cap="flat" cmpd="sng" algn="ctr">
+                      <a:solidFill>
+                        <a:srgbClr val="2A5790"/>
+                      </a:solidFill>
+                      <a:prstDash val="solid"/>
+                      <a:round/>
+                      <a:headEnd type="none" w="med" len="med"/>
+                      <a:tailEnd type="none" w="med" len="med"/>
+                    </a:lnT>
+                    <a:lnB w="9525" cap="flat" cmpd="sng" algn="ctr">
+                      <a:solidFill>
+                        <a:srgbClr val="2A5790"/>
+                      </a:solidFill>
+                      <a:prstDash val="solid"/>
+                      <a:round/>
+                      <a:headEnd type="none" w="med" len="med"/>
+                      <a:tailEnd type="none" w="med" len="med"/>
+                    </a:lnB>
+                    <a:solidFill>
+                      <a:srgbClr val="0D3B73"/>
+                    </a:solidFill>
+                  </a:tcPr>
+                </a:tc>
+              </a:tr>
+              <a:tr h="329184">
+                <a:tc>
+                  <a:txBody>
+                    <a:bodyPr/>
+                    <a:lstStyle/>
+                    <a:p>
+                      <a:pPr algn="ctr" indent="0" marL="0">
+                        <a:buNone/>
+                      </a:pPr>
+                      <a:r>
+                        <a:rPr lang="en-US" sz="1000" dirty="0">
+                          <a:solidFill>
+                            <a:srgbClr val="E8F1FF"/>
+                          </a:solidFill>
+                          <a:latin typeface="Courier New" pitchFamily="34" charset="0"/>
+                          <a:ea typeface="Courier New" pitchFamily="34" charset="-122"/>
+                          <a:cs typeface="Courier New" pitchFamily="34" charset="-120"/>
+                        </a:rPr>
+                        <a:t>4b</a:t>
+                      </a:r>
+                      <a:endParaRPr lang="en-US" sz="1000" dirty="0">
+                        <a:latin typeface="Courier New" charset="0"/>
+                        <a:ea typeface="Courier New" charset="0"/>
+                        <a:cs typeface="Courier New" charset="0"/>
+                      </a:endParaRPr>
+                    </a:p>
+                  </a:txBody>
+                  <a:tcPr marL="73152" marR="73152" marT="18288" marB="18288" anchor="ctr">
+                    <a:lnL w="9525" cap="flat" cmpd="sng" algn="ctr">
+                      <a:solidFill>
+                        <a:srgbClr val="2A5790"/>
+                      </a:solidFill>
+                      <a:prstDash val="solid"/>
+                      <a:round/>
+                      <a:headEnd type="none" w="med" len="med"/>
+                      <a:tailEnd type="none" w="med" len="med"/>
+                    </a:lnL>
+                    <a:lnR w="9525" cap="flat" cmpd="sng" algn="ctr">
+                      <a:solidFill>
+                        <a:srgbClr val="2A5790"/>
+                      </a:solidFill>
+                      <a:prstDash val="solid"/>
+                      <a:round/>
+                      <a:headEnd type="none" w="med" len="med"/>
+                      <a:tailEnd type="none" w="med" len="med"/>
+                    </a:lnR>
+                    <a:lnT w="9525" cap="flat" cmpd="sng" algn="ctr">
+                      <a:solidFill>
+                        <a:srgbClr val="2A5790"/>
+                      </a:solidFill>
+                      <a:prstDash val="solid"/>
+                      <a:round/>
+                      <a:headEnd type="none" w="med" len="med"/>
+                      <a:tailEnd type="none" w="med" len="med"/>
+                    </a:lnT>
+                    <a:lnB w="9525" cap="flat" cmpd="sng" algn="ctr">
+                      <a:solidFill>
+                        <a:srgbClr val="2A5790"/>
+                      </a:solidFill>
+                      <a:prstDash val="solid"/>
+                      <a:round/>
+                      <a:headEnd type="none" w="med" len="med"/>
+                      <a:tailEnd type="none" w="med" len="med"/>
+                    </a:lnB>
+                    <a:solidFill>
+                      <a:srgbClr val="0D3B73"/>
+                    </a:solidFill>
+                  </a:tcPr>
+                </a:tc>
+                <a:tc>
+                  <a:txBody>
+                    <a:bodyPr/>
+                    <a:lstStyle/>
+                    <a:p>
+                      <a:pPr algn="l" indent="0" marL="0">
+                        <a:buNone/>
+                      </a:pPr>
+                      <a:r>
+                        <a:rPr lang="en-US" sz="1000" dirty="0">
+                          <a:solidFill>
+                            <a:srgbClr val="E8F1FF"/>
+                          </a:solidFill>
+                          <a:latin typeface="Arial" pitchFamily="34" charset="0"/>
+                          <a:ea typeface="Arial" pitchFamily="34" charset="-122"/>
+                          <a:cs typeface="Arial" pitchFamily="34" charset="-120"/>
+                        </a:rPr>
+                        <a:t>Overs &gt;80 mm (35%) → M3 → SH-03 → M4 → bays</a:t>
+                      </a:r>
+                      <a:endParaRPr lang="en-US" sz="1000" dirty="0">
+                        <a:latin typeface="Arial" charset="0"/>
+                        <a:ea typeface="Arial" charset="0"/>
+                        <a:cs typeface="Arial" charset="0"/>
+                      </a:endParaRPr>
+                    </a:p>
+                  </a:txBody>
+                  <a:tcPr marL="73152" marR="73152" marT="18288" marB="18288" anchor="ctr">
+                    <a:lnL w="9525" cap="flat" cmpd="sng" algn="ctr">
+                      <a:solidFill>
+                        <a:srgbClr val="2A5790"/>
+                      </a:solidFill>
+                      <a:prstDash val="solid"/>
+                      <a:round/>
+                      <a:headEnd type="none" w="med" len="med"/>
+                      <a:tailEnd type="none" w="med" len="med"/>
+                    </a:lnL>
+                    <a:lnR w="9525" cap="flat" cmpd="sng" algn="ctr">
+                      <a:solidFill>
+                        <a:srgbClr val="2A5790"/>
+                      </a:solidFill>
+                      <a:prstDash val="solid"/>
+                      <a:round/>
+                      <a:headEnd type="none" w="med" len="med"/>
+                      <a:tailEnd type="none" w="med" len="med"/>
+                    </a:lnR>
+                    <a:lnT w="9525" cap="flat" cmpd="sng" algn="ctr">
+                      <a:solidFill>
+                        <a:srgbClr val="2A5790"/>
+                      </a:solidFill>
+                      <a:prstDash val="solid"/>
+                      <a:round/>
+                      <a:headEnd type="none" w="med" len="med"/>
+                      <a:tailEnd type="none" w="med" len="med"/>
+                    </a:lnT>
+                    <a:lnB w="9525" cap="flat" cmpd="sng" algn="ctr">
+                      <a:solidFill>
+                        <a:srgbClr val="2A5790"/>
+                      </a:solidFill>
+                      <a:prstDash val="solid"/>
+                      <a:round/>
+                      <a:headEnd type="none" w="med" len="med"/>
+                      <a:tailEnd type="none" w="med" len="med"/>
+                    </a:lnB>
+                    <a:solidFill>
+                      <a:srgbClr val="0D3B73"/>
+                    </a:solidFill>
+                  </a:tcPr>
+                </a:tc>
+                <a:tc>
+                  <a:txBody>
+                    <a:bodyPr/>
+                    <a:lstStyle/>
+                    <a:p>
+                      <a:pPr algn="r" indent="0" marL="0">
+                        <a:buNone/>
+                      </a:pPr>
+                      <a:r>
+                        <a:rPr lang="en-US" sz="1000" dirty="0">
+                          <a:solidFill>
+                            <a:srgbClr val="E8F1FF"/>
+                          </a:solidFill>
+                          <a:latin typeface="Courier New" pitchFamily="34" charset="0"/>
+                          <a:ea typeface="Courier New" pitchFamily="34" charset="-122"/>
+                          <a:cs typeface="Courier New" pitchFamily="34" charset="-120"/>
+                        </a:rPr>
+                        <a:t>25,836</a:t>
                       </a:r>
                       <a:endParaRPr lang="en-US" sz="1000" dirty="0">
                         <a:latin typeface="Courier New" charset="0"/>
@@ -5219,7 +5836,7 @@
                           <a:ea typeface="Arial" pitchFamily="34" charset="-122"/>
                           <a:cs typeface="Arial" pitchFamily="34" charset="-120"/>
                         </a:rPr>
-                        <a:t>Shredded MSW to detection bays</a:t>
+                        <a:t>To detection bays (WTT basis kept)</a:t>
                       </a:r>
                       <a:endParaRPr lang="en-US" sz="1000" dirty="0">
                         <a:latin typeface="Arial" charset="0"/>
@@ -5356,416 +5973,6 @@
                           <a:cs typeface="Courier New" pitchFamily="34" charset="-120"/>
                         </a:rPr>
                         <a:t>63.0</a:t>
-                      </a:r>
-                      <a:endParaRPr lang="en-US" sz="1000" dirty="0">
-                        <a:latin typeface="Courier New" charset="0"/>
-                        <a:ea typeface="Courier New" charset="0"/>
-                        <a:cs typeface="Courier New" charset="0"/>
-                      </a:endParaRPr>
-                    </a:p>
-                  </a:txBody>
-                  <a:tcPr marL="73152" marR="73152" marT="18288" marB="18288" anchor="ctr">
-                    <a:lnL w="9525" cap="flat" cmpd="sng" algn="ctr">
-                      <a:solidFill>
-                        <a:srgbClr val="2A5790"/>
-                      </a:solidFill>
-                      <a:prstDash val="solid"/>
-                      <a:round/>
-                      <a:headEnd type="none" w="med" len="med"/>
-                      <a:tailEnd type="none" w="med" len="med"/>
-                    </a:lnL>
-                    <a:lnR w="9525" cap="flat" cmpd="sng" algn="ctr">
-                      <a:solidFill>
-                        <a:srgbClr val="2A5790"/>
-                      </a:solidFill>
-                      <a:prstDash val="solid"/>
-                      <a:round/>
-                      <a:headEnd type="none" w="med" len="med"/>
-                      <a:tailEnd type="none" w="med" len="med"/>
-                    </a:lnR>
-                    <a:lnT w="9525" cap="flat" cmpd="sng" algn="ctr">
-                      <a:solidFill>
-                        <a:srgbClr val="2A5790"/>
-                      </a:solidFill>
-                      <a:prstDash val="solid"/>
-                      <a:round/>
-                      <a:headEnd type="none" w="med" len="med"/>
-                      <a:tailEnd type="none" w="med" len="med"/>
-                    </a:lnT>
-                    <a:lnB w="9525" cap="flat" cmpd="sng" algn="ctr">
-                      <a:solidFill>
-                        <a:srgbClr val="2A5790"/>
-                      </a:solidFill>
-                      <a:prstDash val="solid"/>
-                      <a:round/>
-                      <a:headEnd type="none" w="med" len="med"/>
-                      <a:tailEnd type="none" w="med" len="med"/>
-                    </a:lnB>
-                    <a:solidFill>
-                      <a:srgbClr val="0D3B73"/>
-                    </a:solidFill>
-                  </a:tcPr>
-                </a:tc>
-                <a:tc>
-                  <a:txBody>
-                    <a:bodyPr/>
-                    <a:lstStyle/>
-                    <a:p>
-                      <a:pPr algn="r" indent="0" marL="0">
-                        <a:buNone/>
-                      </a:pPr>
-                      <a:r>
-                        <a:rPr lang="en-US" sz="1000" dirty="0">
-                          <a:solidFill>
-                            <a:srgbClr val="E8F1FF"/>
-                          </a:solidFill>
-                          <a:latin typeface="Courier New" pitchFamily="34" charset="0"/>
-                          <a:ea typeface="Courier New" pitchFamily="34" charset="-122"/>
-                          <a:cs typeface="Courier New" pitchFamily="34" charset="-120"/>
-                        </a:rPr>
-                        <a:t>214,286</a:t>
-                      </a:r>
-                      <a:endParaRPr lang="en-US" sz="1000" dirty="0">
-                        <a:latin typeface="Courier New" charset="0"/>
-                        <a:ea typeface="Courier New" charset="0"/>
-                        <a:cs typeface="Courier New" charset="0"/>
-                      </a:endParaRPr>
-                    </a:p>
-                  </a:txBody>
-                  <a:tcPr marL="73152" marR="73152" marT="18288" marB="18288" anchor="ctr">
-                    <a:lnL w="9525" cap="flat" cmpd="sng" algn="ctr">
-                      <a:solidFill>
-                        <a:srgbClr val="2A5790"/>
-                      </a:solidFill>
-                      <a:prstDash val="solid"/>
-                      <a:round/>
-                      <a:headEnd type="none" w="med" len="med"/>
-                      <a:tailEnd type="none" w="med" len="med"/>
-                    </a:lnL>
-                    <a:lnR w="9525" cap="flat" cmpd="sng" algn="ctr">
-                      <a:solidFill>
-                        <a:srgbClr val="2A5790"/>
-                      </a:solidFill>
-                      <a:prstDash val="solid"/>
-                      <a:round/>
-                      <a:headEnd type="none" w="med" len="med"/>
-                      <a:tailEnd type="none" w="med" len="med"/>
-                    </a:lnR>
-                    <a:lnT w="9525" cap="flat" cmpd="sng" algn="ctr">
-                      <a:solidFill>
-                        <a:srgbClr val="2A5790"/>
-                      </a:solidFill>
-                      <a:prstDash val="solid"/>
-                      <a:round/>
-                      <a:headEnd type="none" w="med" len="med"/>
-                      <a:tailEnd type="none" w="med" len="med"/>
-                    </a:lnT>
-                    <a:lnB w="9525" cap="flat" cmpd="sng" algn="ctr">
-                      <a:solidFill>
-                        <a:srgbClr val="2A5790"/>
-                      </a:solidFill>
-                      <a:prstDash val="solid"/>
-                      <a:round/>
-                      <a:headEnd type="none" w="med" len="med"/>
-                      <a:tailEnd type="none" w="med" len="med"/>
-                    </a:lnB>
-                    <a:solidFill>
-                      <a:srgbClr val="0D3B73"/>
-                    </a:solidFill>
-                  </a:tcPr>
-                </a:tc>
-              </a:tr>
-              <a:tr h="329184">
-                <a:tc>
-                  <a:txBody>
-                    <a:bodyPr/>
-                    <a:lstStyle/>
-                    <a:p>
-                      <a:pPr algn="ctr" indent="0" marL="0">
-                        <a:buNone/>
-                      </a:pPr>
-                      <a:r>
-                        <a:rPr lang="en-US" sz="1000" dirty="0">
-                          <a:solidFill>
-                            <a:srgbClr val="E8F1FF"/>
-                          </a:solidFill>
-                          <a:latin typeface="Courier New" pitchFamily="34" charset="0"/>
-                          <a:ea typeface="Courier New" pitchFamily="34" charset="-122"/>
-                          <a:cs typeface="Courier New" pitchFamily="34" charset="-120"/>
-                        </a:rPr>
-                        <a:t>5</a:t>
-                      </a:r>
-                      <a:endParaRPr lang="en-US" sz="1000" dirty="0">
-                        <a:latin typeface="Courier New" charset="0"/>
-                        <a:ea typeface="Courier New" charset="0"/>
-                        <a:cs typeface="Courier New" charset="0"/>
-                      </a:endParaRPr>
-                    </a:p>
-                  </a:txBody>
-                  <a:tcPr marL="73152" marR="73152" marT="18288" marB="18288" anchor="ctr">
-                    <a:lnL w="9525" cap="flat" cmpd="sng" algn="ctr">
-                      <a:solidFill>
-                        <a:srgbClr val="2A5790"/>
-                      </a:solidFill>
-                      <a:prstDash val="solid"/>
-                      <a:round/>
-                      <a:headEnd type="none" w="med" len="med"/>
-                      <a:tailEnd type="none" w="med" len="med"/>
-                    </a:lnL>
-                    <a:lnR w="9525" cap="flat" cmpd="sng" algn="ctr">
-                      <a:solidFill>
-                        <a:srgbClr val="2A5790"/>
-                      </a:solidFill>
-                      <a:prstDash val="solid"/>
-                      <a:round/>
-                      <a:headEnd type="none" w="med" len="med"/>
-                      <a:tailEnd type="none" w="med" len="med"/>
-                    </a:lnR>
-                    <a:lnT w="9525" cap="flat" cmpd="sng" algn="ctr">
-                      <a:solidFill>
-                        <a:srgbClr val="2A5790"/>
-                      </a:solidFill>
-                      <a:prstDash val="solid"/>
-                      <a:round/>
-                      <a:headEnd type="none" w="med" len="med"/>
-                      <a:tailEnd type="none" w="med" len="med"/>
-                    </a:lnT>
-                    <a:lnB w="9525" cap="flat" cmpd="sng" algn="ctr">
-                      <a:solidFill>
-                        <a:srgbClr val="2A5790"/>
-                      </a:solidFill>
-                      <a:prstDash val="solid"/>
-                      <a:round/>
-                      <a:headEnd type="none" w="med" len="med"/>
-                      <a:tailEnd type="none" w="med" len="med"/>
-                    </a:lnB>
-                    <a:solidFill>
-                      <a:srgbClr val="0D3B73"/>
-                    </a:solidFill>
-                  </a:tcPr>
-                </a:tc>
-                <a:tc>
-                  <a:txBody>
-                    <a:bodyPr/>
-                    <a:lstStyle/>
-                    <a:p>
-                      <a:pPr algn="l" indent="0" marL="0">
-                        <a:buNone/>
-                      </a:pPr>
-                      <a:r>
-                        <a:rPr lang="en-US" sz="1000" dirty="0">
-                          <a:solidFill>
-                            <a:srgbClr val="E8F1FF"/>
-                          </a:solidFill>
-                          <a:latin typeface="Arial" pitchFamily="34" charset="0"/>
-                          <a:ea typeface="Arial" pitchFamily="34" charset="-122"/>
-                          <a:cs typeface="Arial" pitchFamily="34" charset="-120"/>
-                        </a:rPr>
-                        <a:t>Bays → stage 1 (3 × 481 t/wk)</a:t>
-                      </a:r>
-                      <a:endParaRPr lang="en-US" sz="1000" dirty="0">
-                        <a:latin typeface="Arial" charset="0"/>
-                        <a:ea typeface="Arial" charset="0"/>
-                        <a:cs typeface="Arial" charset="0"/>
-                      </a:endParaRPr>
-                    </a:p>
-                  </a:txBody>
-                  <a:tcPr marL="73152" marR="73152" marT="18288" marB="18288" anchor="ctr">
-                    <a:lnL w="9525" cap="flat" cmpd="sng" algn="ctr">
-                      <a:solidFill>
-                        <a:srgbClr val="2A5790"/>
-                      </a:solidFill>
-                      <a:prstDash val="solid"/>
-                      <a:round/>
-                      <a:headEnd type="none" w="med" len="med"/>
-                      <a:tailEnd type="none" w="med" len="med"/>
-                    </a:lnL>
-                    <a:lnR w="9525" cap="flat" cmpd="sng" algn="ctr">
-                      <a:solidFill>
-                        <a:srgbClr val="2A5790"/>
-                      </a:solidFill>
-                      <a:prstDash val="solid"/>
-                      <a:round/>
-                      <a:headEnd type="none" w="med" len="med"/>
-                      <a:tailEnd type="none" w="med" len="med"/>
-                    </a:lnR>
-                    <a:lnT w="9525" cap="flat" cmpd="sng" algn="ctr">
-                      <a:solidFill>
-                        <a:srgbClr val="2A5790"/>
-                      </a:solidFill>
-                      <a:prstDash val="solid"/>
-                      <a:round/>
-                      <a:headEnd type="none" w="med" len="med"/>
-                      <a:tailEnd type="none" w="med" len="med"/>
-                    </a:lnT>
-                    <a:lnB w="9525" cap="flat" cmpd="sng" algn="ctr">
-                      <a:solidFill>
-                        <a:srgbClr val="2A5790"/>
-                      </a:solidFill>
-                      <a:prstDash val="solid"/>
-                      <a:round/>
-                      <a:headEnd type="none" w="med" len="med"/>
-                      <a:tailEnd type="none" w="med" len="med"/>
-                    </a:lnB>
-                    <a:solidFill>
-                      <a:srgbClr val="0D3B73"/>
-                    </a:solidFill>
-                  </a:tcPr>
-                </a:tc>
-                <a:tc>
-                  <a:txBody>
-                    <a:bodyPr/>
-                    <a:lstStyle/>
-                    <a:p>
-                      <a:pPr algn="r" indent="0" marL="0">
-                        <a:buNone/>
-                      </a:pPr>
-                      <a:r>
-                        <a:rPr lang="en-US" sz="1000" dirty="0">
-                          <a:solidFill>
-                            <a:srgbClr val="E8F1FF"/>
-                          </a:solidFill>
-                          <a:latin typeface="Courier New" pitchFamily="34" charset="0"/>
-                          <a:ea typeface="Courier New" pitchFamily="34" charset="-122"/>
-                          <a:cs typeface="Courier New" pitchFamily="34" charset="-120"/>
-                        </a:rPr>
-                        <a:t>75,000</a:t>
-                      </a:r>
-                      <a:endParaRPr lang="en-US" sz="1000" dirty="0">
-                        <a:latin typeface="Courier New" charset="0"/>
-                        <a:ea typeface="Courier New" charset="0"/>
-                        <a:cs typeface="Courier New" charset="0"/>
-                      </a:endParaRPr>
-                    </a:p>
-                  </a:txBody>
-                  <a:tcPr marL="73152" marR="73152" marT="18288" marB="18288" anchor="ctr">
-                    <a:lnL w="9525" cap="flat" cmpd="sng" algn="ctr">
-                      <a:solidFill>
-                        <a:srgbClr val="2A5790"/>
-                      </a:solidFill>
-                      <a:prstDash val="solid"/>
-                      <a:round/>
-                      <a:headEnd type="none" w="med" len="med"/>
-                      <a:tailEnd type="none" w="med" len="med"/>
-                    </a:lnL>
-                    <a:lnR w="9525" cap="flat" cmpd="sng" algn="ctr">
-                      <a:solidFill>
-                        <a:srgbClr val="2A5790"/>
-                      </a:solidFill>
-                      <a:prstDash val="solid"/>
-                      <a:round/>
-                      <a:headEnd type="none" w="med" len="med"/>
-                      <a:tailEnd type="none" w="med" len="med"/>
-                    </a:lnR>
-                    <a:lnT w="9525" cap="flat" cmpd="sng" algn="ctr">
-                      <a:solidFill>
-                        <a:srgbClr val="2A5790"/>
-                      </a:solidFill>
-                      <a:prstDash val="solid"/>
-                      <a:round/>
-                      <a:headEnd type="none" w="med" len="med"/>
-                      <a:tailEnd type="none" w="med" len="med"/>
-                    </a:lnT>
-                    <a:lnB w="9525" cap="flat" cmpd="sng" algn="ctr">
-                      <a:solidFill>
-                        <a:srgbClr val="2A5790"/>
-                      </a:solidFill>
-                      <a:prstDash val="solid"/>
-                      <a:round/>
-                      <a:headEnd type="none" w="med" len="med"/>
-                      <a:tailEnd type="none" w="med" len="med"/>
-                    </a:lnB>
-                    <a:solidFill>
-                      <a:srgbClr val="0D3B73"/>
-                    </a:solidFill>
-                  </a:tcPr>
-                </a:tc>
-                <a:tc>
-                  <a:txBody>
-                    <a:bodyPr/>
-                    <a:lstStyle/>
-                    <a:p>
-                      <a:pPr algn="r" indent="0" marL="0">
-                        <a:buNone/>
-                      </a:pPr>
-                      <a:r>
-                        <a:rPr lang="en-US" sz="1000" dirty="0">
-                          <a:solidFill>
-                            <a:srgbClr val="E8F1FF"/>
-                          </a:solidFill>
-                          <a:latin typeface="Courier New" pitchFamily="34" charset="0"/>
-                          <a:ea typeface="Courier New" pitchFamily="34" charset="-122"/>
-                          <a:cs typeface="Courier New" pitchFamily="34" charset="-120"/>
-                        </a:rPr>
-                        <a:t>63.0</a:t>
-                      </a:r>
-                      <a:endParaRPr lang="en-US" sz="1000" dirty="0">
-                        <a:latin typeface="Courier New" charset="0"/>
-                        <a:ea typeface="Courier New" charset="0"/>
-                        <a:cs typeface="Courier New" charset="0"/>
-                      </a:endParaRPr>
-                    </a:p>
-                  </a:txBody>
-                  <a:tcPr marL="73152" marR="73152" marT="18288" marB="18288" anchor="ctr">
-                    <a:lnL w="9525" cap="flat" cmpd="sng" algn="ctr">
-                      <a:solidFill>
-                        <a:srgbClr val="2A5790"/>
-                      </a:solidFill>
-                      <a:prstDash val="solid"/>
-                      <a:round/>
-                      <a:headEnd type="none" w="med" len="med"/>
-                      <a:tailEnd type="none" w="med" len="med"/>
-                    </a:lnL>
-                    <a:lnR w="9525" cap="flat" cmpd="sng" algn="ctr">
-                      <a:solidFill>
-                        <a:srgbClr val="2A5790"/>
-                      </a:solidFill>
-                      <a:prstDash val="solid"/>
-                      <a:round/>
-                      <a:headEnd type="none" w="med" len="med"/>
-                      <a:tailEnd type="none" w="med" len="med"/>
-                    </a:lnR>
-                    <a:lnT w="9525" cap="flat" cmpd="sng" algn="ctr">
-                      <a:solidFill>
-                        <a:srgbClr val="2A5790"/>
-                      </a:solidFill>
-                      <a:prstDash val="solid"/>
-                      <a:round/>
-                      <a:headEnd type="none" w="med" len="med"/>
-                      <a:tailEnd type="none" w="med" len="med"/>
-                    </a:lnT>
-                    <a:lnB w="9525" cap="flat" cmpd="sng" algn="ctr">
-                      <a:solidFill>
-                        <a:srgbClr val="2A5790"/>
-                      </a:solidFill>
-                      <a:prstDash val="solid"/>
-                      <a:round/>
-                      <a:headEnd type="none" w="med" len="med"/>
-                      <a:tailEnd type="none" w="med" len="med"/>
-                    </a:lnB>
-                    <a:solidFill>
-                      <a:srgbClr val="0D3B73"/>
-                    </a:solidFill>
-                  </a:tcPr>
-                </a:tc>
-                <a:tc>
-                  <a:txBody>
-                    <a:bodyPr/>
-                    <a:lstStyle/>
-                    <a:p>
-                      <a:pPr algn="r" indent="0" marL="0">
-                        <a:buNone/>
-                      </a:pPr>
-                      <a:r>
-                        <a:rPr lang="en-US" sz="1000" dirty="0">
-                          <a:solidFill>
-                            <a:srgbClr val="E8F1FF"/>
-                          </a:solidFill>
-                          <a:latin typeface="Courier New" pitchFamily="34" charset="0"/>
-                          <a:ea typeface="Courier New" pitchFamily="34" charset="-122"/>
-                          <a:cs typeface="Courier New" pitchFamily="34" charset="-120"/>
-                        </a:rPr>
-                        <a:t>214,286</a:t>
                       </a:r>
                       <a:endParaRPr lang="en-US" sz="1000" dirty="0">
                         <a:latin typeface="Courier New" charset="0"/>
@@ -5903,7 +6110,7 @@
                           <a:ea typeface="Arial" pitchFamily="34" charset="-122"/>
                           <a:cs typeface="Arial" pitchFamily="34" charset="-120"/>
                         </a:rPr>
-                        <a:t>Stage 1 off-gas (water + degradation)</a:t>
+                        <a:t>Off-gas, first 7 days (water + degradation)</a:t>
                       </a:r>
                       <a:endParaRPr lang="en-US" sz="1000" dirty="0">
                         <a:latin typeface="Arial" charset="0"/>
@@ -5972,74 +6179,6 @@
                           <a:cs typeface="Courier New" pitchFamily="34" charset="-120"/>
                         </a:rPr>
                         <a:t>15,090</a:t>
-                      </a:r>
-                      <a:endParaRPr lang="en-US" sz="1000" dirty="0">
-                        <a:latin typeface="Courier New" charset="0"/>
-                        <a:ea typeface="Courier New" charset="0"/>
-                        <a:cs typeface="Courier New" charset="0"/>
-                      </a:endParaRPr>
-                    </a:p>
-                  </a:txBody>
-                  <a:tcPr marL="73152" marR="73152" marT="18288" marB="18288" anchor="ctr">
-                    <a:lnL w="9525" cap="flat" cmpd="sng" algn="ctr">
-                      <a:solidFill>
-                        <a:srgbClr val="2A5790"/>
-                      </a:solidFill>
-                      <a:prstDash val="solid"/>
-                      <a:round/>
-                      <a:headEnd type="none" w="med" len="med"/>
-                      <a:tailEnd type="none" w="med" len="med"/>
-                    </a:lnL>
-                    <a:lnR w="9525" cap="flat" cmpd="sng" algn="ctr">
-                      <a:solidFill>
-                        <a:srgbClr val="2A5790"/>
-                      </a:solidFill>
-                      <a:prstDash val="solid"/>
-                      <a:round/>
-                      <a:headEnd type="none" w="med" len="med"/>
-                      <a:tailEnd type="none" w="med" len="med"/>
-                    </a:lnR>
-                    <a:lnT w="9525" cap="flat" cmpd="sng" algn="ctr">
-                      <a:solidFill>
-                        <a:srgbClr val="2A5790"/>
-                      </a:solidFill>
-                      <a:prstDash val="solid"/>
-                      <a:round/>
-                      <a:headEnd type="none" w="med" len="med"/>
-                      <a:tailEnd type="none" w="med" len="med"/>
-                    </a:lnT>
-                    <a:lnB w="9525" cap="flat" cmpd="sng" algn="ctr">
-                      <a:solidFill>
-                        <a:srgbClr val="2A5790"/>
-                      </a:solidFill>
-                      <a:prstDash val="solid"/>
-                      <a:round/>
-                      <a:headEnd type="none" w="med" len="med"/>
-                      <a:tailEnd type="none" w="med" len="med"/>
-                    </a:lnB>
-                    <a:solidFill>
-                      <a:srgbClr val="0D3B73"/>
-                    </a:solidFill>
-                  </a:tcPr>
-                </a:tc>
-                <a:tc>
-                  <a:txBody>
-                    <a:bodyPr/>
-                    <a:lstStyle/>
-                    <a:p>
-                      <a:pPr algn="r" indent="0" marL="0">
-                        <a:buNone/>
-                      </a:pPr>
-                      <a:r>
-                        <a:rPr lang="en-US" sz="1000" dirty="0">
-                          <a:solidFill>
-                            <a:srgbClr val="E8F1FF"/>
-                          </a:solidFill>
-                          <a:latin typeface="Courier New" pitchFamily="34" charset="0"/>
-                          <a:ea typeface="Courier New" pitchFamily="34" charset="-122"/>
-                          <a:cs typeface="Courier New" pitchFamily="34" charset="-120"/>
-                        </a:rPr>
-                        <a:t>–</a:t>
                       </a:r>
                       <a:endParaRPr lang="en-US" sz="1000" dirty="0">
                         <a:latin typeface="Courier New" charset="0"/>
@@ -6245,7 +6384,7 @@
                           <a:ea typeface="Arial" pitchFamily="34" charset="-122"/>
                           <a:cs typeface="Arial" pitchFamily="34" charset="-120"/>
                         </a:rPr>
-                        <a:t>Turn stage 1 → stage 2 (3 × 384 t/wk)</a:t>
+                        <a:t>Turn → second 7 days</a:t>
                       </a:r>
                       <a:endParaRPr lang="en-US" sz="1000" dirty="0">
                         <a:latin typeface="Arial" charset="0"/>
@@ -6382,74 +6521,6 @@
                           <a:cs typeface="Courier New" pitchFamily="34" charset="-120"/>
                         </a:rPr>
                         <a:t>75.4</a:t>
-                      </a:r>
-                      <a:endParaRPr lang="en-US" sz="1000" dirty="0">
-                        <a:latin typeface="Courier New" charset="0"/>
-                        <a:ea typeface="Courier New" charset="0"/>
-                        <a:cs typeface="Courier New" charset="0"/>
-                      </a:endParaRPr>
-                    </a:p>
-                  </a:txBody>
-                  <a:tcPr marL="73152" marR="73152" marT="18288" marB="18288" anchor="ctr">
-                    <a:lnL w="9525" cap="flat" cmpd="sng" algn="ctr">
-                      <a:solidFill>
-                        <a:srgbClr val="2A5790"/>
-                      </a:solidFill>
-                      <a:prstDash val="solid"/>
-                      <a:round/>
-                      <a:headEnd type="none" w="med" len="med"/>
-                      <a:tailEnd type="none" w="med" len="med"/>
-                    </a:lnL>
-                    <a:lnR w="9525" cap="flat" cmpd="sng" algn="ctr">
-                      <a:solidFill>
-                        <a:srgbClr val="2A5790"/>
-                      </a:solidFill>
-                      <a:prstDash val="solid"/>
-                      <a:round/>
-                      <a:headEnd type="none" w="med" len="med"/>
-                      <a:tailEnd type="none" w="med" len="med"/>
-                    </a:lnR>
-                    <a:lnT w="9525" cap="flat" cmpd="sng" algn="ctr">
-                      <a:solidFill>
-                        <a:srgbClr val="2A5790"/>
-                      </a:solidFill>
-                      <a:prstDash val="solid"/>
-                      <a:round/>
-                      <a:headEnd type="none" w="med" len="med"/>
-                      <a:tailEnd type="none" w="med" len="med"/>
-                    </a:lnT>
-                    <a:lnB w="9525" cap="flat" cmpd="sng" algn="ctr">
-                      <a:solidFill>
-                        <a:srgbClr val="2A5790"/>
-                      </a:solidFill>
-                      <a:prstDash val="solid"/>
-                      <a:round/>
-                      <a:headEnd type="none" w="med" len="med"/>
-                      <a:tailEnd type="none" w="med" len="med"/>
-                    </a:lnB>
-                    <a:solidFill>
-                      <a:srgbClr val="0D3B73"/>
-                    </a:solidFill>
-                  </a:tcPr>
-                </a:tc>
-                <a:tc>
-                  <a:txBody>
-                    <a:bodyPr/>
-                    <a:lstStyle/>
-                    <a:p>
-                      <a:pPr algn="r" indent="0" marL="0">
-                        <a:buNone/>
-                      </a:pPr>
-                      <a:r>
-                        <a:rPr lang="en-US" sz="1000" dirty="0">
-                          <a:solidFill>
-                            <a:srgbClr val="E8F1FF"/>
-                          </a:solidFill>
-                          <a:latin typeface="Courier New" pitchFamily="34" charset="0"/>
-                          <a:ea typeface="Courier New" pitchFamily="34" charset="-122"/>
-                          <a:cs typeface="Courier New" pitchFamily="34" charset="-120"/>
-                        </a:rPr>
-                        <a:t>171,171</a:t>
                       </a:r>
                       <a:endParaRPr lang="en-US" sz="1000" dirty="0">
                         <a:latin typeface="Courier New" charset="0"/>
@@ -6587,7 +6658,7 @@
                           <a:ea typeface="Arial" pitchFamily="34" charset="-122"/>
                           <a:cs typeface="Arial" pitchFamily="34" charset="-120"/>
                         </a:rPr>
-                        <a:t>Stage 2 off-gas (incl. 1,847 t heat evap.)</a:t>
+                        <a:t>Off-gas, second 7 days (incl. heat evap.)</a:t>
                       </a:r>
                       <a:endParaRPr lang="en-US" sz="1000" dirty="0">
                         <a:latin typeface="Arial" charset="0"/>
@@ -6656,416 +6727,6 @@
                           <a:cs typeface="Courier New" pitchFamily="34" charset="-120"/>
                         </a:rPr>
                         <a:t>7,425</a:t>
-                      </a:r>
-                      <a:endParaRPr lang="en-US" sz="1000" dirty="0">
-                        <a:latin typeface="Courier New" charset="0"/>
-                        <a:ea typeface="Courier New" charset="0"/>
-                        <a:cs typeface="Courier New" charset="0"/>
-                      </a:endParaRPr>
-                    </a:p>
-                  </a:txBody>
-                  <a:tcPr marL="73152" marR="73152" marT="18288" marB="18288" anchor="ctr">
-                    <a:lnL w="9525" cap="flat" cmpd="sng" algn="ctr">
-                      <a:solidFill>
-                        <a:srgbClr val="2A5790"/>
-                      </a:solidFill>
-                      <a:prstDash val="solid"/>
-                      <a:round/>
-                      <a:headEnd type="none" w="med" len="med"/>
-                      <a:tailEnd type="none" w="med" len="med"/>
-                    </a:lnL>
-                    <a:lnR w="9525" cap="flat" cmpd="sng" algn="ctr">
-                      <a:solidFill>
-                        <a:srgbClr val="2A5790"/>
-                      </a:solidFill>
-                      <a:prstDash val="solid"/>
-                      <a:round/>
-                      <a:headEnd type="none" w="med" len="med"/>
-                      <a:tailEnd type="none" w="med" len="med"/>
-                    </a:lnR>
-                    <a:lnT w="9525" cap="flat" cmpd="sng" algn="ctr">
-                      <a:solidFill>
-                        <a:srgbClr val="2A5790"/>
-                      </a:solidFill>
-                      <a:prstDash val="solid"/>
-                      <a:round/>
-                      <a:headEnd type="none" w="med" len="med"/>
-                      <a:tailEnd type="none" w="med" len="med"/>
-                    </a:lnT>
-                    <a:lnB w="9525" cap="flat" cmpd="sng" algn="ctr">
-                      <a:solidFill>
-                        <a:srgbClr val="2A5790"/>
-                      </a:solidFill>
-                      <a:prstDash val="solid"/>
-                      <a:round/>
-                      <a:headEnd type="none" w="med" len="med"/>
-                      <a:tailEnd type="none" w="med" len="med"/>
-                    </a:lnB>
-                    <a:solidFill>
-                      <a:srgbClr val="0D3B73"/>
-                    </a:solidFill>
-                  </a:tcPr>
-                </a:tc>
-                <a:tc>
-                  <a:txBody>
-                    <a:bodyPr/>
-                    <a:lstStyle/>
-                    <a:p>
-                      <a:pPr algn="r" indent="0" marL="0">
-                        <a:buNone/>
-                      </a:pPr>
-                      <a:r>
-                        <a:rPr lang="en-US" sz="1000" dirty="0">
-                          <a:solidFill>
-                            <a:srgbClr val="E8F1FF"/>
-                          </a:solidFill>
-                          <a:latin typeface="Courier New" pitchFamily="34" charset="0"/>
-                          <a:ea typeface="Courier New" pitchFamily="34" charset="-122"/>
-                          <a:cs typeface="Courier New" pitchFamily="34" charset="-120"/>
-                        </a:rPr>
-                        <a:t>–</a:t>
-                      </a:r>
-                      <a:endParaRPr lang="en-US" sz="1000" dirty="0">
-                        <a:latin typeface="Courier New" charset="0"/>
-                        <a:ea typeface="Courier New" charset="0"/>
-                        <a:cs typeface="Courier New" charset="0"/>
-                      </a:endParaRPr>
-                    </a:p>
-                  </a:txBody>
-                  <a:tcPr marL="73152" marR="73152" marT="18288" marB="18288" anchor="ctr">
-                    <a:lnL w="9525" cap="flat" cmpd="sng" algn="ctr">
-                      <a:solidFill>
-                        <a:srgbClr val="2A5790"/>
-                      </a:solidFill>
-                      <a:prstDash val="solid"/>
-                      <a:round/>
-                      <a:headEnd type="none" w="med" len="med"/>
-                      <a:tailEnd type="none" w="med" len="med"/>
-                    </a:lnL>
-                    <a:lnR w="9525" cap="flat" cmpd="sng" algn="ctr">
-                      <a:solidFill>
-                        <a:srgbClr val="2A5790"/>
-                      </a:solidFill>
-                      <a:prstDash val="solid"/>
-                      <a:round/>
-                      <a:headEnd type="none" w="med" len="med"/>
-                      <a:tailEnd type="none" w="med" len="med"/>
-                    </a:lnR>
-                    <a:lnT w="9525" cap="flat" cmpd="sng" algn="ctr">
-                      <a:solidFill>
-                        <a:srgbClr val="2A5790"/>
-                      </a:solidFill>
-                      <a:prstDash val="solid"/>
-                      <a:round/>
-                      <a:headEnd type="none" w="med" len="med"/>
-                      <a:tailEnd type="none" w="med" len="med"/>
-                    </a:lnT>
-                    <a:lnB w="9525" cap="flat" cmpd="sng" algn="ctr">
-                      <a:solidFill>
-                        <a:srgbClr val="2A5790"/>
-                      </a:solidFill>
-                      <a:prstDash val="solid"/>
-                      <a:round/>
-                      <a:headEnd type="none" w="med" len="med"/>
-                      <a:tailEnd type="none" w="med" len="med"/>
-                    </a:lnB>
-                    <a:solidFill>
-                      <a:srgbClr val="0D3B73"/>
-                    </a:solidFill>
-                  </a:tcPr>
-                </a:tc>
-                <a:tc>
-                  <a:txBody>
-                    <a:bodyPr/>
-                    <a:lstStyle/>
-                    <a:p>
-                      <a:pPr algn="r" indent="0" marL="0">
-                        <a:buNone/>
-                      </a:pPr>
-                      <a:r>
-                        <a:rPr lang="en-US" sz="1000" dirty="0">
-                          <a:solidFill>
-                            <a:srgbClr val="E8F1FF"/>
-                          </a:solidFill>
-                          <a:latin typeface="Courier New" pitchFamily="34" charset="0"/>
-                          <a:ea typeface="Courier New" pitchFamily="34" charset="-122"/>
-                          <a:cs typeface="Courier New" pitchFamily="34" charset="-120"/>
-                        </a:rPr>
-                        <a:t>–</a:t>
-                      </a:r>
-                      <a:endParaRPr lang="en-US" sz="1000" dirty="0">
-                        <a:latin typeface="Courier New" charset="0"/>
-                        <a:ea typeface="Courier New" charset="0"/>
-                        <a:cs typeface="Courier New" charset="0"/>
-                      </a:endParaRPr>
-                    </a:p>
-                  </a:txBody>
-                  <a:tcPr marL="73152" marR="73152" marT="18288" marB="18288" anchor="ctr">
-                    <a:lnL w="9525" cap="flat" cmpd="sng" algn="ctr">
-                      <a:solidFill>
-                        <a:srgbClr val="2A5790"/>
-                      </a:solidFill>
-                      <a:prstDash val="solid"/>
-                      <a:round/>
-                      <a:headEnd type="none" w="med" len="med"/>
-                      <a:tailEnd type="none" w="med" len="med"/>
-                    </a:lnL>
-                    <a:lnR w="9525" cap="flat" cmpd="sng" algn="ctr">
-                      <a:solidFill>
-                        <a:srgbClr val="2A5790"/>
-                      </a:solidFill>
-                      <a:prstDash val="solid"/>
-                      <a:round/>
-                      <a:headEnd type="none" w="med" len="med"/>
-                      <a:tailEnd type="none" w="med" len="med"/>
-                    </a:lnR>
-                    <a:lnT w="9525" cap="flat" cmpd="sng" algn="ctr">
-                      <a:solidFill>
-                        <a:srgbClr val="2A5790"/>
-                      </a:solidFill>
-                      <a:prstDash val="solid"/>
-                      <a:round/>
-                      <a:headEnd type="none" w="med" len="med"/>
-                      <a:tailEnd type="none" w="med" len="med"/>
-                    </a:lnT>
-                    <a:lnB w="9525" cap="flat" cmpd="sng" algn="ctr">
-                      <a:solidFill>
-                        <a:srgbClr val="2A5790"/>
-                      </a:solidFill>
-                      <a:prstDash val="solid"/>
-                      <a:round/>
-                      <a:headEnd type="none" w="med" len="med"/>
-                      <a:tailEnd type="none" w="med" len="med"/>
-                    </a:lnB>
-                    <a:solidFill>
-                      <a:srgbClr val="0D3B73"/>
-                    </a:solidFill>
-                  </a:tcPr>
-                </a:tc>
-              </a:tr>
-              <a:tr h="329184">
-                <a:tc>
-                  <a:txBody>
-                    <a:bodyPr/>
-                    <a:lstStyle/>
-                    <a:p>
-                      <a:pPr algn="ctr" indent="0" marL="0">
-                        <a:buNone/>
-                      </a:pPr>
-                      <a:r>
-                        <a:rPr lang="en-US" sz="1000" dirty="0">
-                          <a:solidFill>
-                            <a:srgbClr val="E8F1FF"/>
-                          </a:solidFill>
-                          <a:latin typeface="Courier New" pitchFamily="34" charset="0"/>
-                          <a:ea typeface="Courier New" pitchFamily="34" charset="-122"/>
-                          <a:cs typeface="Courier New" pitchFamily="34" charset="-120"/>
-                        </a:rPr>
-                        <a:t>9</a:t>
-                      </a:r>
-                      <a:endParaRPr lang="en-US" sz="1000" dirty="0">
-                        <a:latin typeface="Courier New" charset="0"/>
-                        <a:ea typeface="Courier New" charset="0"/>
-                        <a:cs typeface="Courier New" charset="0"/>
-                      </a:endParaRPr>
-                    </a:p>
-                  </a:txBody>
-                  <a:tcPr marL="73152" marR="73152" marT="18288" marB="18288" anchor="ctr">
-                    <a:lnL w="9525" cap="flat" cmpd="sng" algn="ctr">
-                      <a:solidFill>
-                        <a:srgbClr val="2A5790"/>
-                      </a:solidFill>
-                      <a:prstDash val="solid"/>
-                      <a:round/>
-                      <a:headEnd type="none" w="med" len="med"/>
-                      <a:tailEnd type="none" w="med" len="med"/>
-                    </a:lnL>
-                    <a:lnR w="9525" cap="flat" cmpd="sng" algn="ctr">
-                      <a:solidFill>
-                        <a:srgbClr val="2A5790"/>
-                      </a:solidFill>
-                      <a:prstDash val="solid"/>
-                      <a:round/>
-                      <a:headEnd type="none" w="med" len="med"/>
-                      <a:tailEnd type="none" w="med" len="med"/>
-                    </a:lnR>
-                    <a:lnT w="9525" cap="flat" cmpd="sng" algn="ctr">
-                      <a:solidFill>
-                        <a:srgbClr val="2A5790"/>
-                      </a:solidFill>
-                      <a:prstDash val="solid"/>
-                      <a:round/>
-                      <a:headEnd type="none" w="med" len="med"/>
-                      <a:tailEnd type="none" w="med" len="med"/>
-                    </a:lnT>
-                    <a:lnB w="9525" cap="flat" cmpd="sng" algn="ctr">
-                      <a:solidFill>
-                        <a:srgbClr val="2A5790"/>
-                      </a:solidFill>
-                      <a:prstDash val="solid"/>
-                      <a:round/>
-                      <a:headEnd type="none" w="med" len="med"/>
-                      <a:tailEnd type="none" w="med" len="med"/>
-                    </a:lnB>
-                    <a:solidFill>
-                      <a:srgbClr val="0D3B73"/>
-                    </a:solidFill>
-                  </a:tcPr>
-                </a:tc>
-                <a:tc>
-                  <a:txBody>
-                    <a:bodyPr/>
-                    <a:lstStyle/>
-                    <a:p>
-                      <a:pPr algn="l" indent="0" marL="0">
-                        <a:buNone/>
-                      </a:pPr>
-                      <a:r>
-                        <a:rPr lang="en-US" sz="1000" dirty="0">
-                          <a:solidFill>
-                            <a:srgbClr val="E8F1FF"/>
-                          </a:solidFill>
-                          <a:latin typeface="Arial" pitchFamily="34" charset="0"/>
-                          <a:ea typeface="Arial" pitchFamily="34" charset="-122"/>
-                          <a:cs typeface="Arial" pitchFamily="34" charset="-120"/>
-                        </a:rPr>
-                        <a:t>Additional heat (kWh/yr)</a:t>
-                      </a:r>
-                      <a:endParaRPr lang="en-US" sz="1000" dirty="0">
-                        <a:latin typeface="Arial" charset="0"/>
-                        <a:ea typeface="Arial" charset="0"/>
-                        <a:cs typeface="Arial" charset="0"/>
-                      </a:endParaRPr>
-                    </a:p>
-                  </a:txBody>
-                  <a:tcPr marL="73152" marR="73152" marT="18288" marB="18288" anchor="ctr">
-                    <a:lnL w="9525" cap="flat" cmpd="sng" algn="ctr">
-                      <a:solidFill>
-                        <a:srgbClr val="2A5790"/>
-                      </a:solidFill>
-                      <a:prstDash val="solid"/>
-                      <a:round/>
-                      <a:headEnd type="none" w="med" len="med"/>
-                      <a:tailEnd type="none" w="med" len="med"/>
-                    </a:lnL>
-                    <a:lnR w="9525" cap="flat" cmpd="sng" algn="ctr">
-                      <a:solidFill>
-                        <a:srgbClr val="2A5790"/>
-                      </a:solidFill>
-                      <a:prstDash val="solid"/>
-                      <a:round/>
-                      <a:headEnd type="none" w="med" len="med"/>
-                      <a:tailEnd type="none" w="med" len="med"/>
-                    </a:lnR>
-                    <a:lnT w="9525" cap="flat" cmpd="sng" algn="ctr">
-                      <a:solidFill>
-                        <a:srgbClr val="2A5790"/>
-                      </a:solidFill>
-                      <a:prstDash val="solid"/>
-                      <a:round/>
-                      <a:headEnd type="none" w="med" len="med"/>
-                      <a:tailEnd type="none" w="med" len="med"/>
-                    </a:lnT>
-                    <a:lnB w="9525" cap="flat" cmpd="sng" algn="ctr">
-                      <a:solidFill>
-                        <a:srgbClr val="2A5790"/>
-                      </a:solidFill>
-                      <a:prstDash val="solid"/>
-                      <a:round/>
-                      <a:headEnd type="none" w="med" len="med"/>
-                      <a:tailEnd type="none" w="med" len="med"/>
-                    </a:lnB>
-                    <a:solidFill>
-                      <a:srgbClr val="0D3B73"/>
-                    </a:solidFill>
-                  </a:tcPr>
-                </a:tc>
-                <a:tc>
-                  <a:txBody>
-                    <a:bodyPr/>
-                    <a:lstStyle/>
-                    <a:p>
-                      <a:pPr algn="r" indent="0" marL="0">
-                        <a:buNone/>
-                      </a:pPr>
-                      <a:r>
-                        <a:rPr lang="en-US" sz="1000" dirty="0">
-                          <a:solidFill>
-                            <a:srgbClr val="E8F1FF"/>
-                          </a:solidFill>
-                          <a:latin typeface="Courier New" pitchFamily="34" charset="0"/>
-                          <a:ea typeface="Courier New" pitchFamily="34" charset="-122"/>
-                          <a:cs typeface="Courier New" pitchFamily="34" charset="-120"/>
-                        </a:rPr>
-                        <a:t>1,282,844</a:t>
-                      </a:r>
-                      <a:endParaRPr lang="en-US" sz="1000" dirty="0">
-                        <a:latin typeface="Courier New" charset="0"/>
-                        <a:ea typeface="Courier New" charset="0"/>
-                        <a:cs typeface="Courier New" charset="0"/>
-                      </a:endParaRPr>
-                    </a:p>
-                  </a:txBody>
-                  <a:tcPr marL="73152" marR="73152" marT="18288" marB="18288" anchor="ctr">
-                    <a:lnL w="9525" cap="flat" cmpd="sng" algn="ctr">
-                      <a:solidFill>
-                        <a:srgbClr val="2A5790"/>
-                      </a:solidFill>
-                      <a:prstDash val="solid"/>
-                      <a:round/>
-                      <a:headEnd type="none" w="med" len="med"/>
-                      <a:tailEnd type="none" w="med" len="med"/>
-                    </a:lnL>
-                    <a:lnR w="9525" cap="flat" cmpd="sng" algn="ctr">
-                      <a:solidFill>
-                        <a:srgbClr val="2A5790"/>
-                      </a:solidFill>
-                      <a:prstDash val="solid"/>
-                      <a:round/>
-                      <a:headEnd type="none" w="med" len="med"/>
-                      <a:tailEnd type="none" w="med" len="med"/>
-                    </a:lnR>
-                    <a:lnT w="9525" cap="flat" cmpd="sng" algn="ctr">
-                      <a:solidFill>
-                        <a:srgbClr val="2A5790"/>
-                      </a:solidFill>
-                      <a:prstDash val="solid"/>
-                      <a:round/>
-                      <a:headEnd type="none" w="med" len="med"/>
-                      <a:tailEnd type="none" w="med" len="med"/>
-                    </a:lnT>
-                    <a:lnB w="9525" cap="flat" cmpd="sng" algn="ctr">
-                      <a:solidFill>
-                        <a:srgbClr val="2A5790"/>
-                      </a:solidFill>
-                      <a:prstDash val="solid"/>
-                      <a:round/>
-                      <a:headEnd type="none" w="med" len="med"/>
-                      <a:tailEnd type="none" w="med" len="med"/>
-                    </a:lnB>
-                    <a:solidFill>
-                      <a:srgbClr val="0D3B73"/>
-                    </a:solidFill>
-                  </a:tcPr>
-                </a:tc>
-                <a:tc>
-                  <a:txBody>
-                    <a:bodyPr/>
-                    <a:lstStyle/>
-                    <a:p>
-                      <a:pPr algn="r" indent="0" marL="0">
-                        <a:buNone/>
-                      </a:pPr>
-                      <a:r>
-                        <a:rPr lang="en-US" sz="1000" dirty="0">
-                          <a:solidFill>
-                            <a:srgbClr val="E8F1FF"/>
-                          </a:solidFill>
-                          <a:latin typeface="Courier New" pitchFamily="34" charset="0"/>
-                          <a:ea typeface="Courier New" pitchFamily="34" charset="-122"/>
-                          <a:cs typeface="Courier New" pitchFamily="34" charset="-120"/>
-                        </a:rPr>
-                        <a:t>–</a:t>
                       </a:r>
                       <a:endParaRPr lang="en-US" sz="1000" dirty="0">
                         <a:latin typeface="Courier New" charset="0"/>
@@ -7271,7 +6932,7 @@
                           <a:ea typeface="Arial" pitchFamily="34" charset="-122"/>
                           <a:cs typeface="Arial" pitchFamily="34" charset="-120"/>
                         </a:rPr>
-                        <a:t>Stage 2 output → OS-01 storage bays</a:t>
+                        <a:t>Tunnel output → OS-01 storage bays</a:t>
                       </a:r>
                       <a:endParaRPr lang="en-US" sz="1000" dirty="0">
                         <a:latin typeface="Arial" charset="0"/>
@@ -7408,416 +7069,6 @@
                           <a:cs typeface="Courier New" pitchFamily="34" charset="-120"/>
                         </a:rPr>
                         <a:t>84.6</a:t>
-                      </a:r>
-                      <a:endParaRPr lang="en-US" sz="1000" dirty="0">
-                        <a:latin typeface="Courier New" charset="0"/>
-                        <a:ea typeface="Courier New" charset="0"/>
-                        <a:cs typeface="Courier New" charset="0"/>
-                      </a:endParaRPr>
-                    </a:p>
-                  </a:txBody>
-                  <a:tcPr marL="73152" marR="73152" marT="18288" marB="18288" anchor="ctr">
-                    <a:lnL w="9525" cap="flat" cmpd="sng" algn="ctr">
-                      <a:solidFill>
-                        <a:srgbClr val="2A5790"/>
-                      </a:solidFill>
-                      <a:prstDash val="solid"/>
-                      <a:round/>
-                      <a:headEnd type="none" w="med" len="med"/>
-                      <a:tailEnd type="none" w="med" len="med"/>
-                    </a:lnL>
-                    <a:lnR w="9525" cap="flat" cmpd="sng" algn="ctr">
-                      <a:solidFill>
-                        <a:srgbClr val="2A5790"/>
-                      </a:solidFill>
-                      <a:prstDash val="solid"/>
-                      <a:round/>
-                      <a:headEnd type="none" w="med" len="med"/>
-                      <a:tailEnd type="none" w="med" len="med"/>
-                    </a:lnR>
-                    <a:lnT w="9525" cap="flat" cmpd="sng" algn="ctr">
-                      <a:solidFill>
-                        <a:srgbClr val="2A5790"/>
-                      </a:solidFill>
-                      <a:prstDash val="solid"/>
-                      <a:round/>
-                      <a:headEnd type="none" w="med" len="med"/>
-                      <a:tailEnd type="none" w="med" len="med"/>
-                    </a:lnT>
-                    <a:lnB w="9525" cap="flat" cmpd="sng" algn="ctr">
-                      <a:solidFill>
-                        <a:srgbClr val="2A5790"/>
-                      </a:solidFill>
-                      <a:prstDash val="solid"/>
-                      <a:round/>
-                      <a:headEnd type="none" w="med" len="med"/>
-                      <a:tailEnd type="none" w="med" len="med"/>
-                    </a:lnB>
-                    <a:solidFill>
-                      <a:srgbClr val="0D3B73"/>
-                    </a:solidFill>
-                  </a:tcPr>
-                </a:tc>
-                <a:tc>
-                  <a:txBody>
-                    <a:bodyPr/>
-                    <a:lstStyle/>
-                    <a:p>
-                      <a:pPr algn="r" indent="0" marL="0">
-                        <a:buNone/>
-                      </a:pPr>
-                      <a:r>
-                        <a:rPr lang="en-US" sz="1000" dirty="0">
-                          <a:solidFill>
-                            <a:srgbClr val="E8F1FF"/>
-                          </a:solidFill>
-                          <a:latin typeface="Courier New" pitchFamily="34" charset="0"/>
-                          <a:ea typeface="Courier New" pitchFamily="34" charset="-122"/>
-                          <a:cs typeface="Courier New" pitchFamily="34" charset="-120"/>
-                        </a:rPr>
-                        <a:t>149,957</a:t>
-                      </a:r>
-                      <a:endParaRPr lang="en-US" sz="1000" dirty="0">
-                        <a:latin typeface="Courier New" charset="0"/>
-                        <a:ea typeface="Courier New" charset="0"/>
-                        <a:cs typeface="Courier New" charset="0"/>
-                      </a:endParaRPr>
-                    </a:p>
-                  </a:txBody>
-                  <a:tcPr marL="73152" marR="73152" marT="18288" marB="18288" anchor="ctr">
-                    <a:lnL w="9525" cap="flat" cmpd="sng" algn="ctr">
-                      <a:solidFill>
-                        <a:srgbClr val="2A5790"/>
-                      </a:solidFill>
-                      <a:prstDash val="solid"/>
-                      <a:round/>
-                      <a:headEnd type="none" w="med" len="med"/>
-                      <a:tailEnd type="none" w="med" len="med"/>
-                    </a:lnL>
-                    <a:lnR w="9525" cap="flat" cmpd="sng" algn="ctr">
-                      <a:solidFill>
-                        <a:srgbClr val="2A5790"/>
-                      </a:solidFill>
-                      <a:prstDash val="solid"/>
-                      <a:round/>
-                      <a:headEnd type="none" w="med" len="med"/>
-                      <a:tailEnd type="none" w="med" len="med"/>
-                    </a:lnR>
-                    <a:lnT w="9525" cap="flat" cmpd="sng" algn="ctr">
-                      <a:solidFill>
-                        <a:srgbClr val="2A5790"/>
-                      </a:solidFill>
-                      <a:prstDash val="solid"/>
-                      <a:round/>
-                      <a:headEnd type="none" w="med" len="med"/>
-                      <a:tailEnd type="none" w="med" len="med"/>
-                    </a:lnT>
-                    <a:lnB w="9525" cap="flat" cmpd="sng" algn="ctr">
-                      <a:solidFill>
-                        <a:srgbClr val="2A5790"/>
-                      </a:solidFill>
-                      <a:prstDash val="solid"/>
-                      <a:round/>
-                      <a:headEnd type="none" w="med" len="med"/>
-                      <a:tailEnd type="none" w="med" len="med"/>
-                    </a:lnB>
-                    <a:solidFill>
-                      <a:srgbClr val="0D3B73"/>
-                    </a:solidFill>
-                  </a:tcPr>
-                </a:tc>
-              </a:tr>
-              <a:tr h="329184">
-                <a:tc>
-                  <a:txBody>
-                    <a:bodyPr/>
-                    <a:lstStyle/>
-                    <a:p>
-                      <a:pPr algn="ctr" indent="0" marL="0">
-                        <a:buNone/>
-                      </a:pPr>
-                      <a:r>
-                        <a:rPr lang="en-US" sz="1000" dirty="0">
-                          <a:solidFill>
-                            <a:srgbClr val="E8F1FF"/>
-                          </a:solidFill>
-                          <a:latin typeface="Courier New" pitchFamily="34" charset="0"/>
-                          <a:ea typeface="Courier New" pitchFamily="34" charset="-122"/>
-                          <a:cs typeface="Courier New" pitchFamily="34" charset="-120"/>
-                        </a:rPr>
-                        <a:t>13</a:t>
-                      </a:r>
-                      <a:endParaRPr lang="en-US" sz="1000" dirty="0">
-                        <a:latin typeface="Courier New" charset="0"/>
-                        <a:ea typeface="Courier New" charset="0"/>
-                        <a:cs typeface="Courier New" charset="0"/>
-                      </a:endParaRPr>
-                    </a:p>
-                  </a:txBody>
-                  <a:tcPr marL="73152" marR="73152" marT="18288" marB="18288" anchor="ctr">
-                    <a:lnL w="9525" cap="flat" cmpd="sng" algn="ctr">
-                      <a:solidFill>
-                        <a:srgbClr val="2A5790"/>
-                      </a:solidFill>
-                      <a:prstDash val="solid"/>
-                      <a:round/>
-                      <a:headEnd type="none" w="med" len="med"/>
-                      <a:tailEnd type="none" w="med" len="med"/>
-                    </a:lnL>
-                    <a:lnR w="9525" cap="flat" cmpd="sng" algn="ctr">
-                      <a:solidFill>
-                        <a:srgbClr val="2A5790"/>
-                      </a:solidFill>
-                      <a:prstDash val="solid"/>
-                      <a:round/>
-                      <a:headEnd type="none" w="med" len="med"/>
-                      <a:tailEnd type="none" w="med" len="med"/>
-                    </a:lnR>
-                    <a:lnT w="9525" cap="flat" cmpd="sng" algn="ctr">
-                      <a:solidFill>
-                        <a:srgbClr val="2A5790"/>
-                      </a:solidFill>
-                      <a:prstDash val="solid"/>
-                      <a:round/>
-                      <a:headEnd type="none" w="med" len="med"/>
-                      <a:tailEnd type="none" w="med" len="med"/>
-                    </a:lnT>
-                    <a:lnB w="9525" cap="flat" cmpd="sng" algn="ctr">
-                      <a:solidFill>
-                        <a:srgbClr val="2A5790"/>
-                      </a:solidFill>
-                      <a:prstDash val="solid"/>
-                      <a:round/>
-                      <a:headEnd type="none" w="med" len="med"/>
-                      <a:tailEnd type="none" w="med" len="med"/>
-                    </a:lnB>
-                    <a:solidFill>
-                      <a:srgbClr val="0D3B73"/>
-                    </a:solidFill>
-                  </a:tcPr>
-                </a:tc>
-                <a:tc>
-                  <a:txBody>
-                    <a:bodyPr/>
-                    <a:lstStyle/>
-                    <a:p>
-                      <a:pPr algn="l" indent="0" marL="0">
-                        <a:buNone/>
-                      </a:pPr>
-                      <a:r>
-                        <a:rPr lang="en-US" sz="1000" dirty="0">
-                          <a:solidFill>
-                            <a:srgbClr val="E8F1FF"/>
-                          </a:solidFill>
-                          <a:latin typeface="Arial" pitchFamily="34" charset="0"/>
-                          <a:ea typeface="Arial" pitchFamily="34" charset="-122"/>
-                          <a:cs typeface="Arial" pitchFamily="34" charset="-120"/>
-                        </a:rPr>
-                        <a:t>OS-01 → DH-01 dosing hopper</a:t>
-                      </a:r>
-                      <a:endParaRPr lang="en-US" sz="1000" dirty="0">
-                        <a:latin typeface="Arial" charset="0"/>
-                        <a:ea typeface="Arial" charset="0"/>
-                        <a:cs typeface="Arial" charset="0"/>
-                      </a:endParaRPr>
-                    </a:p>
-                  </a:txBody>
-                  <a:tcPr marL="73152" marR="73152" marT="18288" marB="18288" anchor="ctr">
-                    <a:lnL w="9525" cap="flat" cmpd="sng" algn="ctr">
-                      <a:solidFill>
-                        <a:srgbClr val="2A5790"/>
-                      </a:solidFill>
-                      <a:prstDash val="solid"/>
-                      <a:round/>
-                      <a:headEnd type="none" w="med" len="med"/>
-                      <a:tailEnd type="none" w="med" len="med"/>
-                    </a:lnL>
-                    <a:lnR w="9525" cap="flat" cmpd="sng" algn="ctr">
-                      <a:solidFill>
-                        <a:srgbClr val="2A5790"/>
-                      </a:solidFill>
-                      <a:prstDash val="solid"/>
-                      <a:round/>
-                      <a:headEnd type="none" w="med" len="med"/>
-                      <a:tailEnd type="none" w="med" len="med"/>
-                    </a:lnR>
-                    <a:lnT w="9525" cap="flat" cmpd="sng" algn="ctr">
-                      <a:solidFill>
-                        <a:srgbClr val="2A5790"/>
-                      </a:solidFill>
-                      <a:prstDash val="solid"/>
-                      <a:round/>
-                      <a:headEnd type="none" w="med" len="med"/>
-                      <a:tailEnd type="none" w="med" len="med"/>
-                    </a:lnT>
-                    <a:lnB w="9525" cap="flat" cmpd="sng" algn="ctr">
-                      <a:solidFill>
-                        <a:srgbClr val="2A5790"/>
-                      </a:solidFill>
-                      <a:prstDash val="solid"/>
-                      <a:round/>
-                      <a:headEnd type="none" w="med" len="med"/>
-                      <a:tailEnd type="none" w="med" len="med"/>
-                    </a:lnB>
-                    <a:solidFill>
-                      <a:srgbClr val="0D3B73"/>
-                    </a:solidFill>
-                  </a:tcPr>
-                </a:tc>
-                <a:tc>
-                  <a:txBody>
-                    <a:bodyPr/>
-                    <a:lstStyle/>
-                    <a:p>
-                      <a:pPr algn="r" indent="0" marL="0">
-                        <a:buNone/>
-                      </a:pPr>
-                      <a:r>
-                        <a:rPr lang="en-US" sz="1000" dirty="0">
-                          <a:solidFill>
-                            <a:srgbClr val="E8F1FF"/>
-                          </a:solidFill>
-                          <a:latin typeface="Courier New" pitchFamily="34" charset="0"/>
-                          <a:ea typeface="Courier New" pitchFamily="34" charset="-122"/>
-                          <a:cs typeface="Courier New" pitchFamily="34" charset="-120"/>
-                        </a:rPr>
-                        <a:t>52,485</a:t>
-                      </a:r>
-                      <a:endParaRPr lang="en-US" sz="1000" dirty="0">
-                        <a:latin typeface="Courier New" charset="0"/>
-                        <a:ea typeface="Courier New" charset="0"/>
-                        <a:cs typeface="Courier New" charset="0"/>
-                      </a:endParaRPr>
-                    </a:p>
-                  </a:txBody>
-                  <a:tcPr marL="73152" marR="73152" marT="18288" marB="18288" anchor="ctr">
-                    <a:lnL w="9525" cap="flat" cmpd="sng" algn="ctr">
-                      <a:solidFill>
-                        <a:srgbClr val="2A5790"/>
-                      </a:solidFill>
-                      <a:prstDash val="solid"/>
-                      <a:round/>
-                      <a:headEnd type="none" w="med" len="med"/>
-                      <a:tailEnd type="none" w="med" len="med"/>
-                    </a:lnL>
-                    <a:lnR w="9525" cap="flat" cmpd="sng" algn="ctr">
-                      <a:solidFill>
-                        <a:srgbClr val="2A5790"/>
-                      </a:solidFill>
-                      <a:prstDash val="solid"/>
-                      <a:round/>
-                      <a:headEnd type="none" w="med" len="med"/>
-                      <a:tailEnd type="none" w="med" len="med"/>
-                    </a:lnR>
-                    <a:lnT w="9525" cap="flat" cmpd="sng" algn="ctr">
-                      <a:solidFill>
-                        <a:srgbClr val="2A5790"/>
-                      </a:solidFill>
-                      <a:prstDash val="solid"/>
-                      <a:round/>
-                      <a:headEnd type="none" w="med" len="med"/>
-                      <a:tailEnd type="none" w="med" len="med"/>
-                    </a:lnT>
-                    <a:lnB w="9525" cap="flat" cmpd="sng" algn="ctr">
-                      <a:solidFill>
-                        <a:srgbClr val="2A5790"/>
-                      </a:solidFill>
-                      <a:prstDash val="solid"/>
-                      <a:round/>
-                      <a:headEnd type="none" w="med" len="med"/>
-                      <a:tailEnd type="none" w="med" len="med"/>
-                    </a:lnB>
-                    <a:solidFill>
-                      <a:srgbClr val="0D3B73"/>
-                    </a:solidFill>
-                  </a:tcPr>
-                </a:tc>
-                <a:tc>
-                  <a:txBody>
-                    <a:bodyPr/>
-                    <a:lstStyle/>
-                    <a:p>
-                      <a:pPr algn="r" indent="0" marL="0">
-                        <a:buNone/>
-                      </a:pPr>
-                      <a:r>
-                        <a:rPr lang="en-US" sz="1000" dirty="0">
-                          <a:solidFill>
-                            <a:srgbClr val="E8F1FF"/>
-                          </a:solidFill>
-                          <a:latin typeface="Courier New" pitchFamily="34" charset="0"/>
-                          <a:ea typeface="Courier New" pitchFamily="34" charset="-122"/>
-                          <a:cs typeface="Courier New" pitchFamily="34" charset="-120"/>
-                        </a:rPr>
-                        <a:t>84.6</a:t>
-                      </a:r>
-                      <a:endParaRPr lang="en-US" sz="1000" dirty="0">
-                        <a:latin typeface="Courier New" charset="0"/>
-                        <a:ea typeface="Courier New" charset="0"/>
-                        <a:cs typeface="Courier New" charset="0"/>
-                      </a:endParaRPr>
-                    </a:p>
-                  </a:txBody>
-                  <a:tcPr marL="73152" marR="73152" marT="18288" marB="18288" anchor="ctr">
-                    <a:lnL w="9525" cap="flat" cmpd="sng" algn="ctr">
-                      <a:solidFill>
-                        <a:srgbClr val="2A5790"/>
-                      </a:solidFill>
-                      <a:prstDash val="solid"/>
-                      <a:round/>
-                      <a:headEnd type="none" w="med" len="med"/>
-                      <a:tailEnd type="none" w="med" len="med"/>
-                    </a:lnL>
-                    <a:lnR w="9525" cap="flat" cmpd="sng" algn="ctr">
-                      <a:solidFill>
-                        <a:srgbClr val="2A5790"/>
-                      </a:solidFill>
-                      <a:prstDash val="solid"/>
-                      <a:round/>
-                      <a:headEnd type="none" w="med" len="med"/>
-                      <a:tailEnd type="none" w="med" len="med"/>
-                    </a:lnR>
-                    <a:lnT w="9525" cap="flat" cmpd="sng" algn="ctr">
-                      <a:solidFill>
-                        <a:srgbClr val="2A5790"/>
-                      </a:solidFill>
-                      <a:prstDash val="solid"/>
-                      <a:round/>
-                      <a:headEnd type="none" w="med" len="med"/>
-                      <a:tailEnd type="none" w="med" len="med"/>
-                    </a:lnT>
-                    <a:lnB w="9525" cap="flat" cmpd="sng" algn="ctr">
-                      <a:solidFill>
-                        <a:srgbClr val="2A5790"/>
-                      </a:solidFill>
-                      <a:prstDash val="solid"/>
-                      <a:round/>
-                      <a:headEnd type="none" w="med" len="med"/>
-                      <a:tailEnd type="none" w="med" len="med"/>
-                    </a:lnB>
-                    <a:solidFill>
-                      <a:srgbClr val="0D3B73"/>
-                    </a:solidFill>
-                  </a:tcPr>
-                </a:tc>
-                <a:tc>
-                  <a:txBody>
-                    <a:bodyPr/>
-                    <a:lstStyle/>
-                    <a:p>
-                      <a:pPr algn="r" indent="0" marL="0">
-                        <a:buNone/>
-                      </a:pPr>
-                      <a:r>
-                        <a:rPr lang="en-US" sz="1000" dirty="0">
-                          <a:solidFill>
-                            <a:srgbClr val="E8F1FF"/>
-                          </a:solidFill>
-                          <a:latin typeface="Courier New" pitchFamily="34" charset="0"/>
-                          <a:ea typeface="Courier New" pitchFamily="34" charset="-122"/>
-                          <a:cs typeface="Courier New" pitchFamily="34" charset="-120"/>
-                        </a:rPr>
-                        <a:t>149,957</a:t>
                       </a:r>
                       <a:endParaRPr lang="en-US" sz="1000" dirty="0">
                         <a:latin typeface="Courier New" charset="0"/>
@@ -7955,7 +7206,7 @@
                           <a:ea typeface="Arial" pitchFamily="34" charset="-122"/>
                           <a:cs typeface="Arial" pitchFamily="34" charset="-120"/>
                         </a:rPr>
-                        <a:t>DH-01 → SP-01 at 33 t/h · 1,600 h</a:t>
+                        <a:t>DH-01 → SP-01 at 33 t/h · M5</a:t>
                       </a:r>
                       <a:endParaRPr lang="en-US" sz="1000" dirty="0">
                         <a:latin typeface="Arial" charset="0"/>
@@ -8142,74 +7393,6 @@
                     </a:solidFill>
                   </a:tcPr>
                 </a:tc>
-                <a:tc>
-                  <a:txBody>
-                    <a:bodyPr/>
-                    <a:lstStyle/>
-                    <a:p>
-                      <a:pPr algn="r" indent="0" marL="0">
-                        <a:buNone/>
-                      </a:pPr>
-                      <a:r>
-                        <a:rPr lang="en-US" sz="1000" dirty="0">
-                          <a:solidFill>
-                            <a:srgbClr val="E8F1FF"/>
-                          </a:solidFill>
-                          <a:latin typeface="Courier New" pitchFamily="34" charset="0"/>
-                          <a:ea typeface="Courier New" pitchFamily="34" charset="-122"/>
-                          <a:cs typeface="Courier New" pitchFamily="34" charset="-120"/>
-                        </a:rPr>
-                        <a:t>149,957</a:t>
-                      </a:r>
-                      <a:endParaRPr lang="en-US" sz="1000" dirty="0">
-                        <a:latin typeface="Courier New" charset="0"/>
-                        <a:ea typeface="Courier New" charset="0"/>
-                        <a:cs typeface="Courier New" charset="0"/>
-                      </a:endParaRPr>
-                    </a:p>
-                  </a:txBody>
-                  <a:tcPr marL="73152" marR="73152" marT="18288" marB="18288" anchor="ctr">
-                    <a:lnL w="9525" cap="flat" cmpd="sng" algn="ctr">
-                      <a:solidFill>
-                        <a:srgbClr val="2A5790"/>
-                      </a:solidFill>
-                      <a:prstDash val="solid"/>
-                      <a:round/>
-                      <a:headEnd type="none" w="med" len="med"/>
-                      <a:tailEnd type="none" w="med" len="med"/>
-                    </a:lnL>
-                    <a:lnR w="9525" cap="flat" cmpd="sng" algn="ctr">
-                      <a:solidFill>
-                        <a:srgbClr val="2A5790"/>
-                      </a:solidFill>
-                      <a:prstDash val="solid"/>
-                      <a:round/>
-                      <a:headEnd type="none" w="med" len="med"/>
-                      <a:tailEnd type="none" w="med" len="med"/>
-                    </a:lnR>
-                    <a:lnT w="9525" cap="flat" cmpd="sng" algn="ctr">
-                      <a:solidFill>
-                        <a:srgbClr val="2A5790"/>
-                      </a:solidFill>
-                      <a:prstDash val="solid"/>
-                      <a:round/>
-                      <a:headEnd type="none" w="med" len="med"/>
-                      <a:tailEnd type="none" w="med" len="med"/>
-                    </a:lnT>
-                    <a:lnB w="9525" cap="flat" cmpd="sng" algn="ctr">
-                      <a:solidFill>
-                        <a:srgbClr val="2A5790"/>
-                      </a:solidFill>
-                      <a:prstDash val="solid"/>
-                      <a:round/>
-                      <a:headEnd type="none" w="med" len="med"/>
-                      <a:tailEnd type="none" w="med" len="med"/>
-                    </a:lnB>
-                    <a:solidFill>
-                      <a:srgbClr val="0D3B73"/>
-                    </a:solidFill>
-                  </a:tcPr>
-                </a:tc>
               </a:tr>
               <a:tr h="329184">
                 <a:tc>
@@ -8229,7 +7412,7 @@
                           <a:ea typeface="Courier New" pitchFamily="34" charset="-122"/>
                           <a:cs typeface="Courier New" pitchFamily="34" charset="-120"/>
                         </a:rPr>
-                        <a:t>15</a:t>
+                        <a:t>16</a:t>
                       </a:r>
                       <a:endParaRPr lang="en-US" sz="1000" dirty="0">
                         <a:latin typeface="Courier New" charset="0"/>
@@ -8297,7 +7480,7 @@
                           <a:ea typeface="Arial" pitchFamily="34" charset="-122"/>
                           <a:cs typeface="Arial" pitchFamily="34" charset="-120"/>
                         </a:rPr>
-                        <a:t>SP-01 products / rejects (split TBC)</a:t>
+                        <a:t>Ferrous recovered M1–M5 (1.29% Fe)</a:t>
                       </a:r>
                       <a:endParaRPr lang="en-US" sz="1000" dirty="0">
                         <a:latin typeface="Arial" charset="0"/>
@@ -8365,75 +7548,7 @@
                           <a:ea typeface="Courier New" pitchFamily="34" charset="-122"/>
                           <a:cs typeface="Courier New" pitchFamily="34" charset="-120"/>
                         </a:rPr>
-                        <a:t>52,485</a:t>
-                      </a:r>
-                      <a:endParaRPr lang="en-US" sz="1000" dirty="0">
-                        <a:latin typeface="Courier New" charset="0"/>
-                        <a:ea typeface="Courier New" charset="0"/>
-                        <a:cs typeface="Courier New" charset="0"/>
-                      </a:endParaRPr>
-                    </a:p>
-                  </a:txBody>
-                  <a:tcPr marL="73152" marR="73152" marT="18288" marB="18288" anchor="ctr">
-                    <a:lnL w="9525" cap="flat" cmpd="sng" algn="ctr">
-                      <a:solidFill>
-                        <a:srgbClr val="2A5790"/>
-                      </a:solidFill>
-                      <a:prstDash val="solid"/>
-                      <a:round/>
-                      <a:headEnd type="none" w="med" len="med"/>
-                      <a:tailEnd type="none" w="med" len="med"/>
-                    </a:lnL>
-                    <a:lnR w="9525" cap="flat" cmpd="sng" algn="ctr">
-                      <a:solidFill>
-                        <a:srgbClr val="2A5790"/>
-                      </a:solidFill>
-                      <a:prstDash val="solid"/>
-                      <a:round/>
-                      <a:headEnd type="none" w="med" len="med"/>
-                      <a:tailEnd type="none" w="med" len="med"/>
-                    </a:lnR>
-                    <a:lnT w="9525" cap="flat" cmpd="sng" algn="ctr">
-                      <a:solidFill>
-                        <a:srgbClr val="2A5790"/>
-                      </a:solidFill>
-                      <a:prstDash val="solid"/>
-                      <a:round/>
-                      <a:headEnd type="none" w="med" len="med"/>
-                      <a:tailEnd type="none" w="med" len="med"/>
-                    </a:lnT>
-                    <a:lnB w="9525" cap="flat" cmpd="sng" algn="ctr">
-                      <a:solidFill>
-                        <a:srgbClr val="2A5790"/>
-                      </a:solidFill>
-                      <a:prstDash val="solid"/>
-                      <a:round/>
-                      <a:headEnd type="none" w="med" len="med"/>
-                      <a:tailEnd type="none" w="med" len="med"/>
-                    </a:lnB>
-                    <a:solidFill>
-                      <a:srgbClr val="0D3B73"/>
-                    </a:solidFill>
-                  </a:tcPr>
-                </a:tc>
-                <a:tc>
-                  <a:txBody>
-                    <a:bodyPr/>
-                    <a:lstStyle/>
-                    <a:p>
-                      <a:pPr algn="r" indent="0" marL="0">
-                        <a:buNone/>
-                      </a:pPr>
-                      <a:r>
-                        <a:rPr lang="en-US" sz="1000" dirty="0">
-                          <a:solidFill>
-                            <a:srgbClr val="E8F1FF"/>
-                          </a:solidFill>
-                          <a:latin typeface="Courier New" pitchFamily="34" charset="0"/>
-                          <a:ea typeface="Courier New" pitchFamily="34" charset="-122"/>
-                          <a:cs typeface="Courier New" pitchFamily="34" charset="-120"/>
-                        </a:rPr>
-                        <a:t>–</a:t>
+                        <a:t>948</a:t>
                       </a:r>
                       <a:endParaRPr lang="en-US" sz="1000" dirty="0">
                         <a:latin typeface="Courier New" charset="0"/>
@@ -8639,7 +7754,7 @@
                           <a:ea typeface="Arial" pitchFamily="34" charset="-122"/>
                           <a:cs typeface="Arial" pitchFamily="34" charset="-120"/>
                         </a:rPr>
-                        <a:t>Bulky delivered → SH-02</a:t>
+                        <a:t>Bulky → SH-02 → off-site</a:t>
                       </a:r>
                       <a:endParaRPr lang="en-US" sz="1000" dirty="0">
                         <a:latin typeface="Arial" charset="0"/>
@@ -8826,416 +7941,6 @@
                     </a:solidFill>
                   </a:tcPr>
                 </a:tc>
-                <a:tc>
-                  <a:txBody>
-                    <a:bodyPr/>
-                    <a:lstStyle/>
-                    <a:p>
-                      <a:pPr algn="r" indent="0" marL="0">
-                        <a:buNone/>
-                      </a:pPr>
-                      <a:r>
-                        <a:rPr lang="en-US" sz="1000" dirty="0">
-                          <a:solidFill>
-                            <a:srgbClr val="E8F1FF"/>
-                          </a:solidFill>
-                          <a:latin typeface="Courier New" pitchFamily="34" charset="0"/>
-                          <a:ea typeface="Courier New" pitchFamily="34" charset="-122"/>
-                          <a:cs typeface="Courier New" pitchFamily="34" charset="-120"/>
-                        </a:rPr>
-                        <a:t>–</a:t>
-                      </a:r>
-                      <a:endParaRPr lang="en-US" sz="1000" dirty="0">
-                        <a:latin typeface="Courier New" charset="0"/>
-                        <a:ea typeface="Courier New" charset="0"/>
-                        <a:cs typeface="Courier New" charset="0"/>
-                      </a:endParaRPr>
-                    </a:p>
-                  </a:txBody>
-                  <a:tcPr marL="73152" marR="73152" marT="18288" marB="18288" anchor="ctr">
-                    <a:lnL w="9525" cap="flat" cmpd="sng" algn="ctr">
-                      <a:solidFill>
-                        <a:srgbClr val="2A5790"/>
-                      </a:solidFill>
-                      <a:prstDash val="solid"/>
-                      <a:round/>
-                      <a:headEnd type="none" w="med" len="med"/>
-                      <a:tailEnd type="none" w="med" len="med"/>
-                    </a:lnL>
-                    <a:lnR w="9525" cap="flat" cmpd="sng" algn="ctr">
-                      <a:solidFill>
-                        <a:srgbClr val="2A5790"/>
-                      </a:solidFill>
-                      <a:prstDash val="solid"/>
-                      <a:round/>
-                      <a:headEnd type="none" w="med" len="med"/>
-                      <a:tailEnd type="none" w="med" len="med"/>
-                    </a:lnR>
-                    <a:lnT w="9525" cap="flat" cmpd="sng" algn="ctr">
-                      <a:solidFill>
-                        <a:srgbClr val="2A5790"/>
-                      </a:solidFill>
-                      <a:prstDash val="solid"/>
-                      <a:round/>
-                      <a:headEnd type="none" w="med" len="med"/>
-                      <a:tailEnd type="none" w="med" len="med"/>
-                    </a:lnT>
-                    <a:lnB w="9525" cap="flat" cmpd="sng" algn="ctr">
-                      <a:solidFill>
-                        <a:srgbClr val="2A5790"/>
-                      </a:solidFill>
-                      <a:prstDash val="solid"/>
-                      <a:round/>
-                      <a:headEnd type="none" w="med" len="med"/>
-                      <a:tailEnd type="none" w="med" len="med"/>
-                    </a:lnB>
-                    <a:solidFill>
-                      <a:srgbClr val="0D3B73"/>
-                    </a:solidFill>
-                  </a:tcPr>
-                </a:tc>
-              </a:tr>
-              <a:tr h="329184">
-                <a:tc>
-                  <a:txBody>
-                    <a:bodyPr/>
-                    <a:lstStyle/>
-                    <a:p>
-                      <a:pPr algn="ctr" indent="0" marL="0">
-                        <a:buNone/>
-                      </a:pPr>
-                      <a:r>
-                        <a:rPr lang="en-US" sz="1000" dirty="0">
-                          <a:solidFill>
-                            <a:srgbClr val="E8F1FF"/>
-                          </a:solidFill>
-                          <a:latin typeface="Courier New" pitchFamily="34" charset="0"/>
-                          <a:ea typeface="Courier New" pitchFamily="34" charset="-122"/>
-                          <a:cs typeface="Courier New" pitchFamily="34" charset="-120"/>
-                        </a:rPr>
-                        <a:t>12</a:t>
-                      </a:r>
-                      <a:endParaRPr lang="en-US" sz="1000" dirty="0">
-                        <a:latin typeface="Courier New" charset="0"/>
-                        <a:ea typeface="Courier New" charset="0"/>
-                        <a:cs typeface="Courier New" charset="0"/>
-                      </a:endParaRPr>
-                    </a:p>
-                  </a:txBody>
-                  <a:tcPr marL="73152" marR="73152" marT="18288" marB="18288" anchor="ctr">
-                    <a:lnL w="9525" cap="flat" cmpd="sng" algn="ctr">
-                      <a:solidFill>
-                        <a:srgbClr val="2A5790"/>
-                      </a:solidFill>
-                      <a:prstDash val="solid"/>
-                      <a:round/>
-                      <a:headEnd type="none" w="med" len="med"/>
-                      <a:tailEnd type="none" w="med" len="med"/>
-                    </a:lnL>
-                    <a:lnR w="9525" cap="flat" cmpd="sng" algn="ctr">
-                      <a:solidFill>
-                        <a:srgbClr val="2A5790"/>
-                      </a:solidFill>
-                      <a:prstDash val="solid"/>
-                      <a:round/>
-                      <a:headEnd type="none" w="med" len="med"/>
-                      <a:tailEnd type="none" w="med" len="med"/>
-                    </a:lnR>
-                    <a:lnT w="9525" cap="flat" cmpd="sng" algn="ctr">
-                      <a:solidFill>
-                        <a:srgbClr val="2A5790"/>
-                      </a:solidFill>
-                      <a:prstDash val="solid"/>
-                      <a:round/>
-                      <a:headEnd type="none" w="med" len="med"/>
-                      <a:tailEnd type="none" w="med" len="med"/>
-                    </a:lnT>
-                    <a:lnB w="9525" cap="flat" cmpd="sng" algn="ctr">
-                      <a:solidFill>
-                        <a:srgbClr val="2A5790"/>
-                      </a:solidFill>
-                      <a:prstDash val="solid"/>
-                      <a:round/>
-                      <a:headEnd type="none" w="med" len="med"/>
-                      <a:tailEnd type="none" w="med" len="med"/>
-                    </a:lnB>
-                    <a:solidFill>
-                      <a:srgbClr val="0D3B73"/>
-                    </a:solidFill>
-                  </a:tcPr>
-                </a:tc>
-                <a:tc>
-                  <a:txBody>
-                    <a:bodyPr/>
-                    <a:lstStyle/>
-                    <a:p>
-                      <a:pPr algn="l" indent="0" marL="0">
-                        <a:buNone/>
-                      </a:pPr>
-                      <a:r>
-                        <a:rPr lang="en-US" sz="1000" dirty="0">
-                          <a:solidFill>
-                            <a:srgbClr val="E8F1FF"/>
-                          </a:solidFill>
-                          <a:latin typeface="Arial" pitchFamily="34" charset="0"/>
-                          <a:ea typeface="Arial" pitchFamily="34" charset="-122"/>
-                          <a:cs typeface="Arial" pitchFamily="34" charset="-120"/>
-                        </a:rPr>
-                        <a:t>Shredded bulky off-site</a:t>
-                      </a:r>
-                      <a:endParaRPr lang="en-US" sz="1000" dirty="0">
-                        <a:latin typeface="Arial" charset="0"/>
-                        <a:ea typeface="Arial" charset="0"/>
-                        <a:cs typeface="Arial" charset="0"/>
-                      </a:endParaRPr>
-                    </a:p>
-                  </a:txBody>
-                  <a:tcPr marL="73152" marR="73152" marT="18288" marB="18288" anchor="ctr">
-                    <a:lnL w="9525" cap="flat" cmpd="sng" algn="ctr">
-                      <a:solidFill>
-                        <a:srgbClr val="2A5790"/>
-                      </a:solidFill>
-                      <a:prstDash val="solid"/>
-                      <a:round/>
-                      <a:headEnd type="none" w="med" len="med"/>
-                      <a:tailEnd type="none" w="med" len="med"/>
-                    </a:lnL>
-                    <a:lnR w="9525" cap="flat" cmpd="sng" algn="ctr">
-                      <a:solidFill>
-                        <a:srgbClr val="2A5790"/>
-                      </a:solidFill>
-                      <a:prstDash val="solid"/>
-                      <a:round/>
-                      <a:headEnd type="none" w="med" len="med"/>
-                      <a:tailEnd type="none" w="med" len="med"/>
-                    </a:lnR>
-                    <a:lnT w="9525" cap="flat" cmpd="sng" algn="ctr">
-                      <a:solidFill>
-                        <a:srgbClr val="2A5790"/>
-                      </a:solidFill>
-                      <a:prstDash val="solid"/>
-                      <a:round/>
-                      <a:headEnd type="none" w="med" len="med"/>
-                      <a:tailEnd type="none" w="med" len="med"/>
-                    </a:lnT>
-                    <a:lnB w="9525" cap="flat" cmpd="sng" algn="ctr">
-                      <a:solidFill>
-                        <a:srgbClr val="2A5790"/>
-                      </a:solidFill>
-                      <a:prstDash val="solid"/>
-                      <a:round/>
-                      <a:headEnd type="none" w="med" len="med"/>
-                      <a:tailEnd type="none" w="med" len="med"/>
-                    </a:lnB>
-                    <a:solidFill>
-                      <a:srgbClr val="0D3B73"/>
-                    </a:solidFill>
-                  </a:tcPr>
-                </a:tc>
-                <a:tc>
-                  <a:txBody>
-                    <a:bodyPr/>
-                    <a:lstStyle/>
-                    <a:p>
-                      <a:pPr algn="r" indent="0" marL="0">
-                        <a:buNone/>
-                      </a:pPr>
-                      <a:r>
-                        <a:rPr lang="en-US" sz="1000" dirty="0">
-                          <a:solidFill>
-                            <a:srgbClr val="E8F1FF"/>
-                          </a:solidFill>
-                          <a:latin typeface="Courier New" pitchFamily="34" charset="0"/>
-                          <a:ea typeface="Courier New" pitchFamily="34" charset="-122"/>
-                          <a:cs typeface="Courier New" pitchFamily="34" charset="-120"/>
-                        </a:rPr>
-                        <a:t>60,000</a:t>
-                      </a:r>
-                      <a:endParaRPr lang="en-US" sz="1000" dirty="0">
-                        <a:latin typeface="Courier New" charset="0"/>
-                        <a:ea typeface="Courier New" charset="0"/>
-                        <a:cs typeface="Courier New" charset="0"/>
-                      </a:endParaRPr>
-                    </a:p>
-                  </a:txBody>
-                  <a:tcPr marL="73152" marR="73152" marT="18288" marB="18288" anchor="ctr">
-                    <a:lnL w="9525" cap="flat" cmpd="sng" algn="ctr">
-                      <a:solidFill>
-                        <a:srgbClr val="2A5790"/>
-                      </a:solidFill>
-                      <a:prstDash val="solid"/>
-                      <a:round/>
-                      <a:headEnd type="none" w="med" len="med"/>
-                      <a:tailEnd type="none" w="med" len="med"/>
-                    </a:lnL>
-                    <a:lnR w="9525" cap="flat" cmpd="sng" algn="ctr">
-                      <a:solidFill>
-                        <a:srgbClr val="2A5790"/>
-                      </a:solidFill>
-                      <a:prstDash val="solid"/>
-                      <a:round/>
-                      <a:headEnd type="none" w="med" len="med"/>
-                      <a:tailEnd type="none" w="med" len="med"/>
-                    </a:lnR>
-                    <a:lnT w="9525" cap="flat" cmpd="sng" algn="ctr">
-                      <a:solidFill>
-                        <a:srgbClr val="2A5790"/>
-                      </a:solidFill>
-                      <a:prstDash val="solid"/>
-                      <a:round/>
-                      <a:headEnd type="none" w="med" len="med"/>
-                      <a:tailEnd type="none" w="med" len="med"/>
-                    </a:lnT>
-                    <a:lnB w="9525" cap="flat" cmpd="sng" algn="ctr">
-                      <a:solidFill>
-                        <a:srgbClr val="2A5790"/>
-                      </a:solidFill>
-                      <a:prstDash val="solid"/>
-                      <a:round/>
-                      <a:headEnd type="none" w="med" len="med"/>
-                      <a:tailEnd type="none" w="med" len="med"/>
-                    </a:lnB>
-                    <a:solidFill>
-                      <a:srgbClr val="0D3B73"/>
-                    </a:solidFill>
-                  </a:tcPr>
-                </a:tc>
-                <a:tc>
-                  <a:txBody>
-                    <a:bodyPr/>
-                    <a:lstStyle/>
-                    <a:p>
-                      <a:pPr algn="r" indent="0" marL="0">
-                        <a:buNone/>
-                      </a:pPr>
-                      <a:r>
-                        <a:rPr lang="en-US" sz="1000" dirty="0">
-                          <a:solidFill>
-                            <a:srgbClr val="E8F1FF"/>
-                          </a:solidFill>
-                          <a:latin typeface="Courier New" pitchFamily="34" charset="0"/>
-                          <a:ea typeface="Courier New" pitchFamily="34" charset="-122"/>
-                          <a:cs typeface="Courier New" pitchFamily="34" charset="-120"/>
-                        </a:rPr>
-                        <a:t>–</a:t>
-                      </a:r>
-                      <a:endParaRPr lang="en-US" sz="1000" dirty="0">
-                        <a:latin typeface="Courier New" charset="0"/>
-                        <a:ea typeface="Courier New" charset="0"/>
-                        <a:cs typeface="Courier New" charset="0"/>
-                      </a:endParaRPr>
-                    </a:p>
-                  </a:txBody>
-                  <a:tcPr marL="73152" marR="73152" marT="18288" marB="18288" anchor="ctr">
-                    <a:lnL w="9525" cap="flat" cmpd="sng" algn="ctr">
-                      <a:solidFill>
-                        <a:srgbClr val="2A5790"/>
-                      </a:solidFill>
-                      <a:prstDash val="solid"/>
-                      <a:round/>
-                      <a:headEnd type="none" w="med" len="med"/>
-                      <a:tailEnd type="none" w="med" len="med"/>
-                    </a:lnL>
-                    <a:lnR w="9525" cap="flat" cmpd="sng" algn="ctr">
-                      <a:solidFill>
-                        <a:srgbClr val="2A5790"/>
-                      </a:solidFill>
-                      <a:prstDash val="solid"/>
-                      <a:round/>
-                      <a:headEnd type="none" w="med" len="med"/>
-                      <a:tailEnd type="none" w="med" len="med"/>
-                    </a:lnR>
-                    <a:lnT w="9525" cap="flat" cmpd="sng" algn="ctr">
-                      <a:solidFill>
-                        <a:srgbClr val="2A5790"/>
-                      </a:solidFill>
-                      <a:prstDash val="solid"/>
-                      <a:round/>
-                      <a:headEnd type="none" w="med" len="med"/>
-                      <a:tailEnd type="none" w="med" len="med"/>
-                    </a:lnT>
-                    <a:lnB w="9525" cap="flat" cmpd="sng" algn="ctr">
-                      <a:solidFill>
-                        <a:srgbClr val="2A5790"/>
-                      </a:solidFill>
-                      <a:prstDash val="solid"/>
-                      <a:round/>
-                      <a:headEnd type="none" w="med" len="med"/>
-                      <a:tailEnd type="none" w="med" len="med"/>
-                    </a:lnB>
-                    <a:solidFill>
-                      <a:srgbClr val="0D3B73"/>
-                    </a:solidFill>
-                  </a:tcPr>
-                </a:tc>
-                <a:tc>
-                  <a:txBody>
-                    <a:bodyPr/>
-                    <a:lstStyle/>
-                    <a:p>
-                      <a:pPr algn="r" indent="0" marL="0">
-                        <a:buNone/>
-                      </a:pPr>
-                      <a:r>
-                        <a:rPr lang="en-US" sz="1000" dirty="0">
-                          <a:solidFill>
-                            <a:srgbClr val="E8F1FF"/>
-                          </a:solidFill>
-                          <a:latin typeface="Courier New" pitchFamily="34" charset="0"/>
-                          <a:ea typeface="Courier New" pitchFamily="34" charset="-122"/>
-                          <a:cs typeface="Courier New" pitchFamily="34" charset="-120"/>
-                        </a:rPr>
-                        <a:t>–</a:t>
-                      </a:r>
-                      <a:endParaRPr lang="en-US" sz="1000" dirty="0">
-                        <a:latin typeface="Courier New" charset="0"/>
-                        <a:ea typeface="Courier New" charset="0"/>
-                        <a:cs typeface="Courier New" charset="0"/>
-                      </a:endParaRPr>
-                    </a:p>
-                  </a:txBody>
-                  <a:tcPr marL="73152" marR="73152" marT="18288" marB="18288" anchor="ctr">
-                    <a:lnL w="9525" cap="flat" cmpd="sng" algn="ctr">
-                      <a:solidFill>
-                        <a:srgbClr val="2A5790"/>
-                      </a:solidFill>
-                      <a:prstDash val="solid"/>
-                      <a:round/>
-                      <a:headEnd type="none" w="med" len="med"/>
-                      <a:tailEnd type="none" w="med" len="med"/>
-                    </a:lnL>
-                    <a:lnR w="9525" cap="flat" cmpd="sng" algn="ctr">
-                      <a:solidFill>
-                        <a:srgbClr val="2A5790"/>
-                      </a:solidFill>
-                      <a:prstDash val="solid"/>
-                      <a:round/>
-                      <a:headEnd type="none" w="med" len="med"/>
-                      <a:tailEnd type="none" w="med" len="med"/>
-                    </a:lnR>
-                    <a:lnT w="9525" cap="flat" cmpd="sng" algn="ctr">
-                      <a:solidFill>
-                        <a:srgbClr val="2A5790"/>
-                      </a:solidFill>
-                      <a:prstDash val="solid"/>
-                      <a:round/>
-                      <a:headEnd type="none" w="med" len="med"/>
-                      <a:tailEnd type="none" w="med" len="med"/>
-                    </a:lnT>
-                    <a:lnB w="9525" cap="flat" cmpd="sng" algn="ctr">
-                      <a:solidFill>
-                        <a:srgbClr val="2A5790"/>
-                      </a:solidFill>
-                      <a:prstDash val="solid"/>
-                      <a:round/>
-                      <a:headEnd type="none" w="med" len="med"/>
-                      <a:tailEnd type="none" w="med" len="med"/>
-                    </a:lnB>
-                    <a:solidFill>
-                      <a:srgbClr val="0D3B73"/>
-                    </a:solidFill>
-                  </a:tcPr>
-                </a:tc>
               </a:tr>
             </a:tbl>
           </a:graphicData>
@@ -9317,7 +8022,7 @@
                 <a:ea typeface="Arial" pitchFamily="34" charset="-122"/>
                 <a:cs typeface="Arial" pitchFamily="34" charset="-120"/>
               </a:rPr>
-              <a:t>SH-01 MSW only, 46.9 t/h; SH-02 bulky only, ≥ 38 t/h</a:t>
+              <a:t>6 identical 40 m tunnels, 481 t at 4.46 m</a:t>
             </a:r>
             <a:endParaRPr lang="en-US" sz="1200" dirty="0"/>
           </a:p>
@@ -9338,7 +8043,7 @@
                 <a:ea typeface="Arial" pitchFamily="34" charset="-122"/>
                 <a:cs typeface="Arial" pitchFamily="34" charset="-120"/>
               </a:rPr>
-              <a:t>Blazequel on outfeed belt + 4 IR-watched bays, 12 h hold</a:t>
+              <a:t>SH-01 → 80 mm trommel; overs via SH-03</a:t>
             </a:r>
             <a:endParaRPr lang="en-US" sz="1200" dirty="0"/>
           </a:p>
@@ -9359,7 +8064,7 @@
                 <a:ea typeface="Arial" pitchFamily="34" charset="-122"/>
                 <a:cs typeface="Arial" pitchFamily="34" charset="-120"/>
               </a:rPr>
-              <a:t>6 identical 40 m tunnels; turns always into an emptied one</a:t>
+              <a:t>5 magnets M1–M5; Blazequel on both shredders</a:t>
             </a:r>
             <a:endParaRPr lang="en-US" sz="1200" dirty="0"/>
           </a:p>
@@ -9380,7 +8085,7 @@
                 <a:ea typeface="Arial" pitchFamily="34" charset="-122"/>
                 <a:cs typeface="Arial" pitchFamily="34" charset="-120"/>
               </a:rPr>
-              <a:t>Heat plant 171 kW + margin, not 257 kW</a:t>
+              <a:t>4 IR-watched bays, 12 h hold</a:t>
             </a:r>
             <a:endParaRPr lang="en-US" sz="1200" dirty="0"/>
           </a:p>
@@ -9401,7 +8106,7 @@
                 <a:ea typeface="Arial" pitchFamily="34" charset="-122"/>
                 <a:cs typeface="Arial" pitchFamily="34" charset="-120"/>
               </a:rPr>
-              <a:t>SP-01 33 t/h in 1,600 h (0.6% margin)</a:t>
+              <a:t>SP-01 33 t/h in 1,600 h</a:t>
             </a:r>
             <a:endParaRPr lang="en-US" sz="1200" dirty="0"/>
           </a:p>
@@ -9483,7 +8188,7 @@
                 <a:ea typeface="Arial" pitchFamily="34" charset="-122"/>
                 <a:cs typeface="Arial" pitchFamily="34" charset="-120"/>
               </a:rPr>
-              <a:t>Portadown Blazequel + post-belt fire log</a:t>
+              <a:t>Trommel unders split (65% assumed)</a:t>
             </a:r>
             <a:endParaRPr lang="en-US" sz="1200" dirty="0"/>
           </a:p>
@@ -9504,7 +8209,7 @@
                 <a:ea typeface="Arial" pitchFamily="34" charset="-122"/>
                 <a:cs typeface="Arial" pitchFamily="34" charset="-120"/>
               </a:rPr>
-              <a:t>SH-02 bulky rate (≥ 38 t/h?)</a:t>
+              <a:t>Magnet efficiencies (assumed)</a:t>
             </a:r>
             <a:endParaRPr lang="en-US" sz="1200" dirty="0"/>
           </a:p>
@@ -9525,7 +8230,7 @@
                 <a:ea typeface="Arial" pitchFamily="34" charset="-122"/>
                 <a:cs typeface="Arial" pitchFamily="34" charset="-120"/>
               </a:rPr>
-              <a:t>Loader cycle time (2 min assumed)</a:t>
+              <a:t>SH-03 model and rate on overs</a:t>
             </a:r>
             <a:endParaRPr lang="en-US" sz="1200" dirty="0"/>
           </a:p>
@@ -9546,7 +8251,7 @@
                 <a:ea typeface="Arial" pitchFamily="34" charset="-122"/>
                 <a:cs typeface="Arial" pitchFamily="34" charset="-120"/>
               </a:rPr>
-              <a:t>WTT: 6 days in stage 1 vs 7</a:t>
+              <a:t>WTT: 40 m stage 2 heat / single pass</a:t>
             </a:r>
             <a:endParaRPr lang="en-US" sz="1200" dirty="0"/>
           </a:p>
@@ -9606,7 +8311,7 @@
                 <a:ea typeface="Courier New" pitchFamily="34" charset="-122"/>
                 <a:cs typeface="Courier New" pitchFamily="34" charset="-120"/>
               </a:rPr>
-              <a:t>26029-PFD-003 rev B · Coleraine / Riverridge · WTT 26029 rev 1 basis · sheet 3 of 3</a:t>
+              <a:t>26029-PFD-003 rev C · Coleraine / Riverridge · WTT 26029 rev 1 basis · sheet 3 of 3</a:t>
             </a:r>
             <a:endParaRPr lang="en-US" sz="800" dirty="0"/>
           </a:p>

</xml_diff>

<commit_message>
Output straight onto trucks to FCG: remove storage bay, dosing hopper and secondary processing
- Dashboard: output route by truck (13.5 × 25 t per unload, ~40/week), truck-availability warning,
  loader hours without hopper feed, fire controls for outbound loads; secondary processing inputs removed
- Blueprint 26029-PFD-003 rev D, methodology sheet 7 and PowerPoint updated; M5 location TBC

Co-Authored-By: Claude Opus 5.5 <noreply@anthropic.com>
Claude-Session: https://claude.ai/code/session_01DJdAKW37ox1vjrzWffae3K
</commit_message>
<xml_diff>
--- a/Coleraine-6x40m-Tunnel-PFD.pptx
+++ b/Coleraine-6x40m-Tunnel-PFD.pptx
@@ -1125,7 +1125,7 @@
                 <a:ea typeface="Arial" pitchFamily="34" charset="-122"/>
                 <a:cs typeface="Arial" pitchFamily="34" charset="-120"/>
               </a:rPr>
-              <a:t>75,000 t/yr MSW · SH-01 → 80 mm trommel → SH-03 on overs · 5 magnets · 6 identical tunnels 40 × 8 × 6 m · Mon–Sat</a:t>
+              <a:t>75,000 t/yr MSW · SH-01 → 80 mm trommel → SH-03 on overs · magnets · 6 × 40 m tunnels · output by truck to FCG</a:t>
             </a:r>
             <a:endParaRPr lang="en-US" sz="1200" dirty="0"/>
           </a:p>
@@ -1582,7 +1582,7 @@
                 <a:ea typeface="Arial" pitchFamily="34" charset="-122"/>
                 <a:cs typeface="Arial" pitchFamily="34" charset="-120"/>
               </a:rPr>
-              <a:t>~950 t</a:t>
+              <a:t>40 /wk</a:t>
             </a:r>
             <a:endParaRPr lang="en-US" sz="2400" dirty="0"/>
           </a:p>
@@ -1621,7 +1621,7 @@
                 <a:ea typeface="Arial" pitchFamily="34" charset="-122"/>
                 <a:cs typeface="Arial" pitchFamily="34" charset="-120"/>
               </a:rPr>
-              <a:t>FERROUS RECOVERED</a:t>
+              <a:t>TRUCKS TO FCG</a:t>
             </a:r>
             <a:endParaRPr lang="en-US" sz="1000" dirty="0"/>
           </a:p>
@@ -1660,7 +1660,7 @@
                 <a:ea typeface="Arial" pitchFamily="34" charset="-122"/>
                 <a:cs typeface="Arial" pitchFamily="34" charset="-120"/>
               </a:rPr>
-              <a:t>5 magnets · 1.29% Fe</a:t>
+              <a:t>13.5 per unload · ~16 min each</a:t>
             </a:r>
             <a:endParaRPr lang="en-US" sz="1000" dirty="0"/>
           </a:p>
@@ -1816,7 +1816,7 @@
                 <a:ea typeface="Courier New" pitchFamily="34" charset="-122"/>
                 <a:cs typeface="Courier New" pitchFamily="34" charset="-120"/>
               </a:rPr>
-              <a:t>26029-PFD-003 rev C · Coleraine / Riverridge · WTT 26029 rev 1 basis · sheet 1 of 3</a:t>
+              <a:t>26029-PFD-003 rev D · Coleraine / Riverridge · WTT 26029 rev 1 basis · sheet 1 of 3</a:t>
             </a:r>
             <a:endParaRPr lang="en-US" sz="800" dirty="0"/>
           </a:p>
@@ -1984,7 +1984,7 @@
         <p:spPr>
           <a:xfrm>
             <a:off x="2377440" y="1371600"/>
-            <a:ext cx="0" cy="3337560"/>
+            <a:ext cx="0" cy="2926080"/>
           </a:xfrm>
           <a:prstGeom prst="line">
             <a:avLst/>
@@ -2046,7 +2046,7 @@
         <p:spPr>
           <a:xfrm>
             <a:off x="3046911" y="1371600"/>
-            <a:ext cx="0" cy="3337560"/>
+            <a:ext cx="0" cy="2926080"/>
           </a:xfrm>
           <a:prstGeom prst="line">
             <a:avLst/>
@@ -2069,7 +2069,7 @@
         <p:spPr>
           <a:xfrm>
             <a:off x="3716383" y="1371600"/>
-            <a:ext cx="0" cy="3337560"/>
+            <a:ext cx="0" cy="2926080"/>
           </a:xfrm>
           <a:prstGeom prst="line">
             <a:avLst/>
@@ -2131,7 +2131,7 @@
         <p:spPr>
           <a:xfrm>
             <a:off x="4385854" y="1371600"/>
-            <a:ext cx="0" cy="3337560"/>
+            <a:ext cx="0" cy="2926080"/>
           </a:xfrm>
           <a:prstGeom prst="line">
             <a:avLst/>
@@ -2154,7 +2154,7 @@
         <p:spPr>
           <a:xfrm>
             <a:off x="5055326" y="1371600"/>
-            <a:ext cx="0" cy="3337560"/>
+            <a:ext cx="0" cy="2926080"/>
           </a:xfrm>
           <a:prstGeom prst="line">
             <a:avLst/>
@@ -2216,7 +2216,7 @@
         <p:spPr>
           <a:xfrm>
             <a:off x="5724797" y="1371600"/>
-            <a:ext cx="0" cy="3337560"/>
+            <a:ext cx="0" cy="2926080"/>
           </a:xfrm>
           <a:prstGeom prst="line">
             <a:avLst/>
@@ -2239,7 +2239,7 @@
         <p:spPr>
           <a:xfrm>
             <a:off x="6394269" y="1371600"/>
-            <a:ext cx="0" cy="3337560"/>
+            <a:ext cx="0" cy="2926080"/>
           </a:xfrm>
           <a:prstGeom prst="line">
             <a:avLst/>
@@ -2301,7 +2301,7 @@
         <p:spPr>
           <a:xfrm>
             <a:off x="7063740" y="1371600"/>
-            <a:ext cx="0" cy="3337560"/>
+            <a:ext cx="0" cy="2926080"/>
           </a:xfrm>
           <a:prstGeom prst="line">
             <a:avLst/>
@@ -2324,7 +2324,7 @@
         <p:spPr>
           <a:xfrm>
             <a:off x="7733211" y="1371600"/>
-            <a:ext cx="0" cy="3337560"/>
+            <a:ext cx="0" cy="2926080"/>
           </a:xfrm>
           <a:prstGeom prst="line">
             <a:avLst/>
@@ -2386,7 +2386,7 @@
         <p:spPr>
           <a:xfrm>
             <a:off x="8402683" y="1371600"/>
-            <a:ext cx="0" cy="3337560"/>
+            <a:ext cx="0" cy="2926080"/>
           </a:xfrm>
           <a:prstGeom prst="line">
             <a:avLst/>
@@ -2409,7 +2409,7 @@
         <p:spPr>
           <a:xfrm>
             <a:off x="9072154" y="1371600"/>
-            <a:ext cx="0" cy="3337560"/>
+            <a:ext cx="0" cy="2926080"/>
           </a:xfrm>
           <a:prstGeom prst="line">
             <a:avLst/>
@@ -2471,7 +2471,7 @@
         <p:spPr>
           <a:xfrm>
             <a:off x="9741626" y="1371600"/>
-            <a:ext cx="0" cy="3337560"/>
+            <a:ext cx="0" cy="2926080"/>
           </a:xfrm>
           <a:prstGeom prst="line">
             <a:avLst/>
@@ -2494,7 +2494,7 @@
         <p:spPr>
           <a:xfrm>
             <a:off x="10411097" y="1371600"/>
-            <a:ext cx="0" cy="3337560"/>
+            <a:ext cx="0" cy="2926080"/>
           </a:xfrm>
           <a:prstGeom prst="line">
             <a:avLst/>
@@ -2556,7 +2556,7 @@
         <p:spPr>
           <a:xfrm>
             <a:off x="11080569" y="1371600"/>
-            <a:ext cx="0" cy="3337560"/>
+            <a:ext cx="0" cy="2926080"/>
           </a:xfrm>
           <a:prstGeom prst="line">
             <a:avLst/>
@@ -2579,7 +2579,7 @@
         <p:spPr>
           <a:xfrm>
             <a:off x="11750040" y="1371600"/>
-            <a:ext cx="0" cy="3337560"/>
+            <a:ext cx="0" cy="2926080"/>
           </a:xfrm>
           <a:prstGeom prst="line">
             <a:avLst/>
@@ -2726,53 +2726,6 @@
         </p:nvSpPr>
         <p:spPr>
           <a:xfrm>
-            <a:off x="8154978" y="1463040"/>
-            <a:ext cx="2343150" cy="320040"/>
-          </a:xfrm>
-          <a:prstGeom prst="rect">
-            <a:avLst/>
-          </a:prstGeom>
-          <a:solidFill>
-            <a:srgbClr val="9EC3F0">
-              <a:alpha val="15000"/>
-            </a:srgbClr>
-          </a:solidFill>
-          <a:ln w="12700">
-            <a:solidFill>
-              <a:srgbClr val="9EC3F0"/>
-            </a:solidFill>
-          </a:ln>
-        </p:spPr>
-        <p:txBody>
-          <a:bodyPr wrap="square" lIns="0" tIns="0" rIns="0" bIns="0" rtlCol="0" anchor="ctr"/>
-          <a:lstStyle/>
-          <a:p>
-            <a:pPr indent="0" marL="0">
-              <a:buNone/>
-            </a:pPr>
-            <a:r>
-              <a:rPr lang="en-US" sz="1000" dirty="0">
-                <a:solidFill>
-                  <a:srgbClr val="E8F1FF"/>
-                </a:solidFill>
-                <a:latin typeface="Arial" pitchFamily="34" charset="0"/>
-                <a:ea typeface="Arial" pitchFamily="34" charset="-122"/>
-                <a:cs typeface="Arial" pitchFamily="34" charset="-120"/>
-              </a:rPr>
-              <a:t>  feed DH-01</a:t>
-            </a:r>
-            <a:endParaRPr lang="en-US" sz="1000" dirty="0"/>
-          </a:p>
-        </p:txBody>
-      </p:sp>
-      <p:sp>
-        <p:nvSpPr>
-          <p:cNvPr id="31" name="Text 29"/>
-          <p:cNvSpPr txBox="1"/>
-          <p:nvPr/>
-        </p:nvSpPr>
-        <p:spPr>
-          <a:xfrm>
             <a:off x="411480" y="1874520"/>
             <a:ext cx="1920240" cy="320040"/>
           </a:xfrm>
@@ -2806,7 +2759,7 @@
       </p:sp>
       <p:sp>
         <p:nvSpPr>
-          <p:cNvPr id="32" name="Text 30"/>
+          <p:cNvPr id="31" name="Text 29"/>
           <p:cNvSpPr txBox="1"/>
           <p:nvPr/>
         </p:nvSpPr>
@@ -2845,7 +2798,7 @@
                 <a:ea typeface="Arial" pitchFamily="34" charset="-122"/>
                 <a:cs typeface="Arial" pitchFamily="34" charset="-120"/>
               </a:rPr>
-              <a:t>  ① empty T4 → OS-01 · 107 b</a:t>
+              <a:t>  ① empty T4 → trucks → FCG · 107 b</a:t>
             </a:r>
             <a:endParaRPr lang="en-US" sz="1000" dirty="0"/>
           </a:p>
@@ -2853,7 +2806,7 @@
       </p:sp>
       <p:sp>
         <p:nvSpPr>
-          <p:cNvPr id="33" name="Text 31"/>
+          <p:cNvPr id="32" name="Text 30"/>
           <p:cNvSpPr txBox="1"/>
           <p:nvPr/>
         </p:nvSpPr>
@@ -2892,7 +2845,7 @@
                 <a:ea typeface="Arial" pitchFamily="34" charset="-122"/>
                 <a:cs typeface="Arial" pitchFamily="34" charset="-120"/>
               </a:rPr>
-              <a:t>  feed SH-01 (+ DH-01 to 14:38)</a:t>
+              <a:t>  feed SH-01</a:t>
             </a:r>
             <a:endParaRPr lang="en-US" sz="1000" dirty="0"/>
           </a:p>
@@ -2900,7 +2853,7 @@
       </p:sp>
       <p:sp>
         <p:nvSpPr>
-          <p:cNvPr id="34" name="Text 32"/>
+          <p:cNvPr id="33" name="Text 31"/>
           <p:cNvSpPr txBox="1"/>
           <p:nvPr/>
         </p:nvSpPr>
@@ -2939,7 +2892,7 @@
       </p:sp>
       <p:sp>
         <p:nvSpPr>
-          <p:cNvPr id="35" name="Text 33"/>
+          <p:cNvPr id="34" name="Text 32"/>
           <p:cNvSpPr txBox="1"/>
           <p:nvPr/>
         </p:nvSpPr>
@@ -2986,54 +2939,7 @@
       </p:sp>
       <p:sp>
         <p:nvSpPr>
-          <p:cNvPr id="36" name="Text 34"/>
-          <p:cNvSpPr txBox="1"/>
-          <p:nvPr/>
-        </p:nvSpPr>
-        <p:spPr>
-          <a:xfrm>
-            <a:off x="7063740" y="2286000"/>
-            <a:ext cx="3434388" cy="320040"/>
-          </a:xfrm>
-          <a:prstGeom prst="rect">
-            <a:avLst/>
-          </a:prstGeom>
-          <a:solidFill>
-            <a:srgbClr val="9EC3F0">
-              <a:alpha val="15000"/>
-            </a:srgbClr>
-          </a:solidFill>
-          <a:ln w="12700">
-            <a:solidFill>
-              <a:srgbClr val="9EC3F0"/>
-            </a:solidFill>
-          </a:ln>
-        </p:spPr>
-        <p:txBody>
-          <a:bodyPr wrap="square" lIns="0" tIns="0" rIns="0" bIns="0" rtlCol="0" anchor="ctr"/>
-          <a:lstStyle/>
-          <a:p>
-            <a:pPr indent="0" marL="0">
-              <a:buNone/>
-            </a:pPr>
-            <a:r>
-              <a:rPr lang="en-US" sz="1000" dirty="0">
-                <a:solidFill>
-                  <a:srgbClr val="E8F1FF"/>
-                </a:solidFill>
-                <a:latin typeface="Arial" pitchFamily="34" charset="0"/>
-                <a:ea typeface="Arial" pitchFamily="34" charset="-122"/>
-                <a:cs typeface="Arial" pitchFamily="34" charset="-120"/>
-              </a:rPr>
-              <a:t>  feed DH-01</a:t>
-            </a:r>
-            <a:endParaRPr lang="en-US" sz="1000" dirty="0"/>
-          </a:p>
-        </p:txBody>
-      </p:sp>
-      <p:sp>
-        <p:nvSpPr>
-          <p:cNvPr id="37" name="Text 35"/>
+          <p:cNvPr id="35" name="Text 33"/>
           <p:cNvSpPr txBox="1"/>
           <p:nvPr/>
         </p:nvSpPr>
@@ -3072,7 +2978,7 @@
       </p:sp>
       <p:sp>
         <p:nvSpPr>
-          <p:cNvPr id="38" name="Text 36"/>
+          <p:cNvPr id="36" name="Text 34"/>
           <p:cNvSpPr txBox="1"/>
           <p:nvPr/>
         </p:nvSpPr>
@@ -3119,7 +3025,7 @@
       </p:sp>
       <p:sp>
         <p:nvSpPr>
-          <p:cNvPr id="39" name="Text 37"/>
+          <p:cNvPr id="37" name="Text 35"/>
           <p:cNvSpPr txBox="1"/>
           <p:nvPr/>
         </p:nvSpPr>
@@ -3158,7 +3064,7 @@
       </p:sp>
       <p:sp>
         <p:nvSpPr>
-          <p:cNvPr id="40" name="Text 38"/>
+          <p:cNvPr id="38" name="Text 36"/>
           <p:cNvSpPr txBox="1"/>
           <p:nvPr/>
         </p:nvSpPr>
@@ -3205,99 +3111,13 @@
       </p:sp>
       <p:sp>
         <p:nvSpPr>
-          <p:cNvPr id="41" name="Text 39"/>
+          <p:cNvPr id="39" name="Text 37"/>
           <p:cNvSpPr txBox="1"/>
           <p:nvPr/>
         </p:nvSpPr>
         <p:spPr>
           <a:xfrm>
             <a:off x="411480" y="3520440"/>
-            <a:ext cx="1920240" cy="320040"/>
-          </a:xfrm>
-          <a:prstGeom prst="rect">
-            <a:avLst/>
-          </a:prstGeom>
-          <a:noFill/>
-          <a:ln/>
-        </p:spPr>
-        <p:txBody>
-          <a:bodyPr wrap="square" lIns="0" tIns="0" rIns="0" bIns="0" rtlCol="0" anchor="ctr"/>
-          <a:lstStyle/>
-          <a:p>
-            <a:pPr indent="0" marL="0">
-              <a:buNone/>
-            </a:pPr>
-            <a:r>
-              <a:rPr lang="en-US" sz="1100" b="1" dirty="0">
-                <a:solidFill>
-                  <a:srgbClr val="E8F1FF"/>
-                </a:solidFill>
-                <a:latin typeface="Arial" pitchFamily="34" charset="0"/>
-                <a:ea typeface="Arial" pitchFamily="34" charset="-122"/>
-                <a:cs typeface="Arial" pitchFamily="34" charset="-120"/>
-              </a:rPr>
-              <a:t>DH-01 → SP-01</a:t>
-            </a:r>
-            <a:endParaRPr lang="en-US" sz="1100" dirty="0"/>
-          </a:p>
-        </p:txBody>
-      </p:sp>
-      <p:sp>
-        <p:nvSpPr>
-          <p:cNvPr id="42" name="Text 40"/>
-          <p:cNvSpPr txBox="1"/>
-          <p:nvPr/>
-        </p:nvSpPr>
-        <p:spPr>
-          <a:xfrm>
-            <a:off x="7063740" y="3520440"/>
-            <a:ext cx="3434388" cy="320040"/>
-          </a:xfrm>
-          <a:prstGeom prst="rect">
-            <a:avLst/>
-          </a:prstGeom>
-          <a:solidFill>
-            <a:srgbClr val="FFD166">
-              <a:alpha val="22000"/>
-            </a:srgbClr>
-          </a:solidFill>
-          <a:ln w="15875">
-            <a:solidFill>
-              <a:srgbClr val="FFD166"/>
-            </a:solidFill>
-          </a:ln>
-        </p:spPr>
-        <p:txBody>
-          <a:bodyPr wrap="square" lIns="0" tIns="0" rIns="0" bIns="0" rtlCol="0" anchor="ctr"/>
-          <a:lstStyle/>
-          <a:p>
-            <a:pPr indent="0" marL="0">
-              <a:buNone/>
-            </a:pPr>
-            <a:r>
-              <a:rPr lang="en-US" sz="1000" dirty="0">
-                <a:solidFill>
-                  <a:srgbClr val="E8F1FF"/>
-                </a:solidFill>
-                <a:latin typeface="Arial" pitchFamily="34" charset="0"/>
-                <a:ea typeface="Arial" pitchFamily="34" charset="-122"/>
-                <a:cs typeface="Arial" pitchFamily="34" charset="-120"/>
-              </a:rPr>
-              <a:t>  secondary processing 33 t/h · M5</a:t>
-            </a:r>
-            <a:endParaRPr lang="en-US" sz="1000" dirty="0"/>
-          </a:p>
-        </p:txBody>
-      </p:sp>
-      <p:sp>
-        <p:nvSpPr>
-          <p:cNvPr id="43" name="Text 41"/>
-          <p:cNvSpPr txBox="1"/>
-          <p:nvPr/>
-        </p:nvSpPr>
-        <p:spPr>
-          <a:xfrm>
-            <a:off x="411480" y="3931920"/>
             <a:ext cx="1920240" cy="320040"/>
           </a:xfrm>
           <a:prstGeom prst="rect">
@@ -3330,13 +3150,13 @@
       </p:sp>
       <p:sp>
         <p:nvSpPr>
-          <p:cNvPr id="44" name="Text 42"/>
+          <p:cNvPr id="40" name="Text 38"/>
           <p:cNvSpPr txBox="1"/>
           <p:nvPr/>
         </p:nvSpPr>
         <p:spPr>
           <a:xfrm>
-            <a:off x="3046911" y="3931920"/>
+            <a:off x="3046911" y="3520440"/>
             <a:ext cx="3213463" cy="320040"/>
           </a:xfrm>
           <a:prstGeom prst="rect">
@@ -3377,13 +3197,13 @@
       </p:sp>
       <p:sp>
         <p:nvSpPr>
-          <p:cNvPr id="45" name="Text 43"/>
+          <p:cNvPr id="41" name="Text 39"/>
           <p:cNvSpPr txBox="1"/>
           <p:nvPr/>
         </p:nvSpPr>
         <p:spPr>
           <a:xfrm>
-            <a:off x="411480" y="4343400"/>
+            <a:off x="411480" y="3931920"/>
             <a:ext cx="1920240" cy="320040"/>
           </a:xfrm>
           <a:prstGeom prst="rect">
@@ -3416,13 +3236,13 @@
       </p:sp>
       <p:sp>
         <p:nvSpPr>
-          <p:cNvPr id="46" name="Text 44"/>
+          <p:cNvPr id="42" name="Text 40"/>
           <p:cNvSpPr txBox="1"/>
           <p:nvPr/>
         </p:nvSpPr>
         <p:spPr>
           <a:xfrm>
-            <a:off x="2377440" y="4343400"/>
+            <a:off x="2377440" y="3931920"/>
             <a:ext cx="9372600" cy="320040"/>
           </a:xfrm>
           <a:prstGeom prst="rect">
@@ -3462,13 +3282,13 @@
       </p:sp>
       <p:sp>
         <p:nvSpPr>
-          <p:cNvPr id="47" name="Shape 45"/>
+          <p:cNvPr id="43" name="Shape 41"/>
           <p:cNvSpPr/>
           <p:nvPr/>
         </p:nvSpPr>
         <p:spPr>
           <a:xfrm>
-            <a:off x="411480" y="5029200"/>
+            <a:off x="411480" y="4617720"/>
             <a:ext cx="3611880" cy="960120"/>
           </a:xfrm>
           <a:prstGeom prst="rect">
@@ -3487,13 +3307,13 @@
       </p:sp>
       <p:sp>
         <p:nvSpPr>
-          <p:cNvPr id="48" name="Text 46"/>
+          <p:cNvPr id="44" name="Text 42"/>
           <p:cNvSpPr txBox="1"/>
           <p:nvPr/>
         </p:nvSpPr>
         <p:spPr>
           <a:xfrm>
-            <a:off x="594360" y="5120640"/>
+            <a:off x="594360" y="4709160"/>
             <a:ext cx="1417320" cy="457200"/>
           </a:xfrm>
           <a:prstGeom prst="rect">
@@ -3526,13 +3346,13 @@
       </p:sp>
       <p:sp>
         <p:nvSpPr>
-          <p:cNvPr id="49" name="Text 47"/>
+          <p:cNvPr id="45" name="Text 43"/>
           <p:cNvSpPr txBox="1"/>
           <p:nvPr/>
         </p:nvSpPr>
         <p:spPr>
           <a:xfrm>
-            <a:off x="2057400" y="5138928"/>
+            <a:off x="2057400" y="4727448"/>
             <a:ext cx="1828800" cy="411480"/>
           </a:xfrm>
           <a:prstGeom prst="rect">
@@ -3565,13 +3385,13 @@
       </p:sp>
       <p:sp>
         <p:nvSpPr>
-          <p:cNvPr id="50" name="Text 48"/>
+          <p:cNvPr id="46" name="Text 44"/>
           <p:cNvSpPr txBox="1"/>
           <p:nvPr/>
         </p:nvSpPr>
         <p:spPr>
           <a:xfrm>
-            <a:off x="594360" y="5577840"/>
+            <a:off x="594360" y="5166360"/>
             <a:ext cx="3246120" cy="347472"/>
           </a:xfrm>
           <a:prstGeom prst="rect">
@@ -3604,13 +3424,13 @@
       </p:sp>
       <p:sp>
         <p:nvSpPr>
-          <p:cNvPr id="51" name="Shape 49"/>
+          <p:cNvPr id="47" name="Shape 45"/>
           <p:cNvSpPr/>
           <p:nvPr/>
         </p:nvSpPr>
         <p:spPr>
           <a:xfrm>
-            <a:off x="4270248" y="5029200"/>
+            <a:off x="4270248" y="4617720"/>
             <a:ext cx="3611880" cy="960120"/>
           </a:xfrm>
           <a:prstGeom prst="rect">
@@ -3629,13 +3449,13 @@
       </p:sp>
       <p:sp>
         <p:nvSpPr>
-          <p:cNvPr id="52" name="Text 50"/>
+          <p:cNvPr id="48" name="Text 46"/>
           <p:cNvSpPr txBox="1"/>
           <p:nvPr/>
         </p:nvSpPr>
         <p:spPr>
           <a:xfrm>
-            <a:off x="4453128" y="5120640"/>
+            <a:off x="4453128" y="4709160"/>
             <a:ext cx="1417320" cy="457200"/>
           </a:xfrm>
           <a:prstGeom prst="rect">
@@ -3668,13 +3488,13 @@
       </p:sp>
       <p:sp>
         <p:nvSpPr>
-          <p:cNvPr id="53" name="Text 51"/>
+          <p:cNvPr id="49" name="Text 47"/>
           <p:cNvSpPr txBox="1"/>
           <p:nvPr/>
         </p:nvSpPr>
         <p:spPr>
           <a:xfrm>
-            <a:off x="5916168" y="5138928"/>
+            <a:off x="5916168" y="4727448"/>
             <a:ext cx="1828800" cy="411480"/>
           </a:xfrm>
           <a:prstGeom prst="rect">
@@ -3707,13 +3527,13 @@
       </p:sp>
       <p:sp>
         <p:nvSpPr>
-          <p:cNvPr id="54" name="Text 52"/>
+          <p:cNvPr id="50" name="Text 48"/>
           <p:cNvSpPr txBox="1"/>
           <p:nvPr/>
         </p:nvSpPr>
         <p:spPr>
           <a:xfrm>
-            <a:off x="4453128" y="5577840"/>
+            <a:off x="4453128" y="5166360"/>
             <a:ext cx="3246120" cy="347472"/>
           </a:xfrm>
           <a:prstGeom prst="rect">
@@ -3746,13 +3566,13 @@
       </p:sp>
       <p:sp>
         <p:nvSpPr>
-          <p:cNvPr id="55" name="Shape 53"/>
+          <p:cNvPr id="51" name="Shape 49"/>
           <p:cNvSpPr/>
           <p:nvPr/>
         </p:nvSpPr>
         <p:spPr>
           <a:xfrm>
-            <a:off x="8129016" y="5029200"/>
+            <a:off x="8129016" y="4617720"/>
             <a:ext cx="3611880" cy="960120"/>
           </a:xfrm>
           <a:prstGeom prst="rect">
@@ -3771,13 +3591,13 @@
       </p:sp>
       <p:sp>
         <p:nvSpPr>
-          <p:cNvPr id="56" name="Text 54"/>
+          <p:cNvPr id="52" name="Text 50"/>
           <p:cNvSpPr txBox="1"/>
           <p:nvPr/>
         </p:nvSpPr>
         <p:spPr>
           <a:xfrm>
-            <a:off x="8311896" y="5120640"/>
+            <a:off x="8311896" y="4709160"/>
             <a:ext cx="1417320" cy="457200"/>
           </a:xfrm>
           <a:prstGeom prst="rect">
@@ -3802,7 +3622,7 @@
                 <a:ea typeface="Arial" pitchFamily="34" charset="-122"/>
                 <a:cs typeface="Arial" pitchFamily="34" charset="-120"/>
               </a:rPr>
-              <a:t>~3,340 h</a:t>
+              <a:t>~2,790 h</a:t>
             </a:r>
             <a:endParaRPr lang="en-US" sz="2000" dirty="0"/>
           </a:p>
@@ -3810,13 +3630,13 @@
       </p:sp>
       <p:sp>
         <p:nvSpPr>
-          <p:cNvPr id="57" name="Text 55"/>
+          <p:cNvPr id="53" name="Text 51"/>
           <p:cNvSpPr txBox="1"/>
           <p:nvPr/>
         </p:nvSpPr>
         <p:spPr>
           <a:xfrm>
-            <a:off x="9774936" y="5138928"/>
+            <a:off x="9774936" y="4727448"/>
             <a:ext cx="1828800" cy="411480"/>
           </a:xfrm>
           <a:prstGeom prst="rect">
@@ -3849,13 +3669,13 @@
       </p:sp>
       <p:sp>
         <p:nvSpPr>
-          <p:cNvPr id="58" name="Text 56"/>
+          <p:cNvPr id="54" name="Text 52"/>
           <p:cNvSpPr txBox="1"/>
           <p:nvPr/>
         </p:nvSpPr>
         <p:spPr>
           <a:xfrm>
-            <a:off x="8311896" y="5577840"/>
+            <a:off x="8311896" y="5166360"/>
             <a:ext cx="3246120" cy="347472"/>
           </a:xfrm>
           <a:prstGeom prst="rect">
@@ -3880,7 +3700,7 @@
                 <a:ea typeface="Arial" pitchFamily="34" charset="-122"/>
                 <a:cs typeface="Arial" pitchFamily="34" charset="-120"/>
               </a:rPr>
-              <a:t>2 loaders at ~1,670 h each (conveyors link SH-01, TR-01, SH-03)</a:t>
+              <a:t>2 loaders, both under 1,600 h (no hopper feed)</a:t>
             </a:r>
             <a:endParaRPr lang="en-US" sz="1000" dirty="0"/>
           </a:p>
@@ -3888,7 +3708,7 @@
       </p:sp>
       <p:sp>
         <p:nvSpPr>
-          <p:cNvPr id="59" name="Text 57"/>
+          <p:cNvPr id="55" name="Text 53"/>
           <p:cNvSpPr txBox="1"/>
           <p:nvPr/>
         </p:nvSpPr>
@@ -3919,7 +3739,7 @@
                 <a:ea typeface="Courier New" pitchFamily="34" charset="-122"/>
                 <a:cs typeface="Courier New" pitchFamily="34" charset="-120"/>
               </a:rPr>
-              <a:t>26029-PFD-003 rev C · Coleraine / Riverridge · WTT 26029 rev 1 basis · sheet 2 of 3</a:t>
+              <a:t>26029-PFD-003 rev D · Coleraine / Riverridge · WTT 26029 rev 1 basis · sheet 2 of 3</a:t>
             </a:r>
             <a:endParaRPr lang="en-US" sz="800" dirty="0"/>
           </a:p>
@@ -6932,281 +6752,7 @@
                           <a:ea typeface="Arial" pitchFamily="34" charset="-122"/>
                           <a:cs typeface="Arial" pitchFamily="34" charset="-120"/>
                         </a:rPr>
-                        <a:t>Tunnel output → OS-01 storage bays</a:t>
-                      </a:r>
-                      <a:endParaRPr lang="en-US" sz="1000" dirty="0">
-                        <a:latin typeface="Arial" charset="0"/>
-                        <a:ea typeface="Arial" charset="0"/>
-                        <a:cs typeface="Arial" charset="0"/>
-                      </a:endParaRPr>
-                    </a:p>
-                  </a:txBody>
-                  <a:tcPr marL="73152" marR="73152" marT="18288" marB="18288" anchor="ctr">
-                    <a:lnL w="9525" cap="flat" cmpd="sng" algn="ctr">
-                      <a:solidFill>
-                        <a:srgbClr val="2A5790"/>
-                      </a:solidFill>
-                      <a:prstDash val="solid"/>
-                      <a:round/>
-                      <a:headEnd type="none" w="med" len="med"/>
-                      <a:tailEnd type="none" w="med" len="med"/>
-                    </a:lnL>
-                    <a:lnR w="9525" cap="flat" cmpd="sng" algn="ctr">
-                      <a:solidFill>
-                        <a:srgbClr val="2A5790"/>
-                      </a:solidFill>
-                      <a:prstDash val="solid"/>
-                      <a:round/>
-                      <a:headEnd type="none" w="med" len="med"/>
-                      <a:tailEnd type="none" w="med" len="med"/>
-                    </a:lnR>
-                    <a:lnT w="9525" cap="flat" cmpd="sng" algn="ctr">
-                      <a:solidFill>
-                        <a:srgbClr val="2A5790"/>
-                      </a:solidFill>
-                      <a:prstDash val="solid"/>
-                      <a:round/>
-                      <a:headEnd type="none" w="med" len="med"/>
-                      <a:tailEnd type="none" w="med" len="med"/>
-                    </a:lnT>
-                    <a:lnB w="9525" cap="flat" cmpd="sng" algn="ctr">
-                      <a:solidFill>
-                        <a:srgbClr val="2A5790"/>
-                      </a:solidFill>
-                      <a:prstDash val="solid"/>
-                      <a:round/>
-                      <a:headEnd type="none" w="med" len="med"/>
-                      <a:tailEnd type="none" w="med" len="med"/>
-                    </a:lnB>
-                    <a:solidFill>
-                      <a:srgbClr val="0D3B73"/>
-                    </a:solidFill>
-                  </a:tcPr>
-                </a:tc>
-                <a:tc>
-                  <a:txBody>
-                    <a:bodyPr/>
-                    <a:lstStyle/>
-                    <a:p>
-                      <a:pPr algn="r" indent="0" marL="0">
-                        <a:buNone/>
-                      </a:pPr>
-                      <a:r>
-                        <a:rPr lang="en-US" sz="1000" dirty="0">
-                          <a:solidFill>
-                            <a:srgbClr val="E8F1FF"/>
-                          </a:solidFill>
-                          <a:latin typeface="Courier New" pitchFamily="34" charset="0"/>
-                          <a:ea typeface="Courier New" pitchFamily="34" charset="-122"/>
-                          <a:cs typeface="Courier New" pitchFamily="34" charset="-120"/>
-                        </a:rPr>
-                        <a:t>52,485</a:t>
-                      </a:r>
-                      <a:endParaRPr lang="en-US" sz="1000" dirty="0">
-                        <a:latin typeface="Courier New" charset="0"/>
-                        <a:ea typeface="Courier New" charset="0"/>
-                        <a:cs typeface="Courier New" charset="0"/>
-                      </a:endParaRPr>
-                    </a:p>
-                  </a:txBody>
-                  <a:tcPr marL="73152" marR="73152" marT="18288" marB="18288" anchor="ctr">
-                    <a:lnL w="9525" cap="flat" cmpd="sng" algn="ctr">
-                      <a:solidFill>
-                        <a:srgbClr val="2A5790"/>
-                      </a:solidFill>
-                      <a:prstDash val="solid"/>
-                      <a:round/>
-                      <a:headEnd type="none" w="med" len="med"/>
-                      <a:tailEnd type="none" w="med" len="med"/>
-                    </a:lnL>
-                    <a:lnR w="9525" cap="flat" cmpd="sng" algn="ctr">
-                      <a:solidFill>
-                        <a:srgbClr val="2A5790"/>
-                      </a:solidFill>
-                      <a:prstDash val="solid"/>
-                      <a:round/>
-                      <a:headEnd type="none" w="med" len="med"/>
-                      <a:tailEnd type="none" w="med" len="med"/>
-                    </a:lnR>
-                    <a:lnT w="9525" cap="flat" cmpd="sng" algn="ctr">
-                      <a:solidFill>
-                        <a:srgbClr val="2A5790"/>
-                      </a:solidFill>
-                      <a:prstDash val="solid"/>
-                      <a:round/>
-                      <a:headEnd type="none" w="med" len="med"/>
-                      <a:tailEnd type="none" w="med" len="med"/>
-                    </a:lnT>
-                    <a:lnB w="9525" cap="flat" cmpd="sng" algn="ctr">
-                      <a:solidFill>
-                        <a:srgbClr val="2A5790"/>
-                      </a:solidFill>
-                      <a:prstDash val="solid"/>
-                      <a:round/>
-                      <a:headEnd type="none" w="med" len="med"/>
-                      <a:tailEnd type="none" w="med" len="med"/>
-                    </a:lnB>
-                    <a:solidFill>
-                      <a:srgbClr val="0D3B73"/>
-                    </a:solidFill>
-                  </a:tcPr>
-                </a:tc>
-                <a:tc>
-                  <a:txBody>
-                    <a:bodyPr/>
-                    <a:lstStyle/>
-                    <a:p>
-                      <a:pPr algn="r" indent="0" marL="0">
-                        <a:buNone/>
-                      </a:pPr>
-                      <a:r>
-                        <a:rPr lang="en-US" sz="1000" dirty="0">
-                          <a:solidFill>
-                            <a:srgbClr val="E8F1FF"/>
-                          </a:solidFill>
-                          <a:latin typeface="Courier New" pitchFamily="34" charset="0"/>
-                          <a:ea typeface="Courier New" pitchFamily="34" charset="-122"/>
-                          <a:cs typeface="Courier New" pitchFamily="34" charset="-120"/>
-                        </a:rPr>
-                        <a:t>84.6</a:t>
-                      </a:r>
-                      <a:endParaRPr lang="en-US" sz="1000" dirty="0">
-                        <a:latin typeface="Courier New" charset="0"/>
-                        <a:ea typeface="Courier New" charset="0"/>
-                        <a:cs typeface="Courier New" charset="0"/>
-                      </a:endParaRPr>
-                    </a:p>
-                  </a:txBody>
-                  <a:tcPr marL="73152" marR="73152" marT="18288" marB="18288" anchor="ctr">
-                    <a:lnL w="9525" cap="flat" cmpd="sng" algn="ctr">
-                      <a:solidFill>
-                        <a:srgbClr val="2A5790"/>
-                      </a:solidFill>
-                      <a:prstDash val="solid"/>
-                      <a:round/>
-                      <a:headEnd type="none" w="med" len="med"/>
-                      <a:tailEnd type="none" w="med" len="med"/>
-                    </a:lnL>
-                    <a:lnR w="9525" cap="flat" cmpd="sng" algn="ctr">
-                      <a:solidFill>
-                        <a:srgbClr val="2A5790"/>
-                      </a:solidFill>
-                      <a:prstDash val="solid"/>
-                      <a:round/>
-                      <a:headEnd type="none" w="med" len="med"/>
-                      <a:tailEnd type="none" w="med" len="med"/>
-                    </a:lnR>
-                    <a:lnT w="9525" cap="flat" cmpd="sng" algn="ctr">
-                      <a:solidFill>
-                        <a:srgbClr val="2A5790"/>
-                      </a:solidFill>
-                      <a:prstDash val="solid"/>
-                      <a:round/>
-                      <a:headEnd type="none" w="med" len="med"/>
-                      <a:tailEnd type="none" w="med" len="med"/>
-                    </a:lnT>
-                    <a:lnB w="9525" cap="flat" cmpd="sng" algn="ctr">
-                      <a:solidFill>
-                        <a:srgbClr val="2A5790"/>
-                      </a:solidFill>
-                      <a:prstDash val="solid"/>
-                      <a:round/>
-                      <a:headEnd type="none" w="med" len="med"/>
-                      <a:tailEnd type="none" w="med" len="med"/>
-                    </a:lnB>
-                    <a:solidFill>
-                      <a:srgbClr val="0D3B73"/>
-                    </a:solidFill>
-                  </a:tcPr>
-                </a:tc>
-              </a:tr>
-              <a:tr h="329184">
-                <a:tc>
-                  <a:txBody>
-                    <a:bodyPr/>
-                    <a:lstStyle/>
-                    <a:p>
-                      <a:pPr algn="ctr" indent="0" marL="0">
-                        <a:buNone/>
-                      </a:pPr>
-                      <a:r>
-                        <a:rPr lang="en-US" sz="1000" dirty="0">
-                          <a:solidFill>
-                            <a:srgbClr val="E8F1FF"/>
-                          </a:solidFill>
-                          <a:latin typeface="Courier New" pitchFamily="34" charset="0"/>
-                          <a:ea typeface="Courier New" pitchFamily="34" charset="-122"/>
-                          <a:cs typeface="Courier New" pitchFamily="34" charset="-120"/>
-                        </a:rPr>
-                        <a:t>14</a:t>
-                      </a:r>
-                      <a:endParaRPr lang="en-US" sz="1000" dirty="0">
-                        <a:latin typeface="Courier New" charset="0"/>
-                        <a:ea typeface="Courier New" charset="0"/>
-                        <a:cs typeface="Courier New" charset="0"/>
-                      </a:endParaRPr>
-                    </a:p>
-                  </a:txBody>
-                  <a:tcPr marL="73152" marR="73152" marT="18288" marB="18288" anchor="ctr">
-                    <a:lnL w="9525" cap="flat" cmpd="sng" algn="ctr">
-                      <a:solidFill>
-                        <a:srgbClr val="2A5790"/>
-                      </a:solidFill>
-                      <a:prstDash val="solid"/>
-                      <a:round/>
-                      <a:headEnd type="none" w="med" len="med"/>
-                      <a:tailEnd type="none" w="med" len="med"/>
-                    </a:lnL>
-                    <a:lnR w="9525" cap="flat" cmpd="sng" algn="ctr">
-                      <a:solidFill>
-                        <a:srgbClr val="2A5790"/>
-                      </a:solidFill>
-                      <a:prstDash val="solid"/>
-                      <a:round/>
-                      <a:headEnd type="none" w="med" len="med"/>
-                      <a:tailEnd type="none" w="med" len="med"/>
-                    </a:lnR>
-                    <a:lnT w="9525" cap="flat" cmpd="sng" algn="ctr">
-                      <a:solidFill>
-                        <a:srgbClr val="2A5790"/>
-                      </a:solidFill>
-                      <a:prstDash val="solid"/>
-                      <a:round/>
-                      <a:headEnd type="none" w="med" len="med"/>
-                      <a:tailEnd type="none" w="med" len="med"/>
-                    </a:lnT>
-                    <a:lnB w="9525" cap="flat" cmpd="sng" algn="ctr">
-                      <a:solidFill>
-                        <a:srgbClr val="2A5790"/>
-                      </a:solidFill>
-                      <a:prstDash val="solid"/>
-                      <a:round/>
-                      <a:headEnd type="none" w="med" len="med"/>
-                      <a:tailEnd type="none" w="med" len="med"/>
-                    </a:lnB>
-                    <a:solidFill>
-                      <a:srgbClr val="0D3B73"/>
-                    </a:solidFill>
-                  </a:tcPr>
-                </a:tc>
-                <a:tc>
-                  <a:txBody>
-                    <a:bodyPr/>
-                    <a:lstStyle/>
-                    <a:p>
-                      <a:pPr algn="l" indent="0" marL="0">
-                        <a:buNone/>
-                      </a:pPr>
-                      <a:r>
-                        <a:rPr lang="en-US" sz="1000" dirty="0">
-                          <a:solidFill>
-                            <a:srgbClr val="E8F1FF"/>
-                          </a:solidFill>
-                          <a:latin typeface="Arial" pitchFamily="34" charset="0"/>
-                          <a:ea typeface="Arial" pitchFamily="34" charset="-122"/>
-                          <a:cs typeface="Arial" pitchFamily="34" charset="-120"/>
-                        </a:rPr>
-                        <a:t>DH-01 → SP-01 at 33 t/h · M5</a:t>
+                        <a:t>Tunnel output → trucks → FCG (40 /wk)</a:t>
                       </a:r>
                       <a:endParaRPr lang="en-US" sz="1000" dirty="0">
                         <a:latin typeface="Arial" charset="0"/>
@@ -7480,7 +7026,7 @@
                           <a:ea typeface="Arial" pitchFamily="34" charset="-122"/>
                           <a:cs typeface="Arial" pitchFamily="34" charset="-120"/>
                         </a:rPr>
-                        <a:t>Ferrous recovered M1–M5 (1.29% Fe)</a:t>
+                        <a:t>Ferrous recovered M1–M4 (1.29% Fe)</a:t>
                       </a:r>
                       <a:endParaRPr lang="en-US" sz="1000" dirty="0">
                         <a:latin typeface="Arial" charset="0"/>
@@ -7548,7 +7094,7 @@
                           <a:ea typeface="Courier New" pitchFamily="34" charset="-122"/>
                           <a:cs typeface="Courier New" pitchFamily="34" charset="-120"/>
                         </a:rPr>
-                        <a:t>948</a:t>
+                        <a:t>869</a:t>
                       </a:r>
                       <a:endParaRPr lang="en-US" sz="1000" dirty="0">
                         <a:latin typeface="Courier New" charset="0"/>
@@ -8064,7 +7610,7 @@
                 <a:ea typeface="Arial" pitchFamily="34" charset="-122"/>
                 <a:cs typeface="Arial" pitchFamily="34" charset="-120"/>
               </a:rPr>
-              <a:t>5 magnets M1–M5; Blazequel on both shredders</a:t>
+              <a:t>Magnets M1–M4 (M5 TBC); Blazequel on both shredders</a:t>
             </a:r>
             <a:endParaRPr lang="en-US" sz="1200" dirty="0"/>
           </a:p>
@@ -8106,7 +7652,7 @@
                 <a:ea typeface="Arial" pitchFamily="34" charset="-122"/>
                 <a:cs typeface="Arial" pitchFamily="34" charset="-120"/>
               </a:rPr>
-              <a:t>SP-01 33 t/h in 1,600 h</a:t>
+              <a:t>Output straight onto trucks to FCG</a:t>
             </a:r>
             <a:endParaRPr lang="en-US" sz="1200" dirty="0"/>
           </a:p>
@@ -8230,7 +7776,7 @@
                 <a:ea typeface="Arial" pitchFamily="34" charset="-122"/>
                 <a:cs typeface="Arial" pitchFamily="34" charset="-120"/>
               </a:rPr>
-              <a:t>SH-03 model and rate on overs</a:t>
+              <a:t>Truck booking + set-down area for FCG loads</a:t>
             </a:r>
             <a:endParaRPr lang="en-US" sz="1200" dirty="0"/>
           </a:p>
@@ -8311,7 +7857,7 @@
                 <a:ea typeface="Courier New" pitchFamily="34" charset="-122"/>
                 <a:cs typeface="Courier New" pitchFamily="34" charset="-120"/>
               </a:rPr>
-              <a:t>26029-PFD-003 rev C · Coleraine / Riverridge · WTT 26029 rev 1 basis · sheet 3 of 3</a:t>
+              <a:t>26029-PFD-003 rev D · Coleraine / Riverridge · WTT 26029 rev 1 basis · sheet 3 of 3</a:t>
             </a:r>
             <a:endParaRPr lang="en-US" sz="800" dirty="0"/>
           </a:p>

</xml_diff>